<commit_message>
downloading replacement and language update(kz)
</commit_message>
<xml_diff>
--- a/public/program-en.pptx
+++ b/public/program-en.pptx
@@ -2,15 +2,15 @@
 <file path=ppt/presentation.xml><?xml version="1.0" encoding="utf-8"?>
 <p:presentation xmlns:a="http://schemas.openxmlformats.org/drawingml/2006/main" xmlns:r="http://schemas.openxmlformats.org/officeDocument/2006/relationships" xmlns:p="http://schemas.openxmlformats.org/presentationml/2006/main">
   <p:sldMasterIdLst>
-    <p:sldMasterId id="2147483648" r:id="rId1"/>
+    <p:sldMasterId id="2147483648" r:id="rId4"/>
   </p:sldMasterIdLst>
   <p:handoutMasterIdLst>
-    <p:handoutMasterId r:id="rId5"/>
+    <p:handoutMasterId r:id="rId8"/>
   </p:handoutMasterIdLst>
   <p:sldIdLst>
-    <p:sldId id="261" r:id="rId2"/>
-    <p:sldId id="263" r:id="rId3"/>
-    <p:sldId id="264" r:id="rId4"/>
+    <p:sldId id="261" r:id="rId5"/>
+    <p:sldId id="263" r:id="rId6"/>
+    <p:sldId id="264" r:id="rId7"/>
   </p:sldIdLst>
   <p:sldSz cx="7569200" cy="10699750"/>
   <p:notesSz cx="7569200" cy="10699750"/>
@@ -39,6 +39,14 @@
     </p:ext>
   </p:extLst>
 </p:presentation>
+</file>
+
+<file path=ppt/revisionInfo.xml><?xml version="1.0" encoding="utf-8"?>
+<p1510:revInfo xmlns:a="http://schemas.openxmlformats.org/drawingml/2006/main" xmlns:r="http://schemas.openxmlformats.org/officeDocument/2006/relationships" xmlns:p1510="http://schemas.microsoft.com/office/powerpoint/2015/10/main">
+  <p1510:revLst>
+    <p1510:client id="{9FA6198C-F0B4-41D6-BBA2-2194EAFAADA0}" v="2" dt="2026-03-09T14:28:39.691"/>
+  </p1510:revLst>
+</p1510:revInfo>
 </file>
 
 <file path=ppt/handoutMasters/handoutMaster1.xml><?xml version="1.0" encoding="utf-8"?>
@@ -135,7 +143,7 @@
           <a:p>
             <a:fld id="{0C391B6F-BBFA-438A-9286-1FC62C3499A0}" type="datetimeFigureOut">
               <a:rPr lang="ru-RU" smtClean="0"/>
-              <a:t>26.02.2026</a:t>
+              <a:t>18.03.2026</a:t>
             </a:fld>
             <a:endParaRPr lang="ru-RU"/>
           </a:p>
@@ -379,7 +387,7 @@
           <a:p>
             <a:fld id="{1D8BD707-D9CF-40AE-B4C6-C98DA3205C09}" type="datetimeFigureOut">
               <a:rPr lang="en-US"/>
-              <a:t>2/26/2026</a:t>
+              <a:t>3/18/2026</a:t>
             </a:fld>
             <a:endParaRPr lang="en-US"/>
           </a:p>
@@ -822,7 +830,7 @@
           <a:p>
             <a:fld id="{1D8BD707-D9CF-40AE-B4C6-C98DA3205C09}" type="datetimeFigureOut">
               <a:rPr lang="en-US"/>
-              <a:t>2/26/2026</a:t>
+              <a:t>3/18/2026</a:t>
             </a:fld>
             <a:endParaRPr lang="en-US"/>
           </a:p>
@@ -1036,7 +1044,7 @@
           <a:p>
             <a:fld id="{1D8BD707-D9CF-40AE-B4C6-C98DA3205C09}" type="datetimeFigureOut">
               <a:rPr lang="en-US"/>
-              <a:t>2/26/2026</a:t>
+              <a:t>3/18/2026</a:t>
             </a:fld>
             <a:endParaRPr lang="en-US"/>
           </a:p>
@@ -1184,7 +1192,7 @@
           <a:p>
             <a:fld id="{1D8BD707-D9CF-40AE-B4C6-C98DA3205C09}" type="datetimeFigureOut">
               <a:rPr lang="en-US"/>
-              <a:t>2/26/2026</a:t>
+              <a:t>3/18/2026</a:t>
             </a:fld>
             <a:endParaRPr lang="en-US"/>
           </a:p>
@@ -1383,7 +1391,7 @@
           <a:p>
             <a:fld id="{1D8BD707-D9CF-40AE-B4C6-C98DA3205C09}" type="datetimeFigureOut">
               <a:rPr lang="en-US"/>
-              <a:t>2/26/2026</a:t>
+              <a:t>3/18/2026</a:t>
             </a:fld>
             <a:endParaRPr lang="en-US"/>
           </a:p>
@@ -1606,7 +1614,7 @@
           <a:p>
             <a:fld id="{1D8BD707-D9CF-40AE-B4C6-C98DA3205C09}" type="datetimeFigureOut">
               <a:rPr lang="en-US"/>
-              <a:t>2/26/2026</a:t>
+              <a:t>3/18/2026</a:t>
             </a:fld>
             <a:endParaRPr lang="en-US"/>
           </a:p>
@@ -1840,7 +1848,7 @@
         <p:spPr>
           <a:xfrm>
             <a:off x="0" y="7442200"/>
-            <a:ext cx="7569200" cy="3054682"/>
+            <a:ext cx="7569200" cy="3156132"/>
           </a:xfrm>
           <a:prstGeom prst="rect">
             <a:avLst/>
@@ -2020,7 +2028,29 @@
                 <a:ea typeface="Roboto" panose="02000000000000000000" pitchFamily="2" charset="0"/>
                 <a:cs typeface="Roboto" panose="02000000000000000000" pitchFamily="2" charset="0"/>
               </a:rPr>
-              <a:t>Kazakhstan-German Transport and Logistics Forum</a:t>
+              <a:t>1</a:t>
+            </a:r>
+            <a:r>
+              <a:rPr lang="en-US" b="1" baseline="30000" dirty="0">
+                <a:solidFill>
+                  <a:srgbClr val="002060"/>
+                </a:solidFill>
+                <a:latin typeface="Century Gothic" panose="020B0502020202020204" pitchFamily="34" charset="0"/>
+                <a:ea typeface="Roboto" panose="02000000000000000000" pitchFamily="2" charset="0"/>
+                <a:cs typeface="Roboto" panose="02000000000000000000" pitchFamily="2" charset="0"/>
+              </a:rPr>
+              <a:t>st</a:t>
+            </a:r>
+            <a:r>
+              <a:rPr lang="en-US" b="1" dirty="0">
+                <a:solidFill>
+                  <a:srgbClr val="002060"/>
+                </a:solidFill>
+                <a:latin typeface="Century Gothic" panose="020B0502020202020204" pitchFamily="34" charset="0"/>
+                <a:ea typeface="Roboto" panose="02000000000000000000" pitchFamily="2" charset="0"/>
+                <a:cs typeface="Roboto" panose="02000000000000000000" pitchFamily="2" charset="0"/>
+              </a:rPr>
+              <a:t> Kazakh-German Transport and Logistics Forum</a:t>
             </a:r>
           </a:p>
           <a:p>
@@ -2492,53 +2522,6 @@
           </a:p>
         </p:txBody>
       </p:sp>
-      <p:pic>
-        <p:nvPicPr>
-          <p:cNvPr id="7" name="Picture 6">
-            <a:extLst>
-              <a:ext uri="{FF2B5EF4-FFF2-40B4-BE49-F238E27FC236}">
-                <a16:creationId xmlns:a16="http://schemas.microsoft.com/office/drawing/2014/main" id="{E4141A2C-8A6B-DF1C-BECD-E4EFCBF531CF}"/>
-              </a:ext>
-            </a:extLst>
-          </p:cNvPr>
-          <p:cNvPicPr>
-            <a:picLocks noChangeAspect="1" noChangeArrowheads="1"/>
-          </p:cNvPicPr>
-          <p:nvPr/>
-        </p:nvPicPr>
-        <p:blipFill>
-          <a:blip r:embed="rId3" cstate="print">
-            <a:extLst>
-              <a:ext uri="{28A0092B-C50C-407E-A947-70E740481C1C}">
-                <a14:useLocalDpi xmlns:a14="http://schemas.microsoft.com/office/drawing/2010/main" val="0"/>
-              </a:ext>
-            </a:extLst>
-          </a:blip>
-          <a:srcRect/>
-          <a:stretch>
-            <a:fillRect/>
-          </a:stretch>
-        </p:blipFill>
-        <p:spPr bwMode="auto">
-          <a:xfrm>
-            <a:off x="3164351" y="5619643"/>
-            <a:ext cx="936162" cy="757687"/>
-          </a:xfrm>
-          <a:prstGeom prst="rect">
-            <a:avLst/>
-          </a:prstGeom>
-          <a:noFill/>
-          <a:extLst>
-            <a:ext uri="{909E8E84-426E-40DD-AFC4-6F175D3DCCD1}">
-              <a14:hiddenFill xmlns:a14="http://schemas.microsoft.com/office/drawing/2010/main">
-                <a:solidFill>
-                  <a:srgbClr val="FFFFFF"/>
-                </a:solidFill>
-              </a14:hiddenFill>
-            </a:ext>
-          </a:extLst>
-        </p:spPr>
-      </p:pic>
       <p:sp>
         <p:nvSpPr>
           <p:cNvPr id="9" name="object 2">
@@ -2553,7 +2536,7 @@
         </p:nvSpPr>
         <p:spPr>
           <a:xfrm>
-            <a:off x="597204" y="9036204"/>
+            <a:off x="902004" y="9150504"/>
             <a:ext cx="885825" cy="198131"/>
           </a:xfrm>
           <a:prstGeom prst="rect">
@@ -2618,7 +2601,7 @@
         </p:nvSpPr>
         <p:spPr>
           <a:xfrm>
-            <a:off x="1677670" y="8998104"/>
+            <a:off x="1982470" y="9112404"/>
             <a:ext cx="5067935" cy="226344"/>
           </a:xfrm>
           <a:prstGeom prst="rect">
@@ -2640,22 +2623,24 @@
               </a:spcBef>
             </a:pPr>
             <a:r>
-              <a:rPr lang="de-DE" sz="1200" spc="-10" dirty="0" err="1">
+              <a:rPr lang="en-US" sz="1200" dirty="0">
                 <a:solidFill>
                   <a:schemeClr val="bg1"/>
                 </a:solidFill>
                 <a:latin typeface="Century Gothic" panose="020B0502020202020204" pitchFamily="34" charset="0"/>
-                <a:ea typeface="Roboto" panose="02000000000000000000" pitchFamily="2" charset="0"/>
-                <a:cs typeface="Roboto" panose="02000000000000000000" pitchFamily="2" charset="0"/>
-                <a:hlinkClick r:id="rId4">
-                  <a:extLst>
-                    <a:ext uri="{A12FA001-AC4F-418D-AE19-62706E023703}">
-                      <ahyp:hlinkClr xmlns:ahyp="http://schemas.microsoft.com/office/drawing/2018/hyperlinkcolor" val="tx"/>
-                    </a:ext>
-                  </a:extLst>
-                </a:hlinkClick>
-              </a:rPr>
-              <a:t>z.tymbayeva@satbayev.university</a:t>
+                <a:cs typeface="Calibri"/>
+              </a:rPr>
+              <a:t> </a:t>
+            </a:r>
+            <a:r>
+              <a:rPr lang="en-US" sz="1200" dirty="0" err="1">
+                <a:solidFill>
+                  <a:schemeClr val="bg1"/>
+                </a:solidFill>
+                <a:latin typeface="Century Gothic" panose="020B0502020202020204" pitchFamily="34" charset="0"/>
+                <a:cs typeface="Calibri"/>
+              </a:rPr>
+              <a:t>s.bolatkyzy@satbayev.university</a:t>
             </a:r>
             <a:r>
               <a:rPr lang="en-US" sz="1200" spc="-10" dirty="0">
@@ -2703,8 +2688,8 @@
         </p:nvSpPr>
         <p:spPr>
           <a:xfrm>
-            <a:off x="3976688" y="7574814"/>
-            <a:ext cx="3233551" cy="1185581"/>
+            <a:off x="3947881" y="7707445"/>
+            <a:ext cx="3441972" cy="1185581"/>
           </a:xfrm>
           <a:prstGeom prst="rect">
             <a:avLst/>
@@ -2757,7 +2742,7 @@
               </a:spcBef>
             </a:pPr>
             <a:r>
-              <a:rPr lang="de-DE" sz="1200" spc="-10" dirty="0" err="1">
+              <a:rPr lang="de-DE" sz="1200" spc="-10" dirty="0">
                 <a:solidFill>
                   <a:srgbClr val="FFFFFF"/>
                 </a:solidFill>
@@ -2765,18 +2750,7 @@
                 <a:ea typeface="Roboto" panose="02000000000000000000" pitchFamily="2" charset="0"/>
                 <a:cs typeface="Roboto" panose="02000000000000000000" pitchFamily="2" charset="0"/>
               </a:rPr>
-              <a:t>Satbayev</a:t>
-            </a:r>
-            <a:r>
-              <a:rPr lang="de-DE" sz="1200" spc="-10" dirty="0">
-                <a:solidFill>
-                  <a:srgbClr val="FFFFFF"/>
-                </a:solidFill>
-                <a:latin typeface="Century Gothic" panose="020B0502020202020204" pitchFamily="34" charset="0"/>
-                <a:ea typeface="Roboto" panose="02000000000000000000" pitchFamily="2" charset="0"/>
-                <a:cs typeface="Roboto" panose="02000000000000000000" pitchFamily="2" charset="0"/>
-              </a:rPr>
-              <a:t> University</a:t>
+              <a:t>Satbayev University</a:t>
             </a:r>
           </a:p>
           <a:p>
@@ -2789,7 +2763,7 @@
               </a:spcBef>
             </a:pPr>
             <a:r>
-              <a:rPr lang="en-US" sz="1200" spc="-10" dirty="0" err="1">
+              <a:rPr lang="de-DE" sz="1200" spc="-10" dirty="0" err="1">
                 <a:solidFill>
                   <a:srgbClr val="FFFFFF"/>
                 </a:solidFill>
@@ -2800,7 +2774,7 @@
               <a:t>Audidorium</a:t>
             </a:r>
             <a:r>
-              <a:rPr lang="en-US" sz="1200" spc="-10" dirty="0">
+              <a:rPr lang="de-DE" sz="1200" spc="-10" dirty="0">
                 <a:solidFill>
                   <a:srgbClr val="FFFFFF"/>
                 </a:solidFill>
@@ -2808,10 +2782,10 @@
                 <a:ea typeface="Roboto" panose="02000000000000000000" pitchFamily="2" charset="0"/>
                 <a:cs typeface="Roboto" panose="02000000000000000000" pitchFamily="2" charset="0"/>
               </a:rPr>
-              <a:t> 343, K. </a:t>
-            </a:r>
-            <a:r>
-              <a:rPr lang="en-US" sz="1200" spc="-10" dirty="0" err="1">
+              <a:t> 343, Assembly Hall </a:t>
+            </a:r>
+            <a:r>
+              <a:rPr lang="de-DE" sz="1200" spc="-10" dirty="0" err="1">
                 <a:solidFill>
                   <a:srgbClr val="FFFFFF"/>
                 </a:solidFill>
@@ -2819,10 +2793,10 @@
                 <a:ea typeface="Roboto" panose="02000000000000000000" pitchFamily="2" charset="0"/>
                 <a:cs typeface="Roboto" panose="02000000000000000000" pitchFamily="2" charset="0"/>
               </a:rPr>
-              <a:t>Turysov</a:t>
-            </a:r>
-            <a:r>
-              <a:rPr lang="en-US" sz="1200" spc="-10" dirty="0">
+              <a:t>named</a:t>
+            </a:r>
+            <a:r>
+              <a:rPr lang="de-DE" sz="1200" spc="-10" dirty="0">
                 <a:solidFill>
                   <a:srgbClr val="FFFFFF"/>
                 </a:solidFill>
@@ -2830,7 +2804,39 @@
                 <a:ea typeface="Roboto" panose="02000000000000000000" pitchFamily="2" charset="0"/>
                 <a:cs typeface="Roboto" panose="02000000000000000000" pitchFamily="2" charset="0"/>
               </a:rPr>
-              <a:t> Assembly Hall</a:t>
+              <a:t> after. </a:t>
+            </a:r>
+          </a:p>
+          <a:p>
+            <a:pPr marL="12700">
+              <a:lnSpc>
+                <a:spcPct val="100000"/>
+              </a:lnSpc>
+              <a:spcBef>
+                <a:spcPts val="105"/>
+              </a:spcBef>
+            </a:pPr>
+            <a:r>
+              <a:rPr lang="de-DE" sz="1200" spc="-10" dirty="0">
+                <a:solidFill>
+                  <a:srgbClr val="FFFFFF"/>
+                </a:solidFill>
+                <a:latin typeface="Century Gothic" panose="020B0502020202020204" pitchFamily="34" charset="0"/>
+                <a:ea typeface="Roboto" panose="02000000000000000000" pitchFamily="2" charset="0"/>
+                <a:cs typeface="Roboto" panose="02000000000000000000" pitchFamily="2" charset="0"/>
+              </a:rPr>
+              <a:t>K. </a:t>
+            </a:r>
+            <a:r>
+              <a:rPr lang="de-DE" sz="1200" spc="-10" dirty="0" err="1">
+                <a:solidFill>
+                  <a:srgbClr val="FFFFFF"/>
+                </a:solidFill>
+                <a:latin typeface="Century Gothic" panose="020B0502020202020204" pitchFamily="34" charset="0"/>
+                <a:ea typeface="Roboto" panose="02000000000000000000" pitchFamily="2" charset="0"/>
+                <a:cs typeface="Roboto" panose="02000000000000000000" pitchFamily="2" charset="0"/>
+              </a:rPr>
+              <a:t>Turysova</a:t>
             </a:r>
             <a:endParaRPr lang="de-DE" sz="1200" spc="-10" dirty="0">
               <a:solidFill>
@@ -2881,7 +2887,7 @@
                 <a:ea typeface="Roboto" panose="02000000000000000000" pitchFamily="2" charset="0"/>
                 <a:cs typeface="Roboto" panose="02000000000000000000" pitchFamily="2" charset="0"/>
               </a:rPr>
-              <a:t> Street </a:t>
+              <a:t> St., </a:t>
             </a:r>
           </a:p>
           <a:p>
@@ -2904,16 +2910,17 @@
               </a:rPr>
               <a:t>Almaty</a:t>
             </a:r>
-          </a:p>
-          <a:p>
-            <a:pPr marL="12700">
-              <a:lnSpc>
-                <a:spcPct val="100000"/>
-              </a:lnSpc>
-              <a:spcBef>
-                <a:spcPts val="105"/>
-              </a:spcBef>
-            </a:pPr>
+            <a:r>
+              <a:rPr lang="en-US" sz="1200" spc="-10" dirty="0">
+                <a:solidFill>
+                  <a:srgbClr val="FFFFFF"/>
+                </a:solidFill>
+                <a:latin typeface="Century Gothic" panose="020B0502020202020204" pitchFamily="34" charset="0"/>
+                <a:ea typeface="Roboto" panose="02000000000000000000" pitchFamily="2" charset="0"/>
+                <a:cs typeface="Roboto" panose="02000000000000000000" pitchFamily="2" charset="0"/>
+              </a:rPr>
+              <a:t>, </a:t>
+            </a:r>
             <a:r>
               <a:rPr lang="de-DE" sz="1200" spc="-10" dirty="0" err="1">
                 <a:solidFill>
@@ -2969,7 +2976,7 @@
         </p:nvSpPr>
         <p:spPr>
           <a:xfrm>
-            <a:off x="597204" y="7574815"/>
+            <a:off x="902004" y="7689115"/>
             <a:ext cx="2926715" cy="1185581"/>
           </a:xfrm>
           <a:prstGeom prst="rect">
@@ -3110,8 +3117,8 @@
         </p:nvSpPr>
         <p:spPr>
           <a:xfrm>
-            <a:off x="597204" y="9494201"/>
-            <a:ext cx="6254446" cy="372025"/>
+            <a:off x="902004" y="9608501"/>
+            <a:ext cx="3198509" cy="560410"/>
           </a:xfrm>
           <a:prstGeom prst="rect">
             <a:avLst/>
@@ -3153,53 +3160,6 @@
           </a:p>
         </p:txBody>
       </p:sp>
-      <p:pic>
-        <p:nvPicPr>
-          <p:cNvPr id="1026" name="Picture 2">
-            <a:extLst>
-              <a:ext uri="{FF2B5EF4-FFF2-40B4-BE49-F238E27FC236}">
-                <a16:creationId xmlns:a16="http://schemas.microsoft.com/office/drawing/2014/main" id="{A4E4641A-1A80-436D-BFB9-BB26767D8056}"/>
-              </a:ext>
-            </a:extLst>
-          </p:cNvPr>
-          <p:cNvPicPr>
-            <a:picLocks noChangeAspect="1" noChangeArrowheads="1"/>
-          </p:cNvPicPr>
-          <p:nvPr/>
-        </p:nvPicPr>
-        <p:blipFill>
-          <a:blip r:embed="rId5" cstate="print">
-            <a:extLst>
-              <a:ext uri="{28A0092B-C50C-407E-A947-70E740481C1C}">
-                <a14:useLocalDpi xmlns:a14="http://schemas.microsoft.com/office/drawing/2010/main" val="0"/>
-              </a:ext>
-            </a:extLst>
-          </a:blip>
-          <a:srcRect/>
-          <a:stretch>
-            <a:fillRect/>
-          </a:stretch>
-        </p:blipFill>
-        <p:spPr bwMode="auto">
-          <a:xfrm>
-            <a:off x="4364205" y="6607508"/>
-            <a:ext cx="2313065" cy="634055"/>
-          </a:xfrm>
-          <a:prstGeom prst="rect">
-            <a:avLst/>
-          </a:prstGeom>
-          <a:noFill/>
-          <a:extLst>
-            <a:ext uri="{909E8E84-426E-40DD-AFC4-6F175D3DCCD1}">
-              <a14:hiddenFill xmlns:a14="http://schemas.microsoft.com/office/drawing/2010/main">
-                <a:solidFill>
-                  <a:srgbClr val="FFFFFF"/>
-                </a:solidFill>
-              </a14:hiddenFill>
-            </a:ext>
-          </a:extLst>
-        </p:spPr>
-      </p:pic>
       <p:pic>
         <p:nvPicPr>
           <p:cNvPr id="3" name="Рисунок 2">
@@ -3215,7 +3175,7 @@
           <p:nvPr/>
         </p:nvPicPr>
         <p:blipFill>
-          <a:blip r:embed="rId6"/>
+          <a:blip r:embed="rId3"/>
           <a:stretch>
             <a:fillRect/>
           </a:stretch>
@@ -3244,7 +3204,7 @@
         </p:nvSpPr>
         <p:spPr>
           <a:xfrm>
-            <a:off x="2611438" y="9613741"/>
+            <a:off x="2833371" y="9931554"/>
             <a:ext cx="3294380" cy="226344"/>
           </a:xfrm>
           <a:prstGeom prst="rect">
@@ -3266,7 +3226,27 @@
               </a:spcBef>
             </a:pPr>
             <a:r>
-              <a:rPr lang="de-DE" sz="1200" spc="-10" dirty="0" err="1">
+              <a:rPr lang="en-US" sz="1200" dirty="0">
+                <a:solidFill>
+                  <a:schemeClr val="bg1"/>
+                </a:solidFill>
+                <a:latin typeface="Century Gothic" panose="020B0502020202020204" pitchFamily="34" charset="0"/>
+                <a:cs typeface="Calibri"/>
+              </a:rPr>
+              <a:t> </a:t>
+            </a:r>
+            <a:r>
+              <a:rPr lang="en-US" sz="1200" dirty="0" err="1">
+                <a:solidFill>
+                  <a:schemeClr val="bg1"/>
+                </a:solidFill>
+                <a:latin typeface="Century Gothic" panose="020B0502020202020204" pitchFamily="34" charset="0"/>
+                <a:cs typeface="Calibri"/>
+              </a:rPr>
+              <a:t>s.bolatkyzy</a:t>
+            </a:r>
+            <a:r>
+              <a:rPr lang="de-DE" sz="1200" spc="-10" dirty="0">
                 <a:solidFill>
                   <a:schemeClr val="bg1"/>
                 </a:solidFill>
@@ -3281,7 +3261,7 @@
                   </a:extLst>
                 </a:hlinkClick>
               </a:rPr>
-              <a:t>z.tymbayeva@satbayev.university</a:t>
+              <a:t>@satbayev.university</a:t>
             </a:r>
             <a:endParaRPr sz="1200" dirty="0">
               <a:solidFill>
@@ -3309,7 +3289,7 @@
           <p:nvPr/>
         </p:nvPicPr>
         <p:blipFill>
-          <a:blip r:embed="rId7" cstate="print">
+          <a:blip r:embed="rId5" cstate="print">
             <a:extLst>
               <a:ext uri="{28A0092B-C50C-407E-A947-70E740481C1C}">
                 <a14:useLocalDpi xmlns:a14="http://schemas.microsoft.com/office/drawing/2010/main" val="0"/>
@@ -3343,104 +3323,70 @@
       </p:pic>
       <p:pic>
         <p:nvPicPr>
-          <p:cNvPr id="1036" name="Picture 12" descr="German Cooperation Logo Vector">
-            <a:extLst>
-              <a:ext uri="{FF2B5EF4-FFF2-40B4-BE49-F238E27FC236}">
-                <a16:creationId xmlns:a16="http://schemas.microsoft.com/office/drawing/2014/main" id="{794AAC9D-A4D1-40B3-DE3D-7DF8782A8901}"/>
-              </a:ext>
-            </a:extLst>
-          </p:cNvPr>
+          <p:cNvPr id="20" name="Grafik 19"/>
           <p:cNvPicPr>
-            <a:picLocks noChangeAspect="1" noChangeArrowheads="1"/>
+            <a:picLocks noChangeAspect="1"/>
           </p:cNvPicPr>
           <p:nvPr/>
         </p:nvPicPr>
         <p:blipFill>
-          <a:blip r:embed="rId8" cstate="print">
+          <a:blip r:embed="rId6" cstate="print">
             <a:extLst>
               <a:ext uri="{28A0092B-C50C-407E-A947-70E740481C1C}">
                 <a14:useLocalDpi xmlns:a14="http://schemas.microsoft.com/office/drawing/2010/main" val="0"/>
               </a:ext>
             </a:extLst>
           </a:blip>
-          <a:srcRect/>
           <a:stretch>
             <a:fillRect/>
           </a:stretch>
         </p:blipFill>
-        <p:spPr bwMode="auto">
+        <p:spPr>
           <a:xfrm>
-            <a:off x="2667000" y="6536868"/>
-            <a:ext cx="1308742" cy="794148"/>
+            <a:off x="341424" y="381969"/>
+            <a:ext cx="982591" cy="462881"/>
           </a:xfrm>
           <a:prstGeom prst="rect">
             <a:avLst/>
           </a:prstGeom>
-          <a:noFill/>
-          <a:extLst>
-            <a:ext uri="{909E8E84-426E-40DD-AFC4-6F175D3DCCD1}">
-              <a14:hiddenFill xmlns:a14="http://schemas.microsoft.com/office/drawing/2010/main">
-                <a:solidFill>
-                  <a:srgbClr val="FFFFFF"/>
-                </a:solidFill>
-              </a14:hiddenFill>
-            </a:ext>
-          </a:extLst>
         </p:spPr>
       </p:pic>
       <p:pic>
         <p:nvPicPr>
-          <p:cNvPr id="15" name="Picture 6">
-            <a:extLst>
-              <a:ext uri="{FF2B5EF4-FFF2-40B4-BE49-F238E27FC236}">
-                <a16:creationId xmlns:a16="http://schemas.microsoft.com/office/drawing/2014/main" id="{FF341CFD-073B-95EE-3B81-85360D29EFE0}"/>
-              </a:ext>
-            </a:extLst>
-          </p:cNvPr>
+          <p:cNvPr id="21" name="Grafik 20"/>
           <p:cNvPicPr>
-            <a:picLocks noChangeAspect="1" noChangeArrowheads="1"/>
+            <a:picLocks noChangeAspect="1"/>
           </p:cNvPicPr>
           <p:nvPr/>
         </p:nvPicPr>
         <p:blipFill>
-          <a:blip r:embed="rId3" cstate="print">
+          <a:blip r:embed="rId6" cstate="print">
             <a:extLst>
               <a:ext uri="{28A0092B-C50C-407E-A947-70E740481C1C}">
                 <a14:useLocalDpi xmlns:a14="http://schemas.microsoft.com/office/drawing/2010/main" val="0"/>
               </a:ext>
             </a:extLst>
           </a:blip>
-          <a:srcRect/>
           <a:stretch>
             <a:fillRect/>
           </a:stretch>
         </p:blipFill>
-        <p:spPr bwMode="auto">
+        <p:spPr>
           <a:xfrm>
-            <a:off x="641503" y="312694"/>
-            <a:ext cx="936162" cy="757687"/>
+            <a:off x="2993151" y="5698902"/>
+            <a:ext cx="982591" cy="462881"/>
           </a:xfrm>
           <a:prstGeom prst="rect">
             <a:avLst/>
           </a:prstGeom>
-          <a:noFill/>
-          <a:extLst>
-            <a:ext uri="{909E8E84-426E-40DD-AFC4-6F175D3DCCD1}">
-              <a14:hiddenFill xmlns:a14="http://schemas.microsoft.com/office/drawing/2010/main">
-                <a:solidFill>
-                  <a:srgbClr val="FFFFFF"/>
-                </a:solidFill>
-              </a14:hiddenFill>
-            </a:ext>
-          </a:extLst>
         </p:spPr>
       </p:pic>
       <p:sp>
         <p:nvSpPr>
-          <p:cNvPr id="2" name="object 2">
+          <p:cNvPr id="2" name="object 4">
             <a:extLst>
               <a:ext uri="{FF2B5EF4-FFF2-40B4-BE49-F238E27FC236}">
-                <a16:creationId xmlns:a16="http://schemas.microsoft.com/office/drawing/2014/main" id="{DCF3A145-200B-9115-EF4E-2DB359BB625F}"/>
+                <a16:creationId xmlns:a16="http://schemas.microsoft.com/office/drawing/2014/main" id="{C9D2F8CB-77E0-46D1-BE9B-58F146849A57}"/>
               </a:ext>
             </a:extLst>
           </p:cNvPr>
@@ -3449,61 +3395,75 @@
         </p:nvSpPr>
         <p:spPr>
           <a:xfrm>
-            <a:off x="590854" y="10014104"/>
-            <a:ext cx="4952696" cy="198131"/>
+            <a:off x="887488" y="10298838"/>
+            <a:ext cx="6394146" cy="183640"/>
           </a:xfrm>
           <a:prstGeom prst="rect">
             <a:avLst/>
           </a:prstGeom>
         </p:spPr>
         <p:txBody>
-          <a:bodyPr vert="horz" wrap="square" lIns="0" tIns="13335" rIns="0" bIns="0" rtlCol="0">
+          <a:bodyPr vert="horz" wrap="square" lIns="0" tIns="8255" rIns="0" bIns="0" rtlCol="0">
             <a:spAutoFit/>
           </a:bodyPr>
           <a:lstStyle/>
           <a:p>
-            <a:pPr marL="12700">
+            <a:pPr marL="12700" marR="5080">
               <a:lnSpc>
-                <a:spcPct val="100000"/>
+                <a:spcPct val="102099"/>
               </a:lnSpc>
               <a:spcBef>
-                <a:spcPts val="105"/>
+                <a:spcPts val="65"/>
               </a:spcBef>
             </a:pPr>
             <a:r>
-              <a:rPr lang="en-US" sz="1200" b="1" spc="50" dirty="0">
-                <a:solidFill>
-                  <a:srgbClr val="FFFFFF"/>
+              <a:rPr lang="en-US" sz="1200" b="1" i="1" spc="70" dirty="0">
+                <a:solidFill>
+                  <a:schemeClr val="bg1"/>
                 </a:solidFill>
                 <a:latin typeface="Century Gothic" panose="020B0502020202020204" pitchFamily="34" charset="0"/>
                 <a:ea typeface="Roboto" panose="02000000000000000000" pitchFamily="2" charset="0"/>
                 <a:cs typeface="Roboto" panose="02000000000000000000" pitchFamily="2" charset="0"/>
               </a:rPr>
-              <a:t>Event website</a:t>
-            </a:r>
-            <a:r>
-              <a:rPr sz="1200" b="1" spc="50" dirty="0">
-                <a:solidFill>
-                  <a:srgbClr val="FFFFFF"/>
+              <a:t>Website</a:t>
+            </a:r>
+            <a:r>
+              <a:rPr lang="ru-RU" sz="1200" b="1" i="1" spc="70" dirty="0">
+                <a:solidFill>
+                  <a:schemeClr val="bg1"/>
                 </a:solidFill>
                 <a:latin typeface="Century Gothic" panose="020B0502020202020204" pitchFamily="34" charset="0"/>
                 <a:ea typeface="Roboto" panose="02000000000000000000" pitchFamily="2" charset="0"/>
                 <a:cs typeface="Roboto" panose="02000000000000000000" pitchFamily="2" charset="0"/>
               </a:rPr>
-              <a:t>:</a:t>
-            </a:r>
-            <a:r>
-              <a:rPr lang="en-US" sz="1200" b="1" spc="50" dirty="0">
-                <a:solidFill>
-                  <a:srgbClr val="FFFFFF"/>
+              <a:t>: </a:t>
+            </a:r>
+            <a:r>
+              <a:rPr lang="de-DE" sz="1200" b="1" i="1" spc="70" dirty="0">
+                <a:solidFill>
+                  <a:schemeClr val="bg1"/>
                 </a:solidFill>
                 <a:latin typeface="Century Gothic" panose="020B0502020202020204" pitchFamily="34" charset="0"/>
                 <a:ea typeface="Roboto" panose="02000000000000000000" pitchFamily="2" charset="0"/>
                 <a:cs typeface="Roboto" panose="02000000000000000000" pitchFamily="2" charset="0"/>
               </a:rPr>
-              <a:t> kazgerlogisticsforum.kz </a:t>
+              <a:t>kazgerlogisticsforum.kz </a:t>
+            </a:r>
+            <a:r>
+              <a:rPr lang="ru-RU" sz="1200" b="1" i="1" spc="70" dirty="0">
+                <a:solidFill>
+                  <a:schemeClr val="bg1"/>
+                </a:solidFill>
+                <a:latin typeface="Century Gothic" panose="020B0502020202020204" pitchFamily="34" charset="0"/>
+                <a:ea typeface="Roboto" panose="02000000000000000000" pitchFamily="2" charset="0"/>
+                <a:cs typeface="Roboto" panose="02000000000000000000" pitchFamily="2" charset="0"/>
+              </a:rPr>
+              <a:t> </a:t>
             </a:r>
             <a:endParaRPr sz="1200" dirty="0">
+              <a:solidFill>
+                <a:schemeClr val="bg1"/>
+              </a:solidFill>
               <a:latin typeface="Century Gothic" panose="020B0502020202020204" pitchFamily="34" charset="0"/>
               <a:ea typeface="Roboto" panose="02000000000000000000" pitchFamily="2" charset="0"/>
               <a:cs typeface="Roboto" panose="02000000000000000000" pitchFamily="2" charset="0"/>
@@ -3511,6 +3471,132 @@
           </a:p>
         </p:txBody>
       </p:sp>
+      <p:sp>
+        <p:nvSpPr>
+          <p:cNvPr id="7" name="object 4">
+            <a:extLst>
+              <a:ext uri="{FF2B5EF4-FFF2-40B4-BE49-F238E27FC236}">
+                <a16:creationId xmlns:a16="http://schemas.microsoft.com/office/drawing/2014/main" id="{44F78EFB-2626-A8C4-A674-9C8F54E4B6CE}"/>
+              </a:ext>
+            </a:extLst>
+          </p:cNvPr>
+          <p:cNvSpPr txBox="1"/>
+          <p:nvPr/>
+        </p:nvSpPr>
+        <p:spPr>
+          <a:xfrm>
+            <a:off x="778179" y="10154601"/>
+            <a:ext cx="6394146" cy="183640"/>
+          </a:xfrm>
+          <a:prstGeom prst="rect">
+            <a:avLst/>
+          </a:prstGeom>
+        </p:spPr>
+        <p:txBody>
+          <a:bodyPr vert="horz" wrap="square" lIns="0" tIns="8255" rIns="0" bIns="0" rtlCol="0">
+            <a:spAutoFit/>
+          </a:bodyPr>
+          <a:lstStyle/>
+          <a:p>
+            <a:pPr marL="12700" marR="5080">
+              <a:lnSpc>
+                <a:spcPct val="102099"/>
+              </a:lnSpc>
+              <a:spcBef>
+                <a:spcPts val="65"/>
+              </a:spcBef>
+            </a:pPr>
+            <a:r>
+              <a:rPr lang="kk-KZ" sz="1200" b="1" i="1" spc="70" dirty="0">
+                <a:solidFill>
+                  <a:schemeClr val="bg1"/>
+                </a:solidFill>
+                <a:latin typeface="Century Gothic" panose="020B0502020202020204" pitchFamily="34" charset="0"/>
+                <a:ea typeface="Roboto" panose="02000000000000000000" pitchFamily="2" charset="0"/>
+                <a:cs typeface="Roboto" panose="02000000000000000000" pitchFamily="2" charset="0"/>
+              </a:rPr>
+              <a:t>Сайт</a:t>
+            </a:r>
+            <a:r>
+              <a:rPr lang="ru-RU" sz="1200" b="1" i="1" spc="70" dirty="0">
+                <a:solidFill>
+                  <a:schemeClr val="bg1"/>
+                </a:solidFill>
+                <a:latin typeface="Century Gothic" panose="020B0502020202020204" pitchFamily="34" charset="0"/>
+                <a:ea typeface="Roboto" panose="02000000000000000000" pitchFamily="2" charset="0"/>
+                <a:cs typeface="Roboto" panose="02000000000000000000" pitchFamily="2" charset="0"/>
+              </a:rPr>
+              <a:t> мероприятия: </a:t>
+            </a:r>
+            <a:r>
+              <a:rPr lang="de-DE" sz="1200" b="1" i="1" spc="70" dirty="0">
+                <a:solidFill>
+                  <a:schemeClr val="bg1"/>
+                </a:solidFill>
+                <a:latin typeface="Century Gothic" panose="020B0502020202020204" pitchFamily="34" charset="0"/>
+                <a:ea typeface="Roboto" panose="02000000000000000000" pitchFamily="2" charset="0"/>
+                <a:cs typeface="Roboto" panose="02000000000000000000" pitchFamily="2" charset="0"/>
+              </a:rPr>
+              <a:t>kazgerlogisticsforum.kz </a:t>
+            </a:r>
+            <a:r>
+              <a:rPr lang="ru-RU" sz="1200" b="1" i="1" spc="70" dirty="0">
+                <a:solidFill>
+                  <a:schemeClr val="bg1"/>
+                </a:solidFill>
+                <a:latin typeface="Century Gothic" panose="020B0502020202020204" pitchFamily="34" charset="0"/>
+                <a:ea typeface="Roboto" panose="02000000000000000000" pitchFamily="2" charset="0"/>
+                <a:cs typeface="Roboto" panose="02000000000000000000" pitchFamily="2" charset="0"/>
+              </a:rPr>
+              <a:t> </a:t>
+            </a:r>
+            <a:endParaRPr sz="1200" dirty="0">
+              <a:solidFill>
+                <a:schemeClr val="bg1"/>
+              </a:solidFill>
+              <a:latin typeface="Century Gothic" panose="020B0502020202020204" pitchFamily="34" charset="0"/>
+              <a:ea typeface="Roboto" panose="02000000000000000000" pitchFamily="2" charset="0"/>
+              <a:cs typeface="Roboto" panose="02000000000000000000" pitchFamily="2" charset="0"/>
+            </a:endParaRPr>
+          </a:p>
+        </p:txBody>
+      </p:sp>
+      <p:pic>
+        <p:nvPicPr>
+          <p:cNvPr id="11" name="Рисунок 10" descr="Изображение выглядит как текст, графический дизайн, Графика, Шрифт&#10;&#10;Автоматически созданное описание">
+            <a:extLst>
+              <a:ext uri="{FF2B5EF4-FFF2-40B4-BE49-F238E27FC236}">
+                <a16:creationId xmlns:a16="http://schemas.microsoft.com/office/drawing/2014/main" id="{A247AAC1-7DAB-7739-1B27-A9F54775EBB6}"/>
+              </a:ext>
+            </a:extLst>
+          </p:cNvPr>
+          <p:cNvPicPr>
+            <a:picLocks noChangeAspect="1"/>
+          </p:cNvPicPr>
+          <p:nvPr/>
+        </p:nvPicPr>
+        <p:blipFill>
+          <a:blip r:embed="rId7" cstate="print">
+            <a:extLst>
+              <a:ext uri="{28A0092B-C50C-407E-A947-70E740481C1C}">
+                <a14:useLocalDpi xmlns:a14="http://schemas.microsoft.com/office/drawing/2010/main" val="0"/>
+              </a:ext>
+            </a:extLst>
+          </a:blip>
+          <a:stretch>
+            <a:fillRect/>
+          </a:stretch>
+        </p:blipFill>
+        <p:spPr>
+          <a:xfrm>
+            <a:off x="2779093" y="6346899"/>
+            <a:ext cx="2895237" cy="1063688"/>
+          </a:xfrm>
+          <a:prstGeom prst="rect">
+            <a:avLst/>
+          </a:prstGeom>
+        </p:spPr>
+      </p:pic>
     </p:spTree>
     <p:extLst>
       <p:ext uri="{BB962C8B-B14F-4D97-AF65-F5344CB8AC3E}">
@@ -3594,53 +3680,6 @@
           </a:extLst>
         </p:spPr>
       </p:pic>
-      <p:pic>
-        <p:nvPicPr>
-          <p:cNvPr id="4" name="Picture 6">
-            <a:extLst>
-              <a:ext uri="{FF2B5EF4-FFF2-40B4-BE49-F238E27FC236}">
-                <a16:creationId xmlns:a16="http://schemas.microsoft.com/office/drawing/2014/main" id="{27E2CB62-0CA2-5EDF-DF03-3B5766C1C889}"/>
-              </a:ext>
-            </a:extLst>
-          </p:cNvPr>
-          <p:cNvPicPr>
-            <a:picLocks noChangeAspect="1" noChangeArrowheads="1"/>
-          </p:cNvPicPr>
-          <p:nvPr/>
-        </p:nvPicPr>
-        <p:blipFill>
-          <a:blip r:embed="rId3" cstate="print">
-            <a:extLst>
-              <a:ext uri="{28A0092B-C50C-407E-A947-70E740481C1C}">
-                <a14:useLocalDpi xmlns:a14="http://schemas.microsoft.com/office/drawing/2010/main" val="0"/>
-              </a:ext>
-            </a:extLst>
-          </a:blip>
-          <a:srcRect/>
-          <a:stretch>
-            <a:fillRect/>
-          </a:stretch>
-        </p:blipFill>
-        <p:spPr bwMode="auto">
-          <a:xfrm>
-            <a:off x="595086" y="234566"/>
-            <a:ext cx="936162" cy="757687"/>
-          </a:xfrm>
-          <a:prstGeom prst="rect">
-            <a:avLst/>
-          </a:prstGeom>
-          <a:noFill/>
-          <a:extLst>
-            <a:ext uri="{909E8E84-426E-40DD-AFC4-6F175D3DCCD1}">
-              <a14:hiddenFill xmlns:a14="http://schemas.microsoft.com/office/drawing/2010/main">
-                <a:solidFill>
-                  <a:srgbClr val="FFFFFF"/>
-                </a:solidFill>
-              </a14:hiddenFill>
-            </a:ext>
-          </a:extLst>
-        </p:spPr>
-      </p:pic>
       <p:sp>
         <p:nvSpPr>
           <p:cNvPr id="2" name="object 2">
@@ -3655,8 +3694,8 @@
         </p:nvSpPr>
         <p:spPr>
           <a:xfrm>
-            <a:off x="1009650" y="1504949"/>
-            <a:ext cx="5924292" cy="9044784"/>
+            <a:off x="837448" y="1249615"/>
+            <a:ext cx="5924292" cy="9229450"/>
           </a:xfrm>
           <a:prstGeom prst="rect">
             <a:avLst/>
@@ -3731,7 +3770,7 @@
                 <a:latin typeface="Century Gothic" panose="020B0502020202020204" pitchFamily="34" charset="0"/>
                 <a:cs typeface="Calibri"/>
               </a:rPr>
-              <a:t> University (Kazakhstan), in cooperation with </a:t>
+              <a:t> University (Kazakhstan), in cooperation with Federal Association of Logistics (BVL </a:t>
             </a:r>
             <a:r>
               <a:rPr lang="en-US" sz="1200" noProof="0" dirty="0" err="1">
@@ -3771,7 +3810,7 @@
                 <a:latin typeface="Century Gothic" panose="020B0502020202020204" pitchFamily="34" charset="0"/>
                 <a:cs typeface="Calibri"/>
               </a:rPr>
-              <a:t> (BVL) (Germany), cordially invites you to participate in the </a:t>
+              <a:t>, Germany), cordially invites you to participate in the </a:t>
             </a:r>
             <a:r>
               <a:rPr lang="en-US" sz="1200" b="1" noProof="0" dirty="0">
@@ -3781,7 +3820,57 @@
                 <a:latin typeface="Century Gothic" panose="020B0502020202020204" pitchFamily="34" charset="0"/>
                 <a:cs typeface="Calibri"/>
               </a:rPr>
-              <a:t>Kazakhstan–German Transport and Logistics Forum “Digitalization, Human Capital, Transit Opportunities,” </a:t>
+              <a:t>1</a:t>
+            </a:r>
+            <a:r>
+              <a:rPr lang="en-US" sz="1200" b="1" baseline="30000" noProof="0" dirty="0">
+                <a:solidFill>
+                  <a:srgbClr val="002060"/>
+                </a:solidFill>
+                <a:latin typeface="Century Gothic" panose="020B0502020202020204" pitchFamily="34" charset="0"/>
+                <a:cs typeface="Calibri"/>
+              </a:rPr>
+              <a:t>st</a:t>
+            </a:r>
+            <a:r>
+              <a:rPr lang="en-US" sz="1200" b="1" noProof="0" dirty="0">
+                <a:solidFill>
+                  <a:srgbClr val="002060"/>
+                </a:solidFill>
+                <a:latin typeface="Century Gothic" panose="020B0502020202020204" pitchFamily="34" charset="0"/>
+                <a:cs typeface="Calibri"/>
+              </a:rPr>
+              <a:t> </a:t>
+            </a:r>
+            <a:r>
+              <a:rPr lang="en-US" sz="1200" b="1" dirty="0">
+                <a:solidFill>
+                  <a:srgbClr val="002060"/>
+                </a:solidFill>
+                <a:latin typeface="Century Gothic" panose="020B0502020202020204" pitchFamily="34" charset="0"/>
+                <a:cs typeface="Calibri"/>
+              </a:rPr>
+              <a:t>K</a:t>
+            </a:r>
+            <a:r>
+              <a:rPr lang="en-US" sz="1200" b="1" noProof="0" dirty="0" err="1">
+                <a:solidFill>
+                  <a:srgbClr val="002060"/>
+                </a:solidFill>
+                <a:latin typeface="Century Gothic" panose="020B0502020202020204" pitchFamily="34" charset="0"/>
+                <a:cs typeface="Calibri"/>
+              </a:rPr>
+              <a:t>azakh</a:t>
+            </a:r>
+            <a:r>
+              <a:rPr lang="en-US" sz="1200" b="1" noProof="0" dirty="0">
+                <a:solidFill>
+                  <a:srgbClr val="002060"/>
+                </a:solidFill>
+                <a:latin typeface="Century Gothic" panose="020B0502020202020204" pitchFamily="34" charset="0"/>
+                <a:cs typeface="Calibri"/>
+              </a:rPr>
+              <a:t>-German Transport and Logistics Forum “Digitalization, Human Capital, Transit Opportunities,” </a:t>
             </a:r>
             <a:r>
               <a:rPr lang="en-US" sz="1200" noProof="0" dirty="0">
@@ -3932,6 +4021,163 @@
             </a:endParaRPr>
           </a:p>
           <a:p>
+            <a:pPr marL="12700" indent="349250" algn="l">
+              <a:lnSpc>
+                <a:spcPct val="100000"/>
+              </a:lnSpc>
+              <a:spcBef>
+                <a:spcPts val="710"/>
+              </a:spcBef>
+            </a:pPr>
+            <a:r>
+              <a:rPr lang="en-US" sz="1200" noProof="0" dirty="0">
+                <a:solidFill>
+                  <a:srgbClr val="002060"/>
+                </a:solidFill>
+                <a:latin typeface="Century Gothic" panose="020B0502020202020204" pitchFamily="34" charset="0"/>
+                <a:cs typeface="Calibri"/>
+              </a:rPr>
+              <a:t>For additional information, please contact:</a:t>
+            </a:r>
+            <a:endParaRPr lang="kk-KZ" sz="1200" noProof="0">
+              <a:solidFill>
+                <a:srgbClr val="002060"/>
+              </a:solidFill>
+              <a:latin typeface="Century Gothic" panose="020B0502020202020204" pitchFamily="34" charset="0"/>
+              <a:cs typeface="Calibri"/>
+            </a:endParaRPr>
+          </a:p>
+          <a:p>
+            <a:pPr marL="12700" indent="349250" algn="l">
+              <a:lnSpc>
+                <a:spcPct val="100000"/>
+              </a:lnSpc>
+              <a:spcBef>
+                <a:spcPts val="710"/>
+              </a:spcBef>
+            </a:pPr>
+            <a:r>
+              <a:rPr lang="en-US" sz="1200" noProof="0">
+                <a:solidFill>
+                  <a:srgbClr val="002060"/>
+                </a:solidFill>
+                <a:latin typeface="Century Gothic" panose="020B0502020202020204" pitchFamily="34" charset="0"/>
+                <a:cs typeface="Calibri"/>
+              </a:rPr>
+              <a:t> </a:t>
+            </a:r>
+            <a:r>
+              <a:rPr lang="en-US" sz="1200" dirty="0" err="1">
+                <a:solidFill>
+                  <a:srgbClr val="022868"/>
+                </a:solidFill>
+                <a:highlight>
+                  <a:srgbClr val="FFFF00"/>
+                </a:highlight>
+                <a:latin typeface="Century Gothic" panose="020B0502020202020204" pitchFamily="34" charset="0"/>
+                <a:cs typeface="Calibri"/>
+              </a:rPr>
+              <a:t>s.bolatkyzy</a:t>
+            </a:r>
+            <a:r>
+              <a:rPr lang="en-US" sz="1200" dirty="0">
+                <a:solidFill>
+                  <a:srgbClr val="022868"/>
+                </a:solidFill>
+                <a:highlight>
+                  <a:srgbClr val="FFFF00"/>
+                </a:highlight>
+                <a:latin typeface="Century Gothic" panose="020B0502020202020204" pitchFamily="34" charset="0"/>
+                <a:cs typeface="Calibri"/>
+              </a:rPr>
+              <a:t> </a:t>
+            </a:r>
+            <a:r>
+              <a:rPr lang="en-US" sz="1200" noProof="0" dirty="0">
+                <a:solidFill>
+                  <a:srgbClr val="002060"/>
+                </a:solidFill>
+                <a:highlight>
+                  <a:srgbClr val="FFFF00"/>
+                </a:highlight>
+                <a:latin typeface="Century Gothic" panose="020B0502020202020204" pitchFamily="34" charset="0"/>
+                <a:cs typeface="Calibri"/>
+                <a:hlinkClick r:id="rId3"/>
+              </a:rPr>
+              <a:t>@satbayev.university</a:t>
+            </a:r>
+            <a:r>
+              <a:rPr lang="en-US" sz="1200" noProof="0" dirty="0">
+                <a:solidFill>
+                  <a:srgbClr val="002060"/>
+                </a:solidFill>
+                <a:highlight>
+                  <a:srgbClr val="FFFF00"/>
+                </a:highlight>
+                <a:latin typeface="Century Gothic" panose="020B0502020202020204" pitchFamily="34" charset="0"/>
+                <a:cs typeface="Calibri"/>
+              </a:rPr>
+              <a:t> </a:t>
+            </a:r>
+          </a:p>
+          <a:p>
+            <a:pPr marL="12700" indent="349250" algn="l">
+              <a:lnSpc>
+                <a:spcPct val="100000"/>
+              </a:lnSpc>
+              <a:spcBef>
+                <a:spcPts val="710"/>
+              </a:spcBef>
+            </a:pPr>
+            <a:r>
+              <a:rPr lang="en-US" sz="1200" noProof="0" dirty="0">
+                <a:solidFill>
+                  <a:srgbClr val="002060"/>
+                </a:solidFill>
+                <a:latin typeface="Century Gothic" panose="020B0502020202020204" pitchFamily="34" charset="0"/>
+                <a:cs typeface="Calibri"/>
+              </a:rPr>
+              <a:t>Questions for the open discussion may be submitted in advance to: </a:t>
+            </a:r>
+            <a:r>
+              <a:rPr lang="en-US" sz="1200" noProof="0" dirty="0">
+                <a:solidFill>
+                  <a:srgbClr val="002060"/>
+                </a:solidFill>
+                <a:highlight>
+                  <a:srgbClr val="FFFF00"/>
+                </a:highlight>
+                <a:latin typeface="Century Gothic" panose="020B0502020202020204" pitchFamily="34" charset="0"/>
+                <a:cs typeface="Calibri"/>
+                <a:hlinkClick r:id="rId4"/>
+              </a:rPr>
+              <a:t>info@logistics-alliance-germany.de</a:t>
+            </a:r>
+            <a:r>
+              <a:rPr lang="en-US" sz="1200" dirty="0">
+                <a:solidFill>
+                  <a:srgbClr val="002060"/>
+                </a:solidFill>
+                <a:highlight>
+                  <a:srgbClr val="FFFF00"/>
+                </a:highlight>
+                <a:latin typeface="Century Gothic" panose="020B0502020202020204" pitchFamily="34" charset="0"/>
+                <a:cs typeface="Calibri"/>
+              </a:rPr>
+              <a:t> </a:t>
+            </a:r>
+            <a:endParaRPr lang="en-US" sz="1200" noProof="0" dirty="0">
+              <a:solidFill>
+                <a:srgbClr val="002060"/>
+              </a:solidFill>
+              <a:highlight>
+                <a:srgbClr val="FFFF00"/>
+              </a:highlight>
+              <a:latin typeface="Century Gothic" panose="020B0502020202020204" pitchFamily="34" charset="0"/>
+              <a:cs typeface="Calibri"/>
+            </a:endParaRPr>
+          </a:p>
+          <a:p>
             <a:pPr marL="12700" indent="349250" algn="just">
               <a:lnSpc>
                 <a:spcPct val="100000"/>
@@ -3940,37 +4186,13 @@
                 <a:spcPts val="710"/>
               </a:spcBef>
             </a:pPr>
-            <a:r>
-              <a:rPr lang="en-US" sz="1200" noProof="0" dirty="0">
-                <a:solidFill>
-                  <a:srgbClr val="002060"/>
-                </a:solidFill>
-                <a:latin typeface="Century Gothic" panose="020B0502020202020204" pitchFamily="34" charset="0"/>
-                <a:cs typeface="Calibri"/>
-              </a:rPr>
-              <a:t>For additional information, please contact: </a:t>
-            </a:r>
-            <a:r>
-              <a:rPr lang="en-US" sz="1200" noProof="0" dirty="0" err="1">
-                <a:solidFill>
-                  <a:srgbClr val="002060"/>
-                </a:solidFill>
-                <a:latin typeface="Century Gothic" panose="020B0502020202020204" pitchFamily="34" charset="0"/>
-                <a:cs typeface="Calibri"/>
-                <a:hlinkClick r:id="rId4"/>
-              </a:rPr>
-              <a:t>z.tymbayeva@satbayev.university</a:t>
-            </a:r>
-            <a:r>
-              <a:rPr lang="en-US" sz="1200" noProof="0" dirty="0">
-                <a:solidFill>
-                  <a:srgbClr val="002060"/>
-                </a:solidFill>
-                <a:latin typeface="Century Gothic" panose="020B0502020202020204" pitchFamily="34" charset="0"/>
-                <a:cs typeface="Calibri"/>
-              </a:rPr>
-              <a:t> </a:t>
-            </a:r>
+            <a:endParaRPr lang="en-US" sz="1200" b="1" noProof="0" dirty="0">
+              <a:solidFill>
+                <a:srgbClr val="002060"/>
+              </a:solidFill>
+              <a:latin typeface="Century Gothic" panose="020B0502020202020204" pitchFamily="34" charset="0"/>
+              <a:cs typeface="Calibri"/>
+            </a:endParaRPr>
           </a:p>
           <a:p>
             <a:pPr marL="12700" indent="349250" algn="just">
@@ -3982,43 +4204,25 @@
               </a:spcBef>
             </a:pPr>
             <a:r>
-              <a:rPr lang="en-US" sz="1200" noProof="0" dirty="0">
-                <a:solidFill>
-                  <a:srgbClr val="002060"/>
-                </a:solidFill>
-                <a:latin typeface="Century Gothic" panose="020B0502020202020204" pitchFamily="34" charset="0"/>
-                <a:cs typeface="Calibri"/>
-              </a:rPr>
-              <a:t>Questions for the open discussion may be submitted in advance to: </a:t>
-            </a:r>
-            <a:r>
-              <a:rPr lang="en-US" sz="1200" noProof="0" dirty="0">
-                <a:solidFill>
-                  <a:srgbClr val="002060"/>
-                </a:solidFill>
-                <a:latin typeface="Century Gothic" panose="020B0502020202020204" pitchFamily="34" charset="0"/>
-                <a:cs typeface="Calibri"/>
-                <a:hlinkClick r:id="rId5"/>
-              </a:rPr>
-              <a:t>info@logistics-alliance-germany.de</a:t>
-            </a:r>
-            <a:r>
-              <a:rPr lang="en-US" sz="1200" dirty="0">
-                <a:solidFill>
-                  <a:srgbClr val="002060"/>
-                </a:solidFill>
-                <a:latin typeface="Century Gothic" panose="020B0502020202020204" pitchFamily="34" charset="0"/>
-                <a:cs typeface="Calibri"/>
-              </a:rPr>
-              <a:t> </a:t>
-            </a:r>
-            <a:endParaRPr lang="en-US" sz="1200" noProof="0" dirty="0">
-              <a:solidFill>
-                <a:srgbClr val="002060"/>
-              </a:solidFill>
-              <a:latin typeface="Century Gothic" panose="020B0502020202020204" pitchFamily="34" charset="0"/>
-              <a:cs typeface="Calibri"/>
-            </a:endParaRPr>
+              <a:rPr lang="en-US" sz="1200" b="1" dirty="0">
+                <a:solidFill>
+                  <a:srgbClr val="002060"/>
+                </a:solidFill>
+                <a:latin typeface="Century Gothic" panose="020B0502020202020204" pitchFamily="34" charset="0"/>
+                <a:cs typeface="Calibri"/>
+              </a:rPr>
+              <a:t>Sincerely y</a:t>
+            </a:r>
+            <a:r>
+              <a:rPr lang="en-US" sz="1200" b="1" noProof="0" dirty="0">
+                <a:solidFill>
+                  <a:srgbClr val="002060"/>
+                </a:solidFill>
+                <a:latin typeface="Century Gothic" panose="020B0502020202020204" pitchFamily="34" charset="0"/>
+                <a:cs typeface="Calibri"/>
+              </a:rPr>
+              <a:t>ours,</a:t>
+            </a:r>
           </a:p>
           <a:p>
             <a:pPr marL="12700" indent="349250" algn="just">
@@ -4029,6 +4233,36 @@
                 <a:spcPts val="710"/>
               </a:spcBef>
             </a:pPr>
+            <a:r>
+              <a:rPr lang="en-US" sz="1200" b="1" noProof="0" dirty="0" err="1">
+                <a:solidFill>
+                  <a:srgbClr val="002060"/>
+                </a:solidFill>
+                <a:latin typeface="Century Gothic" panose="020B0502020202020204" pitchFamily="34" charset="0"/>
+                <a:cs typeface="Calibri"/>
+              </a:rPr>
+              <a:t>Meyram</a:t>
+            </a:r>
+            <a:r>
+              <a:rPr lang="en-US" sz="1200" b="1" noProof="0" dirty="0">
+                <a:solidFill>
+                  <a:srgbClr val="002060"/>
+                </a:solidFill>
+                <a:latin typeface="Century Gothic" panose="020B0502020202020204" pitchFamily="34" charset="0"/>
+                <a:cs typeface="Calibri"/>
+              </a:rPr>
+              <a:t> M. </a:t>
+            </a:r>
+            <a:r>
+              <a:rPr lang="en-US" sz="1200" b="1" noProof="0" dirty="0" err="1">
+                <a:solidFill>
+                  <a:srgbClr val="002060"/>
+                </a:solidFill>
+                <a:latin typeface="Century Gothic" panose="020B0502020202020204" pitchFamily="34" charset="0"/>
+                <a:cs typeface="Calibri"/>
+              </a:rPr>
+              <a:t>Begentayev</a:t>
+            </a:r>
             <a:endParaRPr lang="en-US" sz="1200" b="1" noProof="0" dirty="0">
               <a:solidFill>
                 <a:srgbClr val="002060"/>
@@ -4047,16 +4281,6 @@
               </a:spcBef>
             </a:pPr>
             <a:r>
-              <a:rPr lang="en-US" sz="1200" b="1" dirty="0">
-                <a:solidFill>
-                  <a:srgbClr val="002060"/>
-                </a:solidFill>
-                <a:latin typeface="Century Gothic" panose="020B0502020202020204" pitchFamily="34" charset="0"/>
-                <a:cs typeface="Calibri"/>
-              </a:rPr>
-              <a:t>Sincerely y</a:t>
-            </a:r>
-            <a:r>
               <a:rPr lang="en-US" sz="1200" b="1" noProof="0" dirty="0">
                 <a:solidFill>
                   <a:srgbClr val="002060"/>
@@ -4064,7 +4288,27 @@
                 <a:latin typeface="Century Gothic" panose="020B0502020202020204" pitchFamily="34" charset="0"/>
                 <a:cs typeface="Calibri"/>
               </a:rPr>
-              <a:t>ours,</a:t>
+              <a:t>Chairman of the Board – Rector of the </a:t>
+            </a:r>
+            <a:r>
+              <a:rPr lang="en-US" sz="1200" b="1" noProof="0" dirty="0" err="1">
+                <a:solidFill>
+                  <a:srgbClr val="002060"/>
+                </a:solidFill>
+                <a:latin typeface="Century Gothic" panose="020B0502020202020204" pitchFamily="34" charset="0"/>
+                <a:cs typeface="Calibri"/>
+              </a:rPr>
+              <a:t>Satbayev</a:t>
+            </a:r>
+            <a:r>
+              <a:rPr lang="en-US" sz="1200" b="1" noProof="0" dirty="0">
+                <a:solidFill>
+                  <a:srgbClr val="002060"/>
+                </a:solidFill>
+                <a:latin typeface="Century Gothic" panose="020B0502020202020204" pitchFamily="34" charset="0"/>
+                <a:cs typeface="Calibri"/>
+              </a:rPr>
+              <a:t> University</a:t>
             </a:r>
           </a:p>
           <a:p>
@@ -4076,36 +4320,196 @@
                 <a:spcPts val="710"/>
               </a:spcBef>
             </a:pPr>
-            <a:r>
-              <a:rPr lang="en-US" sz="1200" b="1" noProof="0" dirty="0" err="1">
-                <a:solidFill>
-                  <a:srgbClr val="002060"/>
-                </a:solidFill>
-                <a:latin typeface="Century Gothic" panose="020B0502020202020204" pitchFamily="34" charset="0"/>
-                <a:cs typeface="Calibri"/>
-              </a:rPr>
-              <a:t>Meyram</a:t>
-            </a:r>
-            <a:r>
-              <a:rPr lang="en-US" sz="1200" b="1" noProof="0" dirty="0">
-                <a:solidFill>
-                  <a:srgbClr val="002060"/>
-                </a:solidFill>
-                <a:latin typeface="Century Gothic" panose="020B0502020202020204" pitchFamily="34" charset="0"/>
-                <a:cs typeface="Calibri"/>
-              </a:rPr>
-              <a:t> M. </a:t>
-            </a:r>
-            <a:r>
-              <a:rPr lang="en-US" sz="1200" b="1" noProof="0" dirty="0" err="1">
-                <a:solidFill>
-                  <a:srgbClr val="002060"/>
-                </a:solidFill>
-                <a:latin typeface="Century Gothic" panose="020B0502020202020204" pitchFamily="34" charset="0"/>
-                <a:cs typeface="Calibri"/>
-              </a:rPr>
-              <a:t>Begentayev</a:t>
-            </a:r>
+            <a:endParaRPr lang="en-US" sz="1200" b="1" dirty="0">
+              <a:solidFill>
+                <a:srgbClr val="002060"/>
+              </a:solidFill>
+              <a:latin typeface="Century Gothic" panose="020B0502020202020204" pitchFamily="34" charset="0"/>
+              <a:cs typeface="Calibri"/>
+            </a:endParaRPr>
+          </a:p>
+          <a:p>
+            <a:pPr marL="12700" indent="349250" algn="just">
+              <a:lnSpc>
+                <a:spcPct val="100000"/>
+              </a:lnSpc>
+              <a:spcBef>
+                <a:spcPts val="710"/>
+              </a:spcBef>
+            </a:pPr>
+            <a:r>
+              <a:rPr lang="en-US" sz="1200" b="1" i="1" dirty="0">
+                <a:solidFill>
+                  <a:srgbClr val="002060"/>
+                </a:solidFill>
+                <a:latin typeface="Century Gothic" panose="020B0502020202020204" pitchFamily="34" charset="0"/>
+                <a:cs typeface="Calibri"/>
+              </a:rPr>
+              <a:t>and</a:t>
+            </a:r>
+            <a:r>
+              <a:rPr lang="en-US" sz="1200" b="1" dirty="0">
+                <a:solidFill>
+                  <a:srgbClr val="002060"/>
+                </a:solidFill>
+                <a:latin typeface="Century Gothic" panose="020B0502020202020204" pitchFamily="34" charset="0"/>
+                <a:cs typeface="Calibri"/>
+              </a:rPr>
+              <a:t> </a:t>
+            </a:r>
+          </a:p>
+          <a:p>
+            <a:pPr marL="12700" indent="349250" algn="just">
+              <a:lnSpc>
+                <a:spcPct val="100000"/>
+              </a:lnSpc>
+              <a:spcBef>
+                <a:spcPts val="710"/>
+              </a:spcBef>
+            </a:pPr>
+            <a:endParaRPr lang="en-US" sz="1200" b="1" dirty="0">
+              <a:solidFill>
+                <a:srgbClr val="002060"/>
+              </a:solidFill>
+              <a:latin typeface="Century Gothic" panose="020B0502020202020204" pitchFamily="34" charset="0"/>
+              <a:cs typeface="Calibri"/>
+            </a:endParaRPr>
+          </a:p>
+          <a:p>
+            <a:pPr marL="12700" indent="349250" algn="just">
+              <a:spcBef>
+                <a:spcPts val="710"/>
+              </a:spcBef>
+            </a:pPr>
+            <a:r>
+              <a:rPr lang="en-US" sz="1200" b="1" spc="-10" noProof="0" dirty="0">
+                <a:solidFill>
+                  <a:srgbClr val="002060"/>
+                </a:solidFill>
+                <a:uFill>
+                  <a:solidFill>
+                    <a:srgbClr val="39A0D2"/>
+                  </a:solidFill>
+                </a:uFill>
+                <a:latin typeface="Century Gothic" panose="020B0502020202020204" pitchFamily="34" charset="0"/>
+                <a:cs typeface="Calibri"/>
+              </a:rPr>
+              <a:t>Mirco Nowak</a:t>
+            </a:r>
+            <a:r>
+              <a:rPr lang="en-US" sz="1200" spc="-10" noProof="0" dirty="0">
+                <a:solidFill>
+                  <a:srgbClr val="002060"/>
+                </a:solidFill>
+                <a:uFill>
+                  <a:solidFill>
+                    <a:srgbClr val="39A0D2"/>
+                  </a:solidFill>
+                </a:uFill>
+                <a:latin typeface="Century Gothic" panose="020B0502020202020204" pitchFamily="34" charset="0"/>
+                <a:cs typeface="Calibri"/>
+              </a:rPr>
+              <a:t>, </a:t>
+            </a:r>
+          </a:p>
+          <a:p>
+            <a:pPr marL="12700" indent="349250" algn="just">
+              <a:spcBef>
+                <a:spcPts val="710"/>
+              </a:spcBef>
+            </a:pPr>
+            <a:r>
+              <a:rPr lang="en-US" sz="1200" b="1" spc="-10" noProof="0" dirty="0">
+                <a:solidFill>
+                  <a:srgbClr val="002060"/>
+                </a:solidFill>
+                <a:uFill>
+                  <a:solidFill>
+                    <a:srgbClr val="39A0D2"/>
+                  </a:solidFill>
+                </a:uFill>
+                <a:latin typeface="Century Gothic" panose="020B0502020202020204" pitchFamily="34" charset="0"/>
+                <a:cs typeface="Calibri"/>
+              </a:rPr>
+              <a:t>CEO, LUNO Group Chairperson, Eurasia Chapter,</a:t>
+            </a:r>
+          </a:p>
+          <a:p>
+            <a:pPr marL="12700" indent="349250" algn="just">
+              <a:spcBef>
+                <a:spcPts val="710"/>
+              </a:spcBef>
+            </a:pPr>
+            <a:r>
+              <a:rPr lang="en-US" sz="1200" b="1" spc="-10" noProof="0" dirty="0" err="1">
+                <a:solidFill>
+                  <a:srgbClr val="002060"/>
+                </a:solidFill>
+                <a:uFill>
+                  <a:solidFill>
+                    <a:srgbClr val="39A0D2"/>
+                  </a:solidFill>
+                </a:uFill>
+                <a:latin typeface="Century Gothic" panose="020B0502020202020204" pitchFamily="34" charset="0"/>
+                <a:cs typeface="Calibri"/>
+              </a:rPr>
+              <a:t>Bundesvereinigung</a:t>
+            </a:r>
+            <a:r>
+              <a:rPr lang="en-US" sz="1200" b="1" spc="-10" noProof="0" dirty="0">
+                <a:solidFill>
+                  <a:srgbClr val="002060"/>
+                </a:solidFill>
+                <a:uFill>
+                  <a:solidFill>
+                    <a:srgbClr val="39A0D2"/>
+                  </a:solidFill>
+                </a:uFill>
+                <a:latin typeface="Century Gothic" panose="020B0502020202020204" pitchFamily="34" charset="0"/>
+                <a:cs typeface="Calibri"/>
+              </a:rPr>
+              <a:t> </a:t>
+            </a:r>
+            <a:r>
+              <a:rPr lang="en-US" sz="1200" b="1" spc="-10" noProof="0" dirty="0" err="1">
+                <a:solidFill>
+                  <a:srgbClr val="002060"/>
+                </a:solidFill>
+                <a:uFill>
+                  <a:solidFill>
+                    <a:srgbClr val="39A0D2"/>
+                  </a:solidFill>
+                </a:uFill>
+                <a:latin typeface="Century Gothic" panose="020B0502020202020204" pitchFamily="34" charset="0"/>
+                <a:cs typeface="Calibri"/>
+              </a:rPr>
+              <a:t>Logistik</a:t>
+            </a:r>
+            <a:r>
+              <a:rPr lang="en-US" sz="1200" b="1" spc="-10" noProof="0" dirty="0">
+                <a:solidFill>
+                  <a:srgbClr val="002060"/>
+                </a:solidFill>
+                <a:uFill>
+                  <a:solidFill>
+                    <a:srgbClr val="39A0D2"/>
+                  </a:solidFill>
+                </a:uFill>
+                <a:latin typeface="Century Gothic" panose="020B0502020202020204" pitchFamily="34" charset="0"/>
+                <a:cs typeface="Calibri"/>
+              </a:rPr>
+              <a:t> (BVL), Germany</a:t>
+            </a:r>
+          </a:p>
+          <a:p>
+            <a:pPr marL="12700" indent="349250" algn="just">
+              <a:lnSpc>
+                <a:spcPct val="100000"/>
+              </a:lnSpc>
+              <a:spcBef>
+                <a:spcPts val="710"/>
+              </a:spcBef>
+            </a:pPr>
             <a:endParaRPr lang="en-US" sz="1200" b="1" noProof="0" dirty="0">
               <a:solidFill>
                 <a:srgbClr val="002060"/>
@@ -4115,253 +4519,6 @@
             </a:endParaRPr>
           </a:p>
           <a:p>
-            <a:pPr marL="12700" indent="349250" algn="just">
-              <a:lnSpc>
-                <a:spcPct val="100000"/>
-              </a:lnSpc>
-              <a:spcBef>
-                <a:spcPts val="710"/>
-              </a:spcBef>
-            </a:pPr>
-            <a:r>
-              <a:rPr lang="en-US" sz="1200" b="1" noProof="0" dirty="0">
-                <a:solidFill>
-                  <a:srgbClr val="002060"/>
-                </a:solidFill>
-                <a:latin typeface="Century Gothic" panose="020B0502020202020204" pitchFamily="34" charset="0"/>
-                <a:cs typeface="Calibri"/>
-              </a:rPr>
-              <a:t>Chairman of the Board – Rector of the </a:t>
-            </a:r>
-            <a:r>
-              <a:rPr lang="en-US" sz="1200" b="1" noProof="0" dirty="0" err="1">
-                <a:solidFill>
-                  <a:srgbClr val="002060"/>
-                </a:solidFill>
-                <a:latin typeface="Century Gothic" panose="020B0502020202020204" pitchFamily="34" charset="0"/>
-                <a:cs typeface="Calibri"/>
-              </a:rPr>
-              <a:t>Satbayev</a:t>
-            </a:r>
-            <a:r>
-              <a:rPr lang="en-US" sz="1200" b="1" noProof="0" dirty="0">
-                <a:solidFill>
-                  <a:srgbClr val="002060"/>
-                </a:solidFill>
-                <a:latin typeface="Century Gothic" panose="020B0502020202020204" pitchFamily="34" charset="0"/>
-                <a:cs typeface="Calibri"/>
-              </a:rPr>
-              <a:t> University</a:t>
-            </a:r>
-          </a:p>
-          <a:p>
-            <a:pPr marL="12700" indent="349250" algn="just">
-              <a:lnSpc>
-                <a:spcPct val="100000"/>
-              </a:lnSpc>
-              <a:spcBef>
-                <a:spcPts val="710"/>
-              </a:spcBef>
-            </a:pPr>
-            <a:endParaRPr lang="en-US" sz="1200" b="1" dirty="0">
-              <a:solidFill>
-                <a:srgbClr val="002060"/>
-              </a:solidFill>
-              <a:latin typeface="Century Gothic" panose="020B0502020202020204" pitchFamily="34" charset="0"/>
-              <a:cs typeface="Calibri"/>
-            </a:endParaRPr>
-          </a:p>
-          <a:p>
-            <a:pPr marL="12700" indent="349250" algn="just">
-              <a:lnSpc>
-                <a:spcPct val="100000"/>
-              </a:lnSpc>
-              <a:spcBef>
-                <a:spcPts val="710"/>
-              </a:spcBef>
-            </a:pPr>
-            <a:r>
-              <a:rPr lang="en-US" sz="1200" b="1" i="1" dirty="0">
-                <a:solidFill>
-                  <a:srgbClr val="002060"/>
-                </a:solidFill>
-                <a:latin typeface="Century Gothic" panose="020B0502020202020204" pitchFamily="34" charset="0"/>
-                <a:cs typeface="Calibri"/>
-              </a:rPr>
-              <a:t>and</a:t>
-            </a:r>
-            <a:r>
-              <a:rPr lang="en-US" sz="1200" b="1" dirty="0">
-                <a:solidFill>
-                  <a:srgbClr val="002060"/>
-                </a:solidFill>
-                <a:latin typeface="Century Gothic" panose="020B0502020202020204" pitchFamily="34" charset="0"/>
-                <a:cs typeface="Calibri"/>
-              </a:rPr>
-              <a:t> </a:t>
-            </a:r>
-          </a:p>
-          <a:p>
-            <a:pPr marL="12700" indent="349250" algn="just">
-              <a:lnSpc>
-                <a:spcPct val="100000"/>
-              </a:lnSpc>
-              <a:spcBef>
-                <a:spcPts val="710"/>
-              </a:spcBef>
-            </a:pPr>
-            <a:endParaRPr lang="en-US" sz="1200" b="1" dirty="0">
-              <a:solidFill>
-                <a:srgbClr val="002060"/>
-              </a:solidFill>
-              <a:latin typeface="Century Gothic" panose="020B0502020202020204" pitchFamily="34" charset="0"/>
-              <a:cs typeface="Calibri"/>
-            </a:endParaRPr>
-          </a:p>
-          <a:p>
-            <a:pPr marL="12700" indent="349250" algn="just">
-              <a:spcBef>
-                <a:spcPts val="710"/>
-              </a:spcBef>
-            </a:pPr>
-            <a:r>
-              <a:rPr lang="en-US" sz="1200" b="1" spc="-10" noProof="0" dirty="0">
-                <a:solidFill>
-                  <a:srgbClr val="002060"/>
-                </a:solidFill>
-                <a:uFill>
-                  <a:solidFill>
-                    <a:srgbClr val="39A0D2"/>
-                  </a:solidFill>
-                </a:uFill>
-                <a:latin typeface="Century Gothic" panose="020B0502020202020204" pitchFamily="34" charset="0"/>
-                <a:cs typeface="Calibri"/>
-              </a:rPr>
-              <a:t>Mirco Nowak</a:t>
-            </a:r>
-            <a:r>
-              <a:rPr lang="en-US" sz="1200" spc="-10" noProof="0" dirty="0">
-                <a:solidFill>
-                  <a:srgbClr val="002060"/>
-                </a:solidFill>
-                <a:uFill>
-                  <a:solidFill>
-                    <a:srgbClr val="39A0D2"/>
-                  </a:solidFill>
-                </a:uFill>
-                <a:latin typeface="Century Gothic" panose="020B0502020202020204" pitchFamily="34" charset="0"/>
-                <a:cs typeface="Calibri"/>
-              </a:rPr>
-              <a:t>, </a:t>
-            </a:r>
-          </a:p>
-          <a:p>
-            <a:pPr marL="12700" indent="349250" algn="just">
-              <a:spcBef>
-                <a:spcPts val="710"/>
-              </a:spcBef>
-            </a:pPr>
-            <a:r>
-              <a:rPr lang="en-US" sz="1200" b="1" spc="-10" noProof="0" dirty="0">
-                <a:solidFill>
-                  <a:srgbClr val="002060"/>
-                </a:solidFill>
-                <a:uFill>
-                  <a:solidFill>
-                    <a:srgbClr val="39A0D2"/>
-                  </a:solidFill>
-                </a:uFill>
-                <a:latin typeface="Century Gothic" panose="020B0502020202020204" pitchFamily="34" charset="0"/>
-                <a:cs typeface="Calibri"/>
-              </a:rPr>
-              <a:t>CEO, LUNO Group Chairperson, Eurasia Chapter,</a:t>
-            </a:r>
-          </a:p>
-          <a:p>
-            <a:pPr marL="12700" indent="349250" algn="just">
-              <a:spcBef>
-                <a:spcPts val="710"/>
-              </a:spcBef>
-            </a:pPr>
-            <a:r>
-              <a:rPr lang="en-US" sz="1200" b="1" spc="-10" noProof="0" dirty="0" err="1">
-                <a:solidFill>
-                  <a:srgbClr val="002060"/>
-                </a:solidFill>
-                <a:uFill>
-                  <a:solidFill>
-                    <a:srgbClr val="39A0D2"/>
-                  </a:solidFill>
-                </a:uFill>
-                <a:latin typeface="Century Gothic" panose="020B0502020202020204" pitchFamily="34" charset="0"/>
-                <a:cs typeface="Calibri"/>
-              </a:rPr>
-              <a:t>Bundesvereinigung</a:t>
-            </a:r>
-            <a:r>
-              <a:rPr lang="en-US" sz="1200" b="1" spc="-10" noProof="0" dirty="0">
-                <a:solidFill>
-                  <a:srgbClr val="002060"/>
-                </a:solidFill>
-                <a:uFill>
-                  <a:solidFill>
-                    <a:srgbClr val="39A0D2"/>
-                  </a:solidFill>
-                </a:uFill>
-                <a:latin typeface="Century Gothic" panose="020B0502020202020204" pitchFamily="34" charset="0"/>
-                <a:cs typeface="Calibri"/>
-              </a:rPr>
-              <a:t> </a:t>
-            </a:r>
-            <a:r>
-              <a:rPr lang="en-US" sz="1200" b="1" spc="-10" noProof="0" dirty="0" err="1">
-                <a:solidFill>
-                  <a:srgbClr val="002060"/>
-                </a:solidFill>
-                <a:uFill>
-                  <a:solidFill>
-                    <a:srgbClr val="39A0D2"/>
-                  </a:solidFill>
-                </a:uFill>
-                <a:latin typeface="Century Gothic" panose="020B0502020202020204" pitchFamily="34" charset="0"/>
-                <a:cs typeface="Calibri"/>
-              </a:rPr>
-              <a:t>Logistik</a:t>
-            </a:r>
-            <a:r>
-              <a:rPr lang="en-US" sz="1200" b="1" spc="-10" noProof="0" dirty="0">
-                <a:solidFill>
-                  <a:srgbClr val="002060"/>
-                </a:solidFill>
-                <a:uFill>
-                  <a:solidFill>
-                    <a:srgbClr val="39A0D2"/>
-                  </a:solidFill>
-                </a:uFill>
-                <a:latin typeface="Century Gothic" panose="020B0502020202020204" pitchFamily="34" charset="0"/>
-                <a:cs typeface="Calibri"/>
-              </a:rPr>
-              <a:t> (BVL), Germany</a:t>
-            </a:r>
-          </a:p>
-          <a:p>
-            <a:pPr marL="12700" indent="349250" algn="just">
-              <a:lnSpc>
-                <a:spcPct val="100000"/>
-              </a:lnSpc>
-              <a:spcBef>
-                <a:spcPts val="710"/>
-              </a:spcBef>
-            </a:pPr>
-            <a:endParaRPr lang="en-US" sz="1200" b="1" noProof="0" dirty="0">
-              <a:solidFill>
-                <a:srgbClr val="002060"/>
-              </a:solidFill>
-              <a:latin typeface="Century Gothic" panose="020B0502020202020204" pitchFamily="34" charset="0"/>
-              <a:cs typeface="Calibri"/>
-            </a:endParaRPr>
-          </a:p>
-          <a:p>
             <a:pPr marL="13970" marR="2704465" algn="just">
               <a:lnSpc>
                 <a:spcPts val="1100"/>
@@ -4380,6 +4537,36 @@
           </a:p>
         </p:txBody>
       </p:sp>
+      <p:pic>
+        <p:nvPicPr>
+          <p:cNvPr id="6" name="Grafik 5"/>
+          <p:cNvPicPr>
+            <a:picLocks noChangeAspect="1"/>
+          </p:cNvPicPr>
+          <p:nvPr/>
+        </p:nvPicPr>
+        <p:blipFill>
+          <a:blip r:embed="rId5" cstate="print">
+            <a:extLst>
+              <a:ext uri="{28A0092B-C50C-407E-A947-70E740481C1C}">
+                <a14:useLocalDpi xmlns:a14="http://schemas.microsoft.com/office/drawing/2010/main" val="0"/>
+              </a:ext>
+            </a:extLst>
+          </a:blip>
+          <a:stretch>
+            <a:fillRect/>
+          </a:stretch>
+        </p:blipFill>
+        <p:spPr>
+          <a:xfrm>
+            <a:off x="691830" y="381969"/>
+            <a:ext cx="982591" cy="462881"/>
+          </a:xfrm>
+          <a:prstGeom prst="rect">
+            <a:avLst/>
+          </a:prstGeom>
+        </p:spPr>
+      </p:pic>
     </p:spTree>
     <p:extLst>
       <p:ext uri="{BB962C8B-B14F-4D97-AF65-F5344CB8AC3E}">
@@ -4463,53 +4650,6 @@
           </a:extLst>
         </p:spPr>
       </p:pic>
-      <p:pic>
-        <p:nvPicPr>
-          <p:cNvPr id="4" name="Picture 6">
-            <a:extLst>
-              <a:ext uri="{FF2B5EF4-FFF2-40B4-BE49-F238E27FC236}">
-                <a16:creationId xmlns:a16="http://schemas.microsoft.com/office/drawing/2014/main" id="{FC236C3E-A948-ED90-6833-23B21CA3CA2D}"/>
-              </a:ext>
-            </a:extLst>
-          </p:cNvPr>
-          <p:cNvPicPr>
-            <a:picLocks noChangeAspect="1" noChangeArrowheads="1"/>
-          </p:cNvPicPr>
-          <p:nvPr/>
-        </p:nvPicPr>
-        <p:blipFill>
-          <a:blip r:embed="rId3" cstate="print">
-            <a:extLst>
-              <a:ext uri="{28A0092B-C50C-407E-A947-70E740481C1C}">
-                <a14:useLocalDpi xmlns:a14="http://schemas.microsoft.com/office/drawing/2010/main" val="0"/>
-              </a:ext>
-            </a:extLst>
-          </a:blip>
-          <a:srcRect/>
-          <a:stretch>
-            <a:fillRect/>
-          </a:stretch>
-        </p:blipFill>
-        <p:spPr bwMode="auto">
-          <a:xfrm>
-            <a:off x="595086" y="234566"/>
-            <a:ext cx="936162" cy="757687"/>
-          </a:xfrm>
-          <a:prstGeom prst="rect">
-            <a:avLst/>
-          </a:prstGeom>
-          <a:noFill/>
-          <a:extLst>
-            <a:ext uri="{909E8E84-426E-40DD-AFC4-6F175D3DCCD1}">
-              <a14:hiddenFill xmlns:a14="http://schemas.microsoft.com/office/drawing/2010/main">
-                <a:solidFill>
-                  <a:srgbClr val="FFFFFF"/>
-                </a:solidFill>
-              </a14:hiddenFill>
-            </a:ext>
-          </a:extLst>
-        </p:spPr>
-      </p:pic>
       <p:sp>
         <p:nvSpPr>
           <p:cNvPr id="2" name="object 2">
@@ -4525,7 +4665,7 @@
         <p:spPr>
           <a:xfrm>
             <a:off x="798286" y="1209764"/>
-            <a:ext cx="6379027" cy="9308959"/>
+            <a:ext cx="6379027" cy="9031960"/>
           </a:xfrm>
           <a:prstGeom prst="rect">
             <a:avLst/>
@@ -4546,7 +4686,7 @@
               </a:spcAft>
             </a:pPr>
             <a:r>
-              <a:rPr lang="en-US" sz="1100" spc="-10" noProof="0" dirty="0">
+              <a:rPr lang="en-US" sz="1100" u="sng" spc="-10" noProof="0" dirty="0">
                 <a:solidFill>
                   <a:srgbClr val="002060"/>
                 </a:solidFill>
@@ -4562,10 +4702,7 @@
             </a:r>
           </a:p>
           <a:p>
-            <a:pPr marL="12700" algn="just">
-              <a:lnSpc>
-                <a:spcPct val="100000"/>
-              </a:lnSpc>
+            <a:pPr marL="12700" algn="l">
               <a:spcAft>
                 <a:spcPts val="600"/>
               </a:spcAft>
@@ -4583,14 +4720,70 @@
                 <a:latin typeface="Century Gothic" panose="020B0502020202020204" pitchFamily="34" charset="0"/>
                 <a:cs typeface="Calibri"/>
               </a:rPr>
-              <a:t>Kazakhstan–German Transport and Logistics Forum “Digitalization, Human Capital, Transit Opportunities”</a:t>
+              <a:t>1</a:t>
+            </a:r>
+            <a:r>
+              <a:rPr lang="en-US" sz="1100" b="1" spc="-10" baseline="30000" noProof="0" dirty="0">
+                <a:solidFill>
+                  <a:srgbClr val="002060"/>
+                </a:solidFill>
+                <a:uFill>
+                  <a:solidFill>
+                    <a:srgbClr val="39A0D2"/>
+                  </a:solidFill>
+                </a:uFill>
+                <a:latin typeface="Century Gothic" panose="020B0502020202020204" pitchFamily="34" charset="0"/>
+                <a:cs typeface="Calibri"/>
+              </a:rPr>
+              <a:t>st</a:t>
+            </a:r>
+            <a:r>
+              <a:rPr lang="en-US" sz="1100" b="1" spc="-10" noProof="0" dirty="0">
+                <a:solidFill>
+                  <a:srgbClr val="002060"/>
+                </a:solidFill>
+                <a:uFill>
+                  <a:solidFill>
+                    <a:srgbClr val="39A0D2"/>
+                  </a:solidFill>
+                </a:uFill>
+                <a:latin typeface="Century Gothic" panose="020B0502020202020204" pitchFamily="34" charset="0"/>
+                <a:cs typeface="Calibri"/>
+              </a:rPr>
+              <a:t> Kazakhstan–German Transport and Logistics Forum</a:t>
+            </a:r>
+            <a:br>
+              <a:rPr lang="en-US" sz="1100" b="1" spc="-10" noProof="0" dirty="0">
+                <a:solidFill>
+                  <a:srgbClr val="002060"/>
+                </a:solidFill>
+                <a:uFill>
+                  <a:solidFill>
+                    <a:srgbClr val="39A0D2"/>
+                  </a:solidFill>
+                </a:uFill>
+                <a:latin typeface="Century Gothic" panose="020B0502020202020204" pitchFamily="34" charset="0"/>
+                <a:cs typeface="Calibri"/>
+              </a:rPr>
+            </a:br>
+            <a:r>
+              <a:rPr lang="en-US" sz="1100" b="1" spc="-10" noProof="0" dirty="0">
+                <a:solidFill>
+                  <a:srgbClr val="002060"/>
+                </a:solidFill>
+                <a:uFill>
+                  <a:solidFill>
+                    <a:srgbClr val="39A0D2"/>
+                  </a:solidFill>
+                </a:uFill>
+                <a:latin typeface="Century Gothic" panose="020B0502020202020204" pitchFamily="34" charset="0"/>
+                <a:cs typeface="Calibri"/>
+              </a:rPr>
+              <a:t>“Digitalization, Human Capital, Transit Opportunities”</a:t>
             </a:r>
           </a:p>
           <a:p>
             <a:pPr marL="12700" algn="just">
-              <a:lnSpc>
-                <a:spcPct val="100000"/>
-              </a:lnSpc>
               <a:spcAft>
                 <a:spcPts val="600"/>
               </a:spcAft>
@@ -4609,10 +4802,10 @@
             </a:endParaRPr>
           </a:p>
           <a:p>
-            <a:pPr marL="12700" algn="just">
-              <a:lnSpc>
-                <a:spcPct val="100000"/>
-              </a:lnSpc>
+            <a:pPr marL="12700" algn="l">
+              <a:spcAft>
+                <a:spcPts val="600"/>
+              </a:spcAft>
             </a:pPr>
             <a:r>
               <a:rPr lang="en-US" sz="1100" spc="-10" noProof="0" dirty="0">
@@ -4646,10 +4839,10 @@
             </a:r>
           </a:p>
           <a:p>
-            <a:pPr marL="12700" algn="just">
-              <a:lnSpc>
-                <a:spcPct val="100000"/>
-              </a:lnSpc>
+            <a:pPr marL="12700" algn="l">
+              <a:spcAft>
+                <a:spcPts val="600"/>
+              </a:spcAft>
             </a:pPr>
             <a:endParaRPr lang="en-US" sz="1100" spc="-10" noProof="0" dirty="0">
               <a:solidFill>
@@ -4665,10 +4858,7 @@
             </a:endParaRPr>
           </a:p>
           <a:p>
-            <a:pPr marL="12700" algn="just">
-              <a:lnSpc>
-                <a:spcPct val="100000"/>
-              </a:lnSpc>
+            <a:pPr marL="12700" algn="l">
               <a:spcAft>
                 <a:spcPts val="600"/>
               </a:spcAft>
@@ -4717,10 +4907,7 @@
             </a:endParaRPr>
           </a:p>
           <a:p>
-            <a:pPr marL="355600" algn="just">
-              <a:lnSpc>
-                <a:spcPct val="100000"/>
-              </a:lnSpc>
+            <a:pPr marL="355600" algn="l">
               <a:spcAft>
                 <a:spcPts val="600"/>
               </a:spcAft>
@@ -4742,10 +4929,7 @@
             </a:r>
           </a:p>
           <a:p>
-            <a:pPr marL="355600" algn="just">
-              <a:lnSpc>
-                <a:spcPct val="100000"/>
-              </a:lnSpc>
+            <a:pPr marL="355600" algn="l">
               <a:spcAft>
                 <a:spcPts val="600"/>
               </a:spcAft>
@@ -4767,12 +4951,251 @@
             </a:r>
           </a:p>
           <a:p>
-            <a:pPr marL="355600" algn="just">
+            <a:pPr marL="355600" algn="l">
+              <a:spcAft>
+                <a:spcPts val="1200"/>
+              </a:spcAft>
+            </a:pPr>
+            <a:r>
+              <a:rPr lang="en-US" sz="1100" b="1" spc="-10" noProof="0" dirty="0" err="1">
+                <a:solidFill>
+                  <a:srgbClr val="002060"/>
+                </a:solidFill>
+                <a:uFill>
+                  <a:solidFill>
+                    <a:srgbClr val="39A0D2"/>
+                  </a:solidFill>
+                </a:uFill>
+                <a:latin typeface="Century Gothic" panose="020B0502020202020204" pitchFamily="34" charset="0"/>
+                <a:cs typeface="Calibri"/>
+              </a:rPr>
+              <a:t>Mr</a:t>
+            </a:r>
+            <a:r>
+              <a:rPr lang="en-US" sz="1100" b="1" spc="-10" noProof="0" dirty="0">
+                <a:solidFill>
+                  <a:srgbClr val="002060"/>
+                </a:solidFill>
+                <a:uFill>
+                  <a:solidFill>
+                    <a:srgbClr val="39A0D2"/>
+                  </a:solidFill>
+                </a:uFill>
+                <a:latin typeface="Century Gothic" panose="020B0502020202020204" pitchFamily="34" charset="0"/>
+                <a:cs typeface="Calibri"/>
+              </a:rPr>
+              <a:t> </a:t>
+            </a:r>
+            <a:r>
+              <a:rPr lang="en-US" sz="1100" b="1" spc="-10" noProof="0" dirty="0" err="1">
+                <a:solidFill>
+                  <a:srgbClr val="002060"/>
+                </a:solidFill>
+                <a:uFill>
+                  <a:solidFill>
+                    <a:srgbClr val="39A0D2"/>
+                  </a:solidFill>
+                </a:uFill>
+                <a:latin typeface="Century Gothic" panose="020B0502020202020204" pitchFamily="34" charset="0"/>
+                <a:cs typeface="Calibri"/>
+              </a:rPr>
+              <a:t>Meyram</a:t>
+            </a:r>
+            <a:r>
+              <a:rPr lang="en-US" sz="1100" b="1" spc="-10" noProof="0" dirty="0">
+                <a:solidFill>
+                  <a:srgbClr val="002060"/>
+                </a:solidFill>
+                <a:uFill>
+                  <a:solidFill>
+                    <a:srgbClr val="39A0D2"/>
+                  </a:solidFill>
+                </a:uFill>
+                <a:latin typeface="Century Gothic" panose="020B0502020202020204" pitchFamily="34" charset="0"/>
+                <a:cs typeface="Calibri"/>
+              </a:rPr>
+              <a:t> M. </a:t>
+            </a:r>
+            <a:r>
+              <a:rPr lang="en-US" sz="1100" b="1" spc="-10" noProof="0" dirty="0" err="1">
+                <a:solidFill>
+                  <a:srgbClr val="002060"/>
+                </a:solidFill>
+                <a:uFill>
+                  <a:solidFill>
+                    <a:srgbClr val="39A0D2"/>
+                  </a:solidFill>
+                </a:uFill>
+                <a:latin typeface="Century Gothic" panose="020B0502020202020204" pitchFamily="34" charset="0"/>
+                <a:cs typeface="Calibri"/>
+              </a:rPr>
+              <a:t>Begentayev</a:t>
+            </a:r>
+            <a:r>
+              <a:rPr lang="en-US" sz="1100" b="1" spc="-10" noProof="0" dirty="0">
+                <a:solidFill>
+                  <a:srgbClr val="002060"/>
+                </a:solidFill>
+                <a:uFill>
+                  <a:solidFill>
+                    <a:srgbClr val="39A0D2"/>
+                  </a:solidFill>
+                </a:uFill>
+                <a:latin typeface="Century Gothic" panose="020B0502020202020204" pitchFamily="34" charset="0"/>
+                <a:cs typeface="Calibri"/>
+              </a:rPr>
+              <a:t>, </a:t>
+            </a:r>
+            <a:r>
+              <a:rPr lang="en-US" sz="1100" spc="-10" noProof="0" dirty="0">
+                <a:solidFill>
+                  <a:srgbClr val="002060"/>
+                </a:solidFill>
+                <a:uFill>
+                  <a:solidFill>
+                    <a:srgbClr val="39A0D2"/>
+                  </a:solidFill>
+                </a:uFill>
+                <a:latin typeface="Century Gothic" panose="020B0502020202020204" pitchFamily="34" charset="0"/>
+                <a:cs typeface="Calibri"/>
+              </a:rPr>
+              <a:t>Rector of </a:t>
+            </a:r>
+            <a:r>
+              <a:rPr lang="en-US" sz="1100" spc="-10" noProof="0" dirty="0" err="1">
+                <a:solidFill>
+                  <a:srgbClr val="002060"/>
+                </a:solidFill>
+                <a:uFill>
+                  <a:solidFill>
+                    <a:srgbClr val="39A0D2"/>
+                  </a:solidFill>
+                </a:uFill>
+                <a:latin typeface="Century Gothic" panose="020B0502020202020204" pitchFamily="34" charset="0"/>
+                <a:cs typeface="Calibri"/>
+              </a:rPr>
+              <a:t>Satbayev</a:t>
+            </a:r>
+            <a:r>
+              <a:rPr lang="en-US" sz="1100" spc="-10" noProof="0" dirty="0">
+                <a:solidFill>
+                  <a:srgbClr val="002060"/>
+                </a:solidFill>
+                <a:uFill>
+                  <a:solidFill>
+                    <a:srgbClr val="39A0D2"/>
+                  </a:solidFill>
+                </a:uFill>
+                <a:latin typeface="Century Gothic" panose="020B0502020202020204" pitchFamily="34" charset="0"/>
+                <a:cs typeface="Calibri"/>
+              </a:rPr>
+              <a:t> University</a:t>
+            </a:r>
+          </a:p>
+          <a:p>
+            <a:pPr marL="355600" algn="l">
+              <a:spcAft>
+                <a:spcPts val="1200"/>
+              </a:spcAft>
+            </a:pPr>
+            <a:r>
+              <a:rPr lang="en-US" sz="1100" b="1" spc="-10" dirty="0" err="1">
+                <a:solidFill>
+                  <a:srgbClr val="002060"/>
+                </a:solidFill>
+                <a:uFill>
+                  <a:solidFill>
+                    <a:srgbClr val="39A0D2"/>
+                  </a:solidFill>
+                </a:uFill>
+                <a:latin typeface="Century Gothic" panose="020B0502020202020204" pitchFamily="34" charset="0"/>
+                <a:cs typeface="Calibri"/>
+              </a:rPr>
+              <a:t>Mr</a:t>
+            </a:r>
+            <a:r>
+              <a:rPr lang="en-US" sz="1100" b="1" spc="-10" dirty="0">
+                <a:solidFill>
+                  <a:srgbClr val="002060"/>
+                </a:solidFill>
+                <a:uFill>
+                  <a:solidFill>
+                    <a:srgbClr val="39A0D2"/>
+                  </a:solidFill>
+                </a:uFill>
+                <a:latin typeface="Century Gothic" panose="020B0502020202020204" pitchFamily="34" charset="0"/>
+                <a:cs typeface="Calibri"/>
+              </a:rPr>
+              <a:t> Joachim Fritz</a:t>
+            </a:r>
+            <a:r>
+              <a:rPr lang="en-US" sz="1100" spc="-10" dirty="0">
+                <a:solidFill>
+                  <a:srgbClr val="002060"/>
+                </a:solidFill>
+                <a:uFill>
+                  <a:solidFill>
+                    <a:srgbClr val="39A0D2"/>
+                  </a:solidFill>
+                </a:uFill>
+                <a:latin typeface="Century Gothic" panose="020B0502020202020204" pitchFamily="34" charset="0"/>
+                <a:cs typeface="Calibri"/>
+              </a:rPr>
+              <a:t>, Regional Director Central Asia, GIZ</a:t>
+            </a:r>
+            <a:r>
+              <a:rPr lang="en-US" sz="1100" spc="-10" noProof="0" dirty="0">
+                <a:solidFill>
+                  <a:srgbClr val="002060"/>
+                </a:solidFill>
+                <a:uFill>
+                  <a:solidFill>
+                    <a:srgbClr val="39A0D2"/>
+                  </a:solidFill>
+                </a:uFill>
+                <a:latin typeface="Century Gothic" panose="020B0502020202020204" pitchFamily="34" charset="0"/>
+                <a:cs typeface="Calibri"/>
+              </a:rPr>
+              <a:t> </a:t>
+            </a:r>
+          </a:p>
+          <a:p>
+            <a:pPr marL="12700" algn="l">
               <a:spcAft>
                 <a:spcPts val="600"/>
               </a:spcAft>
             </a:pPr>
             <a:r>
+              <a:rPr lang="en-US" sz="1100" spc="-10" noProof="0" dirty="0">
+                <a:solidFill>
+                  <a:srgbClr val="002060"/>
+                </a:solidFill>
+                <a:uFill>
+                  <a:solidFill>
+                    <a:srgbClr val="39A0D2"/>
+                  </a:solidFill>
+                </a:uFill>
+                <a:latin typeface="Century Gothic" panose="020B0502020202020204" pitchFamily="34" charset="0"/>
+                <a:cs typeface="Calibri"/>
+              </a:rPr>
+              <a:t>11:20 – 11:50 </a:t>
+            </a:r>
+            <a:r>
+              <a:rPr lang="en-US" sz="1100" b="1" spc="-10" dirty="0">
+                <a:solidFill>
+                  <a:srgbClr val="002060"/>
+                </a:solidFill>
+                <a:uFill>
+                  <a:solidFill>
+                    <a:srgbClr val="39A0D2"/>
+                  </a:solidFill>
+                </a:uFill>
+                <a:latin typeface="Century Gothic" panose="020B0502020202020204" pitchFamily="34" charset="0"/>
+                <a:cs typeface="Calibri"/>
+              </a:rPr>
+              <a:t>Impulses</a:t>
+            </a:r>
+            <a:br>
               <a:rPr lang="en-US" sz="1100" b="1" spc="-10" noProof="0" dirty="0">
                 <a:solidFill>
                   <a:srgbClr val="002060"/>
@@ -4785,7 +5208,21 @@
                 <a:latin typeface="Century Gothic" panose="020B0502020202020204" pitchFamily="34" charset="0"/>
                 <a:cs typeface="Calibri"/>
               </a:rPr>
-              <a:t>Mr. </a:t>
+            </a:br>
+            <a:r>
+              <a:rPr lang="en-US" sz="1100" b="1" spc="-10" noProof="0" dirty="0">
+                <a:solidFill>
+                  <a:srgbClr val="002060"/>
+                </a:solidFill>
+                <a:uFill>
+                  <a:solidFill>
+                    <a:srgbClr val="39A0D2"/>
+                  </a:solidFill>
+                </a:uFill>
+                <a:latin typeface="Century Gothic" panose="020B0502020202020204" pitchFamily="34" charset="0"/>
+                <a:cs typeface="Calibri"/>
+              </a:rPr>
+              <a:t>Moderator: Mr. Marat M. </a:t>
             </a:r>
             <a:r>
               <a:rPr lang="en-US" sz="1100" b="1" spc="-10" noProof="0" dirty="0" err="1">
@@ -4800,52 +5237,7 @@
                 <a:latin typeface="Century Gothic" panose="020B0502020202020204" pitchFamily="34" charset="0"/>
                 <a:cs typeface="Calibri"/>
               </a:rPr>
-              <a:t>Meyram</a:t>
-            </a:r>
-            <a:r>
-              <a:rPr lang="en-US" sz="1100" b="1" spc="-10" noProof="0" dirty="0">
-                <a:solidFill>
-                  <a:srgbClr val="002060"/>
-                </a:solidFill>
-                <a:uFill>
-                  <a:solidFill>
-                    <a:srgbClr val="39A0D2"/>
-                  </a:solidFill>
-                </a:uFill>
-                <a:latin typeface="Century Gothic" panose="020B0502020202020204" pitchFamily="34" charset="0"/>
-                <a:cs typeface="Calibri"/>
-              </a:rPr>
-              <a:t> M. </a:t>
-            </a:r>
-            <a:r>
-              <a:rPr lang="en-US" sz="1100" b="1" spc="-10" noProof="0" dirty="0" err="1">
-                <a:solidFill>
-                  <a:srgbClr val="002060"/>
-                </a:solidFill>
-                <a:uFill>
-                  <a:solidFill>
-                    <a:srgbClr val="39A0D2"/>
-                  </a:solidFill>
-                </a:uFill>
-                <a:latin typeface="Century Gothic" panose="020B0502020202020204" pitchFamily="34" charset="0"/>
-                <a:cs typeface="Calibri"/>
-              </a:rPr>
-              <a:t>Begentayev</a:t>
-            </a:r>
-            <a:r>
-              <a:rPr lang="en-US" sz="1100" b="1" spc="-10" noProof="0" dirty="0">
-                <a:solidFill>
-                  <a:srgbClr val="002060"/>
-                </a:solidFill>
-                <a:uFill>
-                  <a:solidFill>
-                    <a:srgbClr val="39A0D2"/>
-                  </a:solidFill>
-                </a:uFill>
-                <a:latin typeface="Century Gothic" panose="020B0502020202020204" pitchFamily="34" charset="0"/>
-                <a:cs typeface="Calibri"/>
-              </a:rPr>
-              <a:t>, </a:t>
+              <a:t>Idrissov</a:t>
             </a:r>
             <a:r>
               <a:rPr lang="en-US" sz="1100" spc="-10" noProof="0" dirty="0">
@@ -4860,88 +5252,674 @@
                 <a:latin typeface="Century Gothic" panose="020B0502020202020204" pitchFamily="34" charset="0"/>
                 <a:cs typeface="Calibri"/>
               </a:rPr>
-              <a:t>Rector of </a:t>
-            </a:r>
-            <a:r>
-              <a:rPr lang="en-US" sz="1100" spc="-10" noProof="0" dirty="0" err="1">
-                <a:solidFill>
-                  <a:srgbClr val="002060"/>
-                </a:solidFill>
-                <a:uFill>
-                  <a:solidFill>
-                    <a:srgbClr val="39A0D2"/>
-                  </a:solidFill>
-                </a:uFill>
-                <a:latin typeface="Century Gothic" panose="020B0502020202020204" pitchFamily="34" charset="0"/>
-                <a:cs typeface="Calibri"/>
-              </a:rPr>
-              <a:t>Satbayev</a:t>
-            </a:r>
-            <a:r>
-              <a:rPr lang="en-US" sz="1100" spc="-10" noProof="0" dirty="0">
-                <a:solidFill>
-                  <a:srgbClr val="002060"/>
-                </a:solidFill>
-                <a:uFill>
-                  <a:solidFill>
-                    <a:srgbClr val="39A0D2"/>
-                  </a:solidFill>
-                </a:uFill>
-                <a:latin typeface="Century Gothic" panose="020B0502020202020204" pitchFamily="34" charset="0"/>
-                <a:cs typeface="Calibri"/>
-              </a:rPr>
-              <a:t> University </a:t>
-            </a:r>
-          </a:p>
-          <a:p>
-            <a:pPr marL="355600" algn="just">
-              <a:lnSpc>
-                <a:spcPct val="100000"/>
-              </a:lnSpc>
+              <a:t>, Kazakhstan Industry Development Institute</a:t>
+            </a:r>
+            <a:endParaRPr lang="en-US" sz="1100" b="1" i="1" spc="-10" dirty="0">
+              <a:solidFill>
+                <a:srgbClr val="002060"/>
+              </a:solidFill>
+              <a:uFill>
+                <a:solidFill>
+                  <a:srgbClr val="39A0D2"/>
+                </a:solidFill>
+              </a:uFill>
+              <a:latin typeface="Century Gothic" panose="020B0502020202020204" pitchFamily="34" charset="0"/>
+              <a:cs typeface="Calibri"/>
+            </a:endParaRPr>
+          </a:p>
+          <a:p>
+            <a:pPr marL="12700" algn="l">
               <a:spcAft>
                 <a:spcPts val="600"/>
               </a:spcAft>
             </a:pPr>
             <a:r>
-              <a:rPr lang="en-US" sz="1100" b="1" spc="-10" noProof="0" dirty="0">
-                <a:solidFill>
-                  <a:srgbClr val="002060"/>
-                </a:solidFill>
-                <a:uFill>
-                  <a:solidFill>
-                    <a:srgbClr val="39A0D2"/>
-                  </a:solidFill>
-                </a:uFill>
-                <a:latin typeface="Century Gothic" panose="020B0502020202020204" pitchFamily="34" charset="0"/>
-                <a:cs typeface="Calibri"/>
-              </a:rPr>
-              <a:t>Ms. Judith Blank, </a:t>
-            </a:r>
-            <a:r>
-              <a:rPr lang="en-US" sz="1100" spc="-10" noProof="0" dirty="0">
-                <a:solidFill>
-                  <a:srgbClr val="002060"/>
-                </a:solidFill>
-                <a:uFill>
-                  <a:solidFill>
-                    <a:srgbClr val="39A0D2"/>
-                  </a:solidFill>
-                </a:uFill>
-                <a:latin typeface="Century Gothic" panose="020B0502020202020204" pitchFamily="34" charset="0"/>
-                <a:cs typeface="Calibri"/>
-              </a:rPr>
-              <a:t>Project Director, Regional Programme Trade Facilitation in Central Asia/TCTC Capacity Development Programme, GIZ Central Asia”</a:t>
-            </a:r>
-          </a:p>
-          <a:p>
-            <a:pPr marL="12700" algn="just">
-              <a:lnSpc>
-                <a:spcPct val="100000"/>
-              </a:lnSpc>
+              <a:rPr lang="en-US" sz="1100" b="1" i="1" spc="-10" dirty="0">
+                <a:solidFill>
+                  <a:srgbClr val="002060"/>
+                </a:solidFill>
+                <a:uFill>
+                  <a:solidFill>
+                    <a:srgbClr val="39A0D2"/>
+                  </a:solidFill>
+                </a:uFill>
+                <a:latin typeface="Century Gothic" panose="020B0502020202020204" pitchFamily="34" charset="0"/>
+                <a:cs typeface="Calibri"/>
+              </a:rPr>
+              <a:t>S</a:t>
+            </a:r>
+            <a:r>
+              <a:rPr lang="en-US" sz="1100" b="1" i="1" spc="-10" noProof="0" dirty="0" err="1">
+                <a:solidFill>
+                  <a:srgbClr val="002060"/>
+                </a:solidFill>
+                <a:uFill>
+                  <a:solidFill>
+                    <a:srgbClr val="39A0D2"/>
+                  </a:solidFill>
+                </a:uFill>
+                <a:latin typeface="Century Gothic" panose="020B0502020202020204" pitchFamily="34" charset="0"/>
+                <a:cs typeface="Calibri"/>
+              </a:rPr>
+              <a:t>peakers</a:t>
+            </a:r>
+            <a:r>
+              <a:rPr lang="en-US" sz="1100" b="1" i="1" spc="-10" noProof="0" dirty="0">
+                <a:solidFill>
+                  <a:srgbClr val="002060"/>
+                </a:solidFill>
+                <a:uFill>
+                  <a:solidFill>
+                    <a:srgbClr val="39A0D2"/>
+                  </a:solidFill>
+                </a:uFill>
+                <a:latin typeface="Century Gothic" panose="020B0502020202020204" pitchFamily="34" charset="0"/>
+                <a:cs typeface="Calibri"/>
+              </a:rPr>
+              <a:t>:</a:t>
+            </a:r>
+          </a:p>
+          <a:p>
+            <a:pPr marL="355600" algn="l">
               <a:spcAft>
                 <a:spcPts val="600"/>
               </a:spcAft>
             </a:pPr>
+            <a:r>
+              <a:rPr lang="en-US" sz="1100" b="1" spc="-10" noProof="0" dirty="0">
+                <a:solidFill>
+                  <a:srgbClr val="002060"/>
+                </a:solidFill>
+                <a:uFill>
+                  <a:solidFill>
+                    <a:srgbClr val="39A0D2"/>
+                  </a:solidFill>
+                </a:uFill>
+                <a:latin typeface="Century Gothic" panose="020B0502020202020204" pitchFamily="34" charset="0"/>
+                <a:cs typeface="Calibri"/>
+              </a:rPr>
+              <a:t>Ms. </a:t>
+            </a:r>
+            <a:r>
+              <a:rPr lang="en-US" sz="1100" b="1" spc="-10" noProof="0" dirty="0" err="1">
+                <a:solidFill>
+                  <a:srgbClr val="002060"/>
+                </a:solidFill>
+                <a:uFill>
+                  <a:solidFill>
+                    <a:srgbClr val="39A0D2"/>
+                  </a:solidFill>
+                </a:uFill>
+                <a:latin typeface="Century Gothic" panose="020B0502020202020204" pitchFamily="34" charset="0"/>
+                <a:cs typeface="Calibri"/>
+              </a:rPr>
+              <a:t>Gulmira</a:t>
+            </a:r>
+            <a:r>
+              <a:rPr lang="en-US" sz="1100" b="1" spc="-10" noProof="0" dirty="0">
+                <a:solidFill>
+                  <a:srgbClr val="002060"/>
+                </a:solidFill>
+                <a:uFill>
+                  <a:solidFill>
+                    <a:srgbClr val="39A0D2"/>
+                  </a:solidFill>
+                </a:uFill>
+                <a:latin typeface="Century Gothic" panose="020B0502020202020204" pitchFamily="34" charset="0"/>
+                <a:cs typeface="Calibri"/>
+              </a:rPr>
+              <a:t> S. </a:t>
+            </a:r>
+            <a:r>
+              <a:rPr lang="en-US" sz="1100" b="1" spc="-10" noProof="0" dirty="0" err="1">
+                <a:solidFill>
+                  <a:srgbClr val="002060"/>
+                </a:solidFill>
+                <a:uFill>
+                  <a:solidFill>
+                    <a:srgbClr val="39A0D2"/>
+                  </a:solidFill>
+                </a:uFill>
+                <a:latin typeface="Century Gothic" panose="020B0502020202020204" pitchFamily="34" charset="0"/>
+                <a:cs typeface="Calibri"/>
+              </a:rPr>
+              <a:t>Mukhanova</a:t>
+            </a:r>
+            <a:r>
+              <a:rPr lang="en-US" sz="1100" spc="-10" noProof="0" dirty="0">
+                <a:solidFill>
+                  <a:srgbClr val="002060"/>
+                </a:solidFill>
+                <a:uFill>
+                  <a:solidFill>
+                    <a:srgbClr val="39A0D2"/>
+                  </a:solidFill>
+                </a:uFill>
+                <a:latin typeface="Century Gothic" panose="020B0502020202020204" pitchFamily="34" charset="0"/>
+                <a:cs typeface="Calibri"/>
+              </a:rPr>
+              <a:t>, Candidate of Technical Sciences, Associate Professor, Professor at the M. </a:t>
+            </a:r>
+            <a:r>
+              <a:rPr lang="en-US" sz="1100" spc="-10" noProof="0" dirty="0" err="1">
+                <a:solidFill>
+                  <a:srgbClr val="002060"/>
+                </a:solidFill>
+                <a:uFill>
+                  <a:solidFill>
+                    <a:srgbClr val="39A0D2"/>
+                  </a:solidFill>
+                </a:uFill>
+                <a:latin typeface="Century Gothic" panose="020B0502020202020204" pitchFamily="34" charset="0"/>
+                <a:cs typeface="Calibri"/>
+              </a:rPr>
+              <a:t>Tynyshpaev</a:t>
+            </a:r>
+            <a:r>
+              <a:rPr lang="en-US" sz="1100" spc="-10" noProof="0" dirty="0">
+                <a:solidFill>
+                  <a:srgbClr val="002060"/>
+                </a:solidFill>
+                <a:uFill>
+                  <a:solidFill>
+                    <a:srgbClr val="39A0D2"/>
+                  </a:solidFill>
+                </a:uFill>
+                <a:latin typeface="Century Gothic" panose="020B0502020202020204" pitchFamily="34" charset="0"/>
+                <a:cs typeface="Calibri"/>
+              </a:rPr>
+              <a:t> School of Transport Engineering and Logistics</a:t>
+            </a:r>
+          </a:p>
+          <a:p>
+            <a:pPr marL="355600" algn="l">
+              <a:spcAft>
+                <a:spcPts val="1200"/>
+              </a:spcAft>
+            </a:pPr>
+            <a:r>
+              <a:rPr lang="ru-RU" sz="1100" b="1" spc="-10" dirty="0">
+                <a:solidFill>
+                  <a:srgbClr val="002060"/>
+                </a:solidFill>
+                <a:uFill>
+                  <a:solidFill>
+                    <a:srgbClr val="39A0D2"/>
+                  </a:solidFill>
+                </a:uFill>
+                <a:latin typeface="Century Gothic" panose="020B0502020202020204" pitchFamily="34" charset="0"/>
+                <a:cs typeface="Calibri"/>
+              </a:rPr>
+              <a:t>М</a:t>
+            </a:r>
+            <a:r>
+              <a:rPr lang="en-US" sz="1100" b="1" spc="-10" dirty="0">
+                <a:solidFill>
+                  <a:srgbClr val="002060"/>
+                </a:solidFill>
+                <a:uFill>
+                  <a:solidFill>
+                    <a:srgbClr val="39A0D2"/>
+                  </a:solidFill>
+                </a:uFill>
+                <a:latin typeface="Century Gothic" panose="020B0502020202020204" pitchFamily="34" charset="0"/>
+                <a:cs typeface="Calibri"/>
+              </a:rPr>
+              <a:t>s. Judith Blank, </a:t>
+            </a:r>
+            <a:r>
+              <a:rPr lang="en-US" sz="1100" spc="-10" dirty="0">
+                <a:solidFill>
+                  <a:srgbClr val="002060"/>
+                </a:solidFill>
+                <a:uFill>
+                  <a:solidFill>
+                    <a:srgbClr val="39A0D2"/>
+                  </a:solidFill>
+                </a:uFill>
+                <a:latin typeface="Century Gothic" panose="020B0502020202020204" pitchFamily="34" charset="0"/>
+                <a:cs typeface="Calibri"/>
+              </a:rPr>
+              <a:t>Project Director, Regional </a:t>
+            </a:r>
+            <a:r>
+              <a:rPr lang="en-US" sz="1100" spc="-10" dirty="0" err="1">
+                <a:solidFill>
+                  <a:srgbClr val="002060"/>
+                </a:solidFill>
+                <a:uFill>
+                  <a:solidFill>
+                    <a:srgbClr val="39A0D2"/>
+                  </a:solidFill>
+                </a:uFill>
+                <a:latin typeface="Century Gothic" panose="020B0502020202020204" pitchFamily="34" charset="0"/>
+                <a:cs typeface="Calibri"/>
+              </a:rPr>
+              <a:t>Programme</a:t>
+            </a:r>
+            <a:r>
+              <a:rPr lang="en-US" sz="1100" spc="-10" dirty="0">
+                <a:solidFill>
+                  <a:srgbClr val="002060"/>
+                </a:solidFill>
+                <a:uFill>
+                  <a:solidFill>
+                    <a:srgbClr val="39A0D2"/>
+                  </a:solidFill>
+                </a:uFill>
+                <a:latin typeface="Century Gothic" panose="020B0502020202020204" pitchFamily="34" charset="0"/>
+                <a:cs typeface="Calibri"/>
+              </a:rPr>
+              <a:t> Trade Facilitation in Central Asia/TCTC Capacity Development </a:t>
+            </a:r>
+            <a:r>
+              <a:rPr lang="en-US" sz="1100" spc="-10" dirty="0" err="1">
+                <a:solidFill>
+                  <a:srgbClr val="002060"/>
+                </a:solidFill>
+                <a:uFill>
+                  <a:solidFill>
+                    <a:srgbClr val="39A0D2"/>
+                  </a:solidFill>
+                </a:uFill>
+                <a:latin typeface="Century Gothic" panose="020B0502020202020204" pitchFamily="34" charset="0"/>
+                <a:cs typeface="Calibri"/>
+              </a:rPr>
+              <a:t>Programme</a:t>
+            </a:r>
+            <a:r>
+              <a:rPr lang="en-US" sz="1100" spc="-10" dirty="0">
+                <a:solidFill>
+                  <a:srgbClr val="002060"/>
+                </a:solidFill>
+                <a:uFill>
+                  <a:solidFill>
+                    <a:srgbClr val="39A0D2"/>
+                  </a:solidFill>
+                </a:uFill>
+                <a:latin typeface="Century Gothic" panose="020B0502020202020204" pitchFamily="34" charset="0"/>
+                <a:cs typeface="Calibri"/>
+              </a:rPr>
+              <a:t>, GIZ Central Asia</a:t>
+            </a:r>
+            <a:endParaRPr lang="ru-RU" sz="1100" spc="-10" dirty="0">
+              <a:solidFill>
+                <a:srgbClr val="002060"/>
+              </a:solidFill>
+              <a:uFill>
+                <a:solidFill>
+                  <a:srgbClr val="39A0D2"/>
+                </a:solidFill>
+              </a:uFill>
+              <a:latin typeface="Century Gothic" panose="020B0502020202020204" pitchFamily="34" charset="0"/>
+              <a:cs typeface="Calibri"/>
+            </a:endParaRPr>
+          </a:p>
+          <a:p>
+            <a:pPr marL="355600" algn="l">
+              <a:spcAft>
+                <a:spcPts val="1200"/>
+              </a:spcAft>
+            </a:pPr>
+            <a:r>
+              <a:rPr lang="en-US" sz="1100" b="1" spc="-10" dirty="0" err="1">
+                <a:solidFill>
+                  <a:srgbClr val="002060"/>
+                </a:solidFill>
+                <a:uFill>
+                  <a:solidFill>
+                    <a:srgbClr val="39A0D2"/>
+                  </a:solidFill>
+                </a:uFill>
+                <a:latin typeface="Century Gothic" panose="020B0502020202020204" pitchFamily="34" charset="0"/>
+                <a:cs typeface="Calibri"/>
+              </a:rPr>
+              <a:t>Mr</a:t>
+            </a:r>
+            <a:r>
+              <a:rPr lang="en-US" sz="1100" b="1" spc="-10" dirty="0">
+                <a:solidFill>
+                  <a:srgbClr val="002060"/>
+                </a:solidFill>
+                <a:uFill>
+                  <a:solidFill>
+                    <a:srgbClr val="39A0D2"/>
+                  </a:solidFill>
+                </a:uFill>
+                <a:latin typeface="Century Gothic" panose="020B0502020202020204" pitchFamily="34" charset="0"/>
+                <a:cs typeface="Calibri"/>
+              </a:rPr>
+              <a:t> Vladimir </a:t>
+            </a:r>
+            <a:r>
+              <a:rPr lang="en-US" sz="1100" b="1" spc="-10" dirty="0" err="1">
+                <a:solidFill>
+                  <a:srgbClr val="002060"/>
+                </a:solidFill>
+                <a:uFill>
+                  <a:solidFill>
+                    <a:srgbClr val="39A0D2"/>
+                  </a:solidFill>
+                </a:uFill>
+                <a:latin typeface="Century Gothic" panose="020B0502020202020204" pitchFamily="34" charset="0"/>
+                <a:cs typeface="Calibri"/>
+              </a:rPr>
+              <a:t>Turekhanov</a:t>
+            </a:r>
+            <a:r>
+              <a:rPr lang="en-US" sz="1100" b="1" spc="-10" dirty="0">
+                <a:solidFill>
+                  <a:srgbClr val="002060"/>
+                </a:solidFill>
+                <a:uFill>
+                  <a:solidFill>
+                    <a:srgbClr val="39A0D2"/>
+                  </a:solidFill>
+                </a:uFill>
+                <a:latin typeface="Century Gothic" panose="020B0502020202020204" pitchFamily="34" charset="0"/>
+                <a:cs typeface="Calibri"/>
+              </a:rPr>
+              <a:t>, </a:t>
+            </a:r>
+            <a:r>
+              <a:rPr lang="en-US" sz="1100" spc="-10" dirty="0">
+                <a:solidFill>
+                  <a:srgbClr val="002060"/>
+                </a:solidFill>
+                <a:uFill>
+                  <a:solidFill>
+                    <a:srgbClr val="39A0D2"/>
+                  </a:solidFill>
+                </a:uFill>
+                <a:latin typeface="Century Gothic" panose="020B0502020202020204" pitchFamily="34" charset="0"/>
+                <a:cs typeface="Calibri"/>
+              </a:rPr>
+              <a:t>Head of the Kazakhstan Association of Automation and Robotics (KAAR)</a:t>
+            </a:r>
+            <a:endParaRPr lang="ru-RU" sz="1100" spc="-10" dirty="0">
+              <a:solidFill>
+                <a:srgbClr val="002060"/>
+              </a:solidFill>
+              <a:uFill>
+                <a:solidFill>
+                  <a:srgbClr val="39A0D2"/>
+                </a:solidFill>
+              </a:uFill>
+              <a:latin typeface="Century Gothic" panose="020B0502020202020204" pitchFamily="34" charset="0"/>
+              <a:cs typeface="Calibri"/>
+            </a:endParaRPr>
+          </a:p>
+          <a:p>
+            <a:pPr marL="12700" algn="l">
+              <a:spcAft>
+                <a:spcPts val="600"/>
+              </a:spcAft>
+            </a:pPr>
+            <a:r>
+              <a:rPr lang="en-US" sz="1100" spc="-10" noProof="0" dirty="0">
+                <a:solidFill>
+                  <a:srgbClr val="002060"/>
+                </a:solidFill>
+                <a:uFill>
+                  <a:solidFill>
+                    <a:srgbClr val="39A0D2"/>
+                  </a:solidFill>
+                </a:uFill>
+                <a:latin typeface="Century Gothic" panose="020B0502020202020204" pitchFamily="34" charset="0"/>
+                <a:cs typeface="Calibri"/>
+              </a:rPr>
+              <a:t>11:50 – 13:00</a:t>
+            </a:r>
+            <a:r>
+              <a:rPr lang="en-US" sz="1100" b="1" spc="-10" noProof="0" dirty="0">
+                <a:solidFill>
+                  <a:srgbClr val="002060"/>
+                </a:solidFill>
+                <a:uFill>
+                  <a:solidFill>
+                    <a:srgbClr val="39A0D2"/>
+                  </a:solidFill>
+                </a:uFill>
+                <a:latin typeface="Century Gothic" panose="020B0502020202020204" pitchFamily="34" charset="0"/>
+                <a:cs typeface="Calibri"/>
+              </a:rPr>
+              <a:t> Panel Discussion Middle Corridor</a:t>
+            </a:r>
+            <a:br>
+              <a:rPr lang="en-US" sz="1100" b="1" spc="-10" noProof="0" dirty="0">
+                <a:solidFill>
+                  <a:srgbClr val="002060"/>
+                </a:solidFill>
+                <a:uFill>
+                  <a:solidFill>
+                    <a:srgbClr val="39A0D2"/>
+                  </a:solidFill>
+                </a:uFill>
+                <a:latin typeface="Century Gothic" panose="020B0502020202020204" pitchFamily="34" charset="0"/>
+                <a:cs typeface="Calibri"/>
+              </a:rPr>
+            </a:br>
+            <a:r>
+              <a:rPr lang="en-US" sz="1100" b="1" i="1" spc="-10" noProof="0" dirty="0">
+                <a:solidFill>
+                  <a:srgbClr val="002060"/>
+                </a:solidFill>
+                <a:uFill>
+                  <a:solidFill>
+                    <a:srgbClr val="39A0D2"/>
+                  </a:solidFill>
+                </a:uFill>
+                <a:latin typeface="Century Gothic" panose="020B0502020202020204" pitchFamily="34" charset="0"/>
+                <a:cs typeface="Calibri"/>
+              </a:rPr>
+              <a:t>Moderator:</a:t>
+            </a:r>
+            <a:r>
+              <a:rPr lang="en-US" sz="1100" i="1" spc="-10" noProof="0" dirty="0">
+                <a:solidFill>
+                  <a:srgbClr val="002060"/>
+                </a:solidFill>
+                <a:uFill>
+                  <a:solidFill>
+                    <a:srgbClr val="39A0D2"/>
+                  </a:solidFill>
+                </a:uFill>
+                <a:latin typeface="Century Gothic" panose="020B0502020202020204" pitchFamily="34" charset="0"/>
+                <a:cs typeface="Calibri"/>
+              </a:rPr>
+              <a:t> </a:t>
+            </a:r>
+            <a:r>
+              <a:rPr lang="en-US" sz="1100" b="1" spc="-10" noProof="0" dirty="0">
+                <a:solidFill>
+                  <a:srgbClr val="002060"/>
+                </a:solidFill>
+                <a:uFill>
+                  <a:solidFill>
+                    <a:srgbClr val="39A0D2"/>
+                  </a:solidFill>
+                </a:uFill>
+                <a:latin typeface="Century Gothic" panose="020B0502020202020204" pitchFamily="34" charset="0"/>
+                <a:cs typeface="Calibri"/>
+              </a:rPr>
+              <a:t>Mr. </a:t>
+            </a:r>
+            <a:r>
+              <a:rPr lang="en-US" sz="1100" b="1" spc="-10" noProof="0" dirty="0" err="1">
+                <a:solidFill>
+                  <a:srgbClr val="002060"/>
+                </a:solidFill>
+                <a:uFill>
+                  <a:solidFill>
+                    <a:srgbClr val="39A0D2"/>
+                  </a:solidFill>
+                </a:uFill>
+                <a:latin typeface="Century Gothic" panose="020B0502020202020204" pitchFamily="34" charset="0"/>
+                <a:cs typeface="Calibri"/>
+              </a:rPr>
+              <a:t>Mirco</a:t>
+            </a:r>
+            <a:r>
+              <a:rPr lang="en-US" sz="1100" b="1" spc="-10" noProof="0" dirty="0">
+                <a:solidFill>
+                  <a:srgbClr val="002060"/>
+                </a:solidFill>
+                <a:uFill>
+                  <a:solidFill>
+                    <a:srgbClr val="39A0D2"/>
+                  </a:solidFill>
+                </a:uFill>
+                <a:latin typeface="Century Gothic" panose="020B0502020202020204" pitchFamily="34" charset="0"/>
+                <a:cs typeface="Calibri"/>
+              </a:rPr>
+              <a:t> Nowak</a:t>
+            </a:r>
+            <a:r>
+              <a:rPr lang="en-US" sz="1100" spc="-10" noProof="0" dirty="0">
+                <a:solidFill>
+                  <a:srgbClr val="002060"/>
+                </a:solidFill>
+                <a:uFill>
+                  <a:solidFill>
+                    <a:srgbClr val="39A0D2"/>
+                  </a:solidFill>
+                </a:uFill>
+                <a:latin typeface="Century Gothic" panose="020B0502020202020204" pitchFamily="34" charset="0"/>
+                <a:cs typeface="Calibri"/>
+              </a:rPr>
+              <a:t>, CEO, LUNO Group; Chairperson, Chapter Eurasia, </a:t>
+            </a:r>
+            <a:r>
+              <a:rPr lang="en-US" sz="1100" spc="-10" noProof="0" dirty="0" err="1">
+                <a:solidFill>
+                  <a:srgbClr val="002060"/>
+                </a:solidFill>
+                <a:uFill>
+                  <a:solidFill>
+                    <a:srgbClr val="39A0D2"/>
+                  </a:solidFill>
+                </a:uFill>
+                <a:latin typeface="Century Gothic" panose="020B0502020202020204" pitchFamily="34" charset="0"/>
+                <a:cs typeface="Calibri"/>
+              </a:rPr>
+              <a:t>Bundesvereinigung</a:t>
+            </a:r>
+            <a:r>
+              <a:rPr lang="en-US" sz="1100" spc="-10" noProof="0" dirty="0">
+                <a:solidFill>
+                  <a:srgbClr val="002060"/>
+                </a:solidFill>
+                <a:uFill>
+                  <a:solidFill>
+                    <a:srgbClr val="39A0D2"/>
+                  </a:solidFill>
+                </a:uFill>
+                <a:latin typeface="Century Gothic" panose="020B0502020202020204" pitchFamily="34" charset="0"/>
+                <a:cs typeface="Calibri"/>
+              </a:rPr>
+              <a:t> </a:t>
+            </a:r>
+            <a:r>
+              <a:rPr lang="en-US" sz="1100" spc="-10" noProof="0" dirty="0" err="1">
+                <a:solidFill>
+                  <a:srgbClr val="002060"/>
+                </a:solidFill>
+                <a:uFill>
+                  <a:solidFill>
+                    <a:srgbClr val="39A0D2"/>
+                  </a:solidFill>
+                </a:uFill>
+                <a:latin typeface="Century Gothic" panose="020B0502020202020204" pitchFamily="34" charset="0"/>
+                <a:cs typeface="Calibri"/>
+              </a:rPr>
+              <a:t>Logistik</a:t>
+            </a:r>
+            <a:r>
+              <a:rPr lang="en-US" sz="1100" spc="-10" noProof="0" dirty="0">
+                <a:solidFill>
+                  <a:srgbClr val="002060"/>
+                </a:solidFill>
+                <a:uFill>
+                  <a:solidFill>
+                    <a:srgbClr val="39A0D2"/>
+                  </a:solidFill>
+                </a:uFill>
+                <a:latin typeface="Century Gothic" panose="020B0502020202020204" pitchFamily="34" charset="0"/>
+                <a:cs typeface="Calibri"/>
+              </a:rPr>
+              <a:t> (BVL), Germany</a:t>
+            </a:r>
+            <a:endParaRPr lang="en-US" sz="1100" b="1" i="1" spc="-10" dirty="0">
+              <a:solidFill>
+                <a:srgbClr val="002060"/>
+              </a:solidFill>
+              <a:uFill>
+                <a:solidFill>
+                  <a:srgbClr val="39A0D2"/>
+                </a:solidFill>
+              </a:uFill>
+              <a:latin typeface="Century Gothic" panose="020B0502020202020204" pitchFamily="34" charset="0"/>
+              <a:cs typeface="Calibri"/>
+            </a:endParaRPr>
+          </a:p>
+          <a:p>
+            <a:pPr marL="12700" algn="l">
+              <a:spcAft>
+                <a:spcPts val="600"/>
+              </a:spcAft>
+            </a:pPr>
+            <a:r>
+              <a:rPr lang="en-US" sz="1100" b="1" i="1" spc="-10" noProof="0" dirty="0">
+                <a:solidFill>
+                  <a:srgbClr val="002060"/>
+                </a:solidFill>
+                <a:uFill>
+                  <a:solidFill>
+                    <a:srgbClr val="39A0D2"/>
+                  </a:solidFill>
+                </a:uFill>
+                <a:latin typeface="Century Gothic" panose="020B0502020202020204" pitchFamily="34" charset="0"/>
+                <a:cs typeface="Calibri"/>
+              </a:rPr>
+              <a:t>Speakers:</a:t>
+            </a:r>
+          </a:p>
+          <a:p>
+            <a:pPr marL="355600" algn="l">
+              <a:spcAft>
+                <a:spcPts val="1200"/>
+              </a:spcAft>
+            </a:pPr>
+            <a:r>
+              <a:rPr lang="en-US" sz="1100" spc="-10" dirty="0" err="1">
+                <a:solidFill>
+                  <a:srgbClr val="002060"/>
+                </a:solidFill>
+                <a:uFill>
+                  <a:solidFill>
+                    <a:srgbClr val="39A0D2"/>
+                  </a:solidFill>
+                </a:uFill>
+                <a:latin typeface="Century Gothic" panose="020B0502020202020204" pitchFamily="34" charset="0"/>
+                <a:cs typeface="Calibri"/>
+              </a:rPr>
+              <a:t>KazLogistic</a:t>
+            </a:r>
+            <a:r>
+              <a:rPr lang="en-US" sz="1100" spc="-10" dirty="0">
+                <a:solidFill>
+                  <a:srgbClr val="002060"/>
+                </a:solidFill>
+                <a:uFill>
+                  <a:solidFill>
+                    <a:srgbClr val="39A0D2"/>
+                  </a:solidFill>
+                </a:uFill>
+                <a:latin typeface="Century Gothic" panose="020B0502020202020204" pitchFamily="34" charset="0"/>
+                <a:cs typeface="Calibri"/>
+              </a:rPr>
+              <a:t> Association Representative</a:t>
+            </a:r>
             <a:endParaRPr lang="en-US" sz="1100" spc="-10" noProof="0" dirty="0">
               <a:solidFill>
                 <a:srgbClr val="002060"/>
@@ -4956,10 +5934,10 @@
             </a:endParaRPr>
           </a:p>
           <a:p>
-            <a:pPr marL="12700" algn="just">
-              <a:lnSpc>
-                <a:spcPct val="100000"/>
-              </a:lnSpc>
+            <a:pPr marL="355600" algn="l">
+              <a:spcAft>
+                <a:spcPts val="1200"/>
+              </a:spcAft>
             </a:pPr>
             <a:r>
               <a:rPr lang="en-US" sz="1100" spc="-10" noProof="0" dirty="0">
@@ -4974,336 +5952,9 @@
                 <a:latin typeface="Century Gothic" panose="020B0502020202020204" pitchFamily="34" charset="0"/>
                 <a:cs typeface="Calibri"/>
               </a:rPr>
-              <a:t>11:20 – 12:20</a:t>
-            </a:r>
-            <a:r>
-              <a:rPr lang="en-US" sz="1100" b="1" spc="-10" noProof="0" dirty="0">
-                <a:solidFill>
-                  <a:srgbClr val="002060"/>
-                </a:solidFill>
-                <a:uFill>
-                  <a:solidFill>
-                    <a:srgbClr val="39A0D2"/>
-                  </a:solidFill>
-                </a:uFill>
-                <a:latin typeface="Century Gothic" panose="020B0502020202020204" pitchFamily="34" charset="0"/>
-                <a:cs typeface="Calibri"/>
-              </a:rPr>
-              <a:t> Plenary Session</a:t>
-            </a:r>
-          </a:p>
-          <a:p>
-            <a:pPr marL="12700" algn="just">
-              <a:lnSpc>
-                <a:spcPct val="100000"/>
-              </a:lnSpc>
-            </a:pPr>
-            <a:r>
-              <a:rPr lang="en-US" sz="1100" b="1" i="1" spc="-10" noProof="0" dirty="0">
-                <a:solidFill>
-                  <a:srgbClr val="002060"/>
-                </a:solidFill>
-                <a:uFill>
-                  <a:solidFill>
-                    <a:srgbClr val="39A0D2"/>
-                  </a:solidFill>
-                </a:uFill>
-                <a:latin typeface="Century Gothic" panose="020B0502020202020204" pitchFamily="34" charset="0"/>
-                <a:cs typeface="Calibri"/>
-              </a:rPr>
-              <a:t>Moderator:</a:t>
-            </a:r>
-            <a:r>
-              <a:rPr lang="en-US" sz="1100" i="1" spc="-10" noProof="0" dirty="0">
-                <a:solidFill>
-                  <a:srgbClr val="002060"/>
-                </a:solidFill>
-                <a:uFill>
-                  <a:solidFill>
-                    <a:srgbClr val="39A0D2"/>
-                  </a:solidFill>
-                </a:uFill>
-                <a:latin typeface="Century Gothic" panose="020B0502020202020204" pitchFamily="34" charset="0"/>
-                <a:cs typeface="Calibri"/>
-              </a:rPr>
-              <a:t> </a:t>
-            </a:r>
-            <a:r>
-              <a:rPr lang="en-US" sz="1100" b="1" spc="-10" noProof="0" dirty="0">
-                <a:solidFill>
-                  <a:srgbClr val="002060"/>
-                </a:solidFill>
-                <a:uFill>
-                  <a:solidFill>
-                    <a:srgbClr val="39A0D2"/>
-                  </a:solidFill>
-                </a:uFill>
-                <a:latin typeface="Century Gothic" panose="020B0502020202020204" pitchFamily="34" charset="0"/>
-                <a:cs typeface="Calibri"/>
-              </a:rPr>
-              <a:t>Mr. Marat M. Idrissov</a:t>
-            </a:r>
-            <a:r>
-              <a:rPr lang="en-US" sz="1100" spc="-10" noProof="0" dirty="0">
-                <a:solidFill>
-                  <a:srgbClr val="002060"/>
-                </a:solidFill>
-                <a:uFill>
-                  <a:solidFill>
-                    <a:srgbClr val="39A0D2"/>
-                  </a:solidFill>
-                </a:uFill>
-                <a:latin typeface="Century Gothic" panose="020B0502020202020204" pitchFamily="34" charset="0"/>
-                <a:cs typeface="Calibri"/>
-              </a:rPr>
-              <a:t>, Kazakhstan Industry Development Institute</a:t>
-            </a:r>
-          </a:p>
-          <a:p>
-            <a:pPr marL="12700" algn="just">
-              <a:lnSpc>
-                <a:spcPct val="100000"/>
-              </a:lnSpc>
-              <a:spcAft>
-                <a:spcPts val="600"/>
-              </a:spcAft>
-            </a:pPr>
-            <a:r>
-              <a:rPr lang="en-US" sz="1100" b="1" i="1" spc="-10" noProof="0" dirty="0">
-                <a:solidFill>
-                  <a:srgbClr val="002060"/>
-                </a:solidFill>
-                <a:uFill>
-                  <a:solidFill>
-                    <a:srgbClr val="39A0D2"/>
-                  </a:solidFill>
-                </a:uFill>
-                <a:latin typeface="Century Gothic" panose="020B0502020202020204" pitchFamily="34" charset="0"/>
-                <a:cs typeface="Calibri"/>
-              </a:rPr>
-              <a:t>Speakers:</a:t>
-            </a:r>
-          </a:p>
-          <a:p>
-            <a:pPr marL="355600" algn="just">
-              <a:lnSpc>
-                <a:spcPct val="100000"/>
-              </a:lnSpc>
-              <a:spcAft>
-                <a:spcPts val="600"/>
-              </a:spcAft>
-            </a:pPr>
-            <a:r>
-              <a:rPr lang="en-US" sz="1100" b="1" spc="-10" noProof="0" dirty="0">
-                <a:solidFill>
-                  <a:srgbClr val="002060"/>
-                </a:solidFill>
-                <a:uFill>
-                  <a:solidFill>
-                    <a:srgbClr val="39A0D2"/>
-                  </a:solidFill>
-                </a:uFill>
-                <a:latin typeface="Century Gothic" panose="020B0502020202020204" pitchFamily="34" charset="0"/>
-                <a:cs typeface="Calibri"/>
-              </a:rPr>
-              <a:t>Ms. Gulmira S. Mukhanova</a:t>
-            </a:r>
-            <a:r>
-              <a:rPr lang="en-US" sz="1100" spc="-10" noProof="0" dirty="0">
-                <a:solidFill>
-                  <a:srgbClr val="002060"/>
-                </a:solidFill>
-                <a:uFill>
-                  <a:solidFill>
-                    <a:srgbClr val="39A0D2"/>
-                  </a:solidFill>
-                </a:uFill>
-                <a:latin typeface="Century Gothic" panose="020B0502020202020204" pitchFamily="34" charset="0"/>
-                <a:cs typeface="Calibri"/>
-              </a:rPr>
-              <a:t>, Candidate of Technical Sciences, Associate Professor, Professor at the M. </a:t>
-            </a:r>
-            <a:r>
-              <a:rPr lang="en-US" sz="1100" spc="-10" noProof="0" dirty="0" err="1">
-                <a:solidFill>
-                  <a:srgbClr val="002060"/>
-                </a:solidFill>
-                <a:uFill>
-                  <a:solidFill>
-                    <a:srgbClr val="39A0D2"/>
-                  </a:solidFill>
-                </a:uFill>
-                <a:latin typeface="Century Gothic" panose="020B0502020202020204" pitchFamily="34" charset="0"/>
-                <a:cs typeface="Calibri"/>
-              </a:rPr>
-              <a:t>Tynyshpaev</a:t>
-            </a:r>
-            <a:r>
-              <a:rPr lang="en-US" sz="1100" spc="-10" noProof="0" dirty="0">
-                <a:solidFill>
-                  <a:srgbClr val="002060"/>
-                </a:solidFill>
-                <a:uFill>
-                  <a:solidFill>
-                    <a:srgbClr val="39A0D2"/>
-                  </a:solidFill>
-                </a:uFill>
-                <a:latin typeface="Century Gothic" panose="020B0502020202020204" pitchFamily="34" charset="0"/>
-                <a:cs typeface="Calibri"/>
-              </a:rPr>
-              <a:t> School of Transport Engineering and Logistics</a:t>
-            </a:r>
-          </a:p>
-          <a:p>
-            <a:pPr marL="355600" algn="just">
-              <a:lnSpc>
-                <a:spcPct val="100000"/>
-              </a:lnSpc>
-              <a:spcAft>
-                <a:spcPts val="600"/>
-              </a:spcAft>
-            </a:pPr>
-            <a:r>
-              <a:rPr lang="en-US" sz="1100" b="1" spc="-10" noProof="0" dirty="0">
-                <a:solidFill>
-                  <a:srgbClr val="002060"/>
-                </a:solidFill>
-                <a:uFill>
-                  <a:solidFill>
-                    <a:srgbClr val="39A0D2"/>
-                  </a:solidFill>
-                </a:uFill>
-                <a:latin typeface="Century Gothic" panose="020B0502020202020204" pitchFamily="34" charset="0"/>
-                <a:cs typeface="Calibri"/>
-              </a:rPr>
-              <a:t>Mr. Mirco Nowak</a:t>
-            </a:r>
-            <a:r>
-              <a:rPr lang="en-US" sz="1100" spc="-10" noProof="0" dirty="0">
-                <a:solidFill>
-                  <a:srgbClr val="002060"/>
-                </a:solidFill>
-                <a:uFill>
-                  <a:solidFill>
-                    <a:srgbClr val="39A0D2"/>
-                  </a:solidFill>
-                </a:uFill>
-                <a:latin typeface="Century Gothic" panose="020B0502020202020204" pitchFamily="34" charset="0"/>
-                <a:cs typeface="Calibri"/>
-              </a:rPr>
-              <a:t>, CEO, LUNO Group; Chairperson, Eurasia Chapter, </a:t>
-            </a:r>
-            <a:r>
-              <a:rPr lang="en-US" sz="1100" spc="-10" noProof="0" dirty="0" err="1">
-                <a:solidFill>
-                  <a:srgbClr val="002060"/>
-                </a:solidFill>
-                <a:uFill>
-                  <a:solidFill>
-                    <a:srgbClr val="39A0D2"/>
-                  </a:solidFill>
-                </a:uFill>
-                <a:latin typeface="Century Gothic" panose="020B0502020202020204" pitchFamily="34" charset="0"/>
-                <a:cs typeface="Calibri"/>
-              </a:rPr>
-              <a:t>Bundesvereinigung</a:t>
-            </a:r>
-            <a:r>
-              <a:rPr lang="en-US" sz="1100" spc="-10" noProof="0" dirty="0">
-                <a:solidFill>
-                  <a:srgbClr val="002060"/>
-                </a:solidFill>
-                <a:uFill>
-                  <a:solidFill>
-                    <a:srgbClr val="39A0D2"/>
-                  </a:solidFill>
-                </a:uFill>
-                <a:latin typeface="Century Gothic" panose="020B0502020202020204" pitchFamily="34" charset="0"/>
-                <a:cs typeface="Calibri"/>
-              </a:rPr>
-              <a:t> </a:t>
-            </a:r>
-            <a:r>
-              <a:rPr lang="en-US" sz="1100" spc="-10" noProof="0" dirty="0" err="1">
-                <a:solidFill>
-                  <a:srgbClr val="002060"/>
-                </a:solidFill>
-                <a:uFill>
-                  <a:solidFill>
-                    <a:srgbClr val="39A0D2"/>
-                  </a:solidFill>
-                </a:uFill>
-                <a:latin typeface="Century Gothic" panose="020B0502020202020204" pitchFamily="34" charset="0"/>
-                <a:cs typeface="Calibri"/>
-              </a:rPr>
-              <a:t>Logistik</a:t>
-            </a:r>
-            <a:r>
-              <a:rPr lang="en-US" sz="1100" spc="-10" noProof="0" dirty="0">
-                <a:solidFill>
-                  <a:srgbClr val="002060"/>
-                </a:solidFill>
-                <a:uFill>
-                  <a:solidFill>
-                    <a:srgbClr val="39A0D2"/>
-                  </a:solidFill>
-                </a:uFill>
-                <a:latin typeface="Century Gothic" panose="020B0502020202020204" pitchFamily="34" charset="0"/>
-                <a:cs typeface="Calibri"/>
-              </a:rPr>
-              <a:t> (BVL), Germany</a:t>
-            </a:r>
-          </a:p>
-          <a:p>
-            <a:pPr marL="355600" algn="just">
-              <a:lnSpc>
-                <a:spcPct val="100000"/>
-              </a:lnSpc>
-              <a:spcAft>
-                <a:spcPts val="600"/>
-              </a:spcAft>
-            </a:pPr>
-            <a:r>
-              <a:rPr lang="en-US" sz="1100" b="1" spc="-10" noProof="0" dirty="0">
-                <a:solidFill>
-                  <a:srgbClr val="002060"/>
-                </a:solidFill>
-                <a:uFill>
-                  <a:solidFill>
-                    <a:srgbClr val="39A0D2"/>
-                  </a:solidFill>
-                </a:uFill>
-                <a:latin typeface="Century Gothic" panose="020B0502020202020204" pitchFamily="34" charset="0"/>
-                <a:cs typeface="Calibri"/>
-              </a:rPr>
-              <a:t>Ms. Judith Blank, </a:t>
-            </a:r>
-            <a:r>
-              <a:rPr lang="en-US" sz="1100" spc="-10" noProof="0" dirty="0">
-                <a:solidFill>
-                  <a:srgbClr val="002060"/>
-                </a:solidFill>
-                <a:uFill>
-                  <a:solidFill>
-                    <a:srgbClr val="39A0D2"/>
-                  </a:solidFill>
-                </a:uFill>
-                <a:latin typeface="Century Gothic" panose="020B0502020202020204" pitchFamily="34" charset="0"/>
-                <a:cs typeface="Calibri"/>
-              </a:rPr>
-              <a:t>Project Director, Regional Programme Trade Facilitation in Central Asia/TCTC Capacity Development Programme, GIZ Central Asia”</a:t>
-            </a:r>
-          </a:p>
-          <a:p>
-            <a:pPr marL="12700" algn="just">
-              <a:lnSpc>
-                <a:spcPct val="100000"/>
-              </a:lnSpc>
-              <a:spcAft>
-                <a:spcPts val="600"/>
-              </a:spcAft>
-            </a:pPr>
-            <a:endParaRPr lang="en-US" sz="1100" spc="-10" noProof="0" dirty="0">
+              <a:t>Representatives of Kazakh and German companies and institutions </a:t>
+            </a:r>
+            <a:endParaRPr lang="kk-KZ" sz="1100" spc="-10" noProof="0">
               <a:solidFill>
                 <a:srgbClr val="002060"/>
               </a:solidFill>
@@ -5317,10 +5968,59 @@
             </a:endParaRPr>
           </a:p>
           <a:p>
-            <a:pPr marL="12700" algn="just">
-              <a:lnSpc>
-                <a:spcPct val="100000"/>
-              </a:lnSpc>
+            <a:pPr marL="355600" algn="l">
+              <a:spcAft>
+                <a:spcPts val="1200"/>
+              </a:spcAft>
+            </a:pPr>
+            <a:r>
+              <a:rPr lang="en-US" sz="1100" spc="-10" noProof="0">
+                <a:solidFill>
+                  <a:srgbClr val="002060"/>
+                </a:solidFill>
+                <a:uFill>
+                  <a:solidFill>
+                    <a:srgbClr val="39A0D2"/>
+                  </a:solidFill>
+                </a:uFill>
+                <a:latin typeface="Century Gothic" panose="020B0502020202020204" pitchFamily="34" charset="0"/>
+                <a:cs typeface="Calibri"/>
+              </a:rPr>
+              <a:t>13:00 </a:t>
+            </a:r>
+            <a:r>
+              <a:rPr lang="en-US" sz="1100" spc="-10" noProof="0" dirty="0">
+                <a:solidFill>
+                  <a:srgbClr val="002060"/>
+                </a:solidFill>
+                <a:uFill>
+                  <a:solidFill>
+                    <a:srgbClr val="39A0D2"/>
+                  </a:solidFill>
+                </a:uFill>
+                <a:latin typeface="Century Gothic" panose="020B0502020202020204" pitchFamily="34" charset="0"/>
+                <a:cs typeface="Calibri"/>
+              </a:rPr>
+              <a:t>– 14:30 </a:t>
+            </a:r>
+            <a:r>
+              <a:rPr lang="en-US" sz="1100" b="1" spc="-10" noProof="0" dirty="0">
+                <a:solidFill>
+                  <a:srgbClr val="002060"/>
+                </a:solidFill>
+                <a:uFill>
+                  <a:solidFill>
+                    <a:srgbClr val="39A0D2"/>
+                  </a:solidFill>
+                </a:uFill>
+                <a:latin typeface="Century Gothic" panose="020B0502020202020204" pitchFamily="34" charset="0"/>
+                <a:cs typeface="Calibri"/>
+              </a:rPr>
+              <a:t>Lunch Break</a:t>
+            </a:r>
+          </a:p>
+          <a:p>
+            <a:pPr marL="12700" algn="l">
               <a:spcAft>
                 <a:spcPts val="600"/>
               </a:spcAft>
@@ -5338,7 +6038,7 @@
                 <a:latin typeface="Century Gothic" panose="020B0502020202020204" pitchFamily="34" charset="0"/>
                 <a:cs typeface="Calibri"/>
               </a:rPr>
-              <a:t>12:20 – 12:30 </a:t>
+              <a:t>14:30 – 17:00</a:t>
             </a:r>
             <a:r>
               <a:rPr lang="en-US" sz="1100" b="1" spc="-10" noProof="0" dirty="0">
@@ -5353,37 +6053,37 @@
                 <a:latin typeface="Century Gothic" panose="020B0502020202020204" pitchFamily="34" charset="0"/>
                 <a:cs typeface="Calibri"/>
               </a:rPr>
-              <a:t>Coffee Break</a:t>
-            </a:r>
-          </a:p>
-          <a:p>
-            <a:pPr marL="12700" algn="just">
-              <a:lnSpc>
-                <a:spcPct val="100000"/>
-              </a:lnSpc>
+              <a:t> B2B Meetings</a:t>
+            </a:r>
+          </a:p>
+          <a:p>
+            <a:pPr marL="12700" algn="l">
+              <a:spcAft>
+                <a:spcPts val="1200"/>
+              </a:spcAft>
+            </a:pPr>
+            <a:r>
+              <a:rPr lang="en-US" sz="1100" spc="-10" noProof="0" dirty="0">
+                <a:solidFill>
+                  <a:srgbClr val="002060"/>
+                </a:solidFill>
+                <a:uFill>
+                  <a:solidFill>
+                    <a:srgbClr val="39A0D2"/>
+                  </a:solidFill>
+                </a:uFill>
+                <a:latin typeface="Century Gothic" panose="020B0502020202020204" pitchFamily="34" charset="0"/>
+                <a:cs typeface="Calibri"/>
+              </a:rPr>
+              <a:t>A series of targeted business meetings aimed at identifying potential partners and discussing joint scientific, educational, and business projects. For participants’ convenience, the official Forum website will provide information on attendees and a meeting-scheduling system.</a:t>
+            </a:r>
+          </a:p>
+          <a:p>
+            <a:pPr marL="12700" algn="l">
               <a:spcAft>
                 <a:spcPts val="600"/>
               </a:spcAft>
             </a:pPr>
-            <a:endParaRPr lang="en-US" sz="1100" spc="-10" noProof="0" dirty="0">
-              <a:solidFill>
-                <a:srgbClr val="002060"/>
-              </a:solidFill>
-              <a:uFill>
-                <a:solidFill>
-                  <a:srgbClr val="39A0D2"/>
-                </a:solidFill>
-              </a:uFill>
-              <a:latin typeface="Century Gothic" panose="020B0502020202020204" pitchFamily="34" charset="0"/>
-              <a:cs typeface="Calibri"/>
-            </a:endParaRPr>
-          </a:p>
-          <a:p>
-            <a:pPr marL="12700" algn="just">
-              <a:lnSpc>
-                <a:spcPct val="100000"/>
-              </a:lnSpc>
-            </a:pPr>
             <a:r>
               <a:rPr lang="en-US" sz="1100" spc="-10" noProof="0" dirty="0">
                 <a:solidFill>
@@ -5397,7 +6097,7 @@
                 <a:latin typeface="Century Gothic" panose="020B0502020202020204" pitchFamily="34" charset="0"/>
                 <a:cs typeface="Calibri"/>
               </a:rPr>
-              <a:t>12:30 – 12:45 </a:t>
+              <a:t>17:00 </a:t>
             </a:r>
             <a:r>
               <a:rPr lang="en-US" sz="1100" b="1" spc="-10" noProof="0" dirty="0">
@@ -5412,29 +6112,29 @@
                 <a:latin typeface="Century Gothic" panose="020B0502020202020204" pitchFamily="34" charset="0"/>
                 <a:cs typeface="Calibri"/>
               </a:rPr>
-              <a:t>Q&amp;A Session with Speakers</a:t>
-            </a:r>
-          </a:p>
-          <a:p>
-            <a:pPr marL="12700" algn="just">
-              <a:lnSpc>
-                <a:spcPct val="100000"/>
-              </a:lnSpc>
-            </a:pPr>
-            <a:r>
-              <a:rPr lang="en-US" sz="1100" b="1" i="1" spc="-10" noProof="0" dirty="0">
-                <a:solidFill>
-                  <a:srgbClr val="002060"/>
-                </a:solidFill>
-                <a:uFill>
-                  <a:solidFill>
-                    <a:srgbClr val="39A0D2"/>
-                  </a:solidFill>
-                </a:uFill>
-                <a:latin typeface="Century Gothic" panose="020B0502020202020204" pitchFamily="34" charset="0"/>
-                <a:cs typeface="Calibri"/>
-              </a:rPr>
-              <a:t>Moderator:</a:t>
+              <a:t>Closing of the Forum</a:t>
+            </a:r>
+          </a:p>
+          <a:p>
+            <a:pPr marL="12700" algn="l">
+              <a:spcAft>
+                <a:spcPts val="1200"/>
+              </a:spcAft>
+            </a:pPr>
+            <a:r>
+              <a:rPr lang="en-US" sz="1100" b="1" spc="-10" noProof="0" dirty="0">
+                <a:solidFill>
+                  <a:srgbClr val="002060"/>
+                </a:solidFill>
+                <a:uFill>
+                  <a:solidFill>
+                    <a:srgbClr val="39A0D2"/>
+                  </a:solidFill>
+                </a:uFill>
+                <a:latin typeface="Century Gothic" panose="020B0502020202020204" pitchFamily="34" charset="0"/>
+                <a:cs typeface="Calibri"/>
+              </a:rPr>
+              <a:t>Evening Reception </a:t>
             </a:r>
             <a:r>
               <a:rPr lang="en-US" sz="1100" spc="-10" noProof="0" dirty="0">
@@ -5449,9 +6149,103 @@
                 <a:latin typeface="Century Gothic" panose="020B0502020202020204" pitchFamily="34" charset="0"/>
                 <a:cs typeface="Calibri"/>
               </a:rPr>
+              <a:t>(</a:t>
+            </a:r>
+            <a:r>
+              <a:rPr lang="en-US" sz="1100" spc="-10" noProof="0" dirty="0" err="1">
+                <a:solidFill>
+                  <a:srgbClr val="002060"/>
+                </a:solidFill>
+                <a:highlight>
+                  <a:srgbClr val="FFFF00"/>
+                </a:highlight>
+                <a:uFill>
+                  <a:solidFill>
+                    <a:srgbClr val="39A0D2"/>
+                  </a:solidFill>
+                </a:uFill>
+                <a:latin typeface="Century Gothic" panose="020B0502020202020204" pitchFamily="34" charset="0"/>
+                <a:cs typeface="Calibri"/>
+              </a:rPr>
+              <a:t>Paulaner</a:t>
+            </a:r>
+            <a:r>
+              <a:rPr lang="en-US" sz="1100" spc="-10" noProof="0" dirty="0">
+                <a:solidFill>
+                  <a:srgbClr val="002060"/>
+                </a:solidFill>
+                <a:highlight>
+                  <a:srgbClr val="FFFF00"/>
+                </a:highlight>
+                <a:uFill>
+                  <a:solidFill>
+                    <a:srgbClr val="39A0D2"/>
+                  </a:solidFill>
+                </a:uFill>
+                <a:latin typeface="Century Gothic" panose="020B0502020202020204" pitchFamily="34" charset="0"/>
+                <a:cs typeface="Calibri"/>
+              </a:rPr>
               <a:t> </a:t>
             </a:r>
             <a:r>
+              <a:rPr lang="en-US" sz="1100" spc="-10" noProof="0" dirty="0" err="1">
+                <a:solidFill>
+                  <a:srgbClr val="002060"/>
+                </a:solidFill>
+                <a:highlight>
+                  <a:srgbClr val="FFFF00"/>
+                </a:highlight>
+                <a:uFill>
+                  <a:solidFill>
+                    <a:srgbClr val="39A0D2"/>
+                  </a:solidFill>
+                </a:uFill>
+                <a:latin typeface="Century Gothic" panose="020B0502020202020204" pitchFamily="34" charset="0"/>
+                <a:cs typeface="Calibri"/>
+              </a:rPr>
+              <a:t>Bräuhaus</a:t>
+            </a:r>
+            <a:r>
+              <a:rPr lang="en-US" sz="1100" spc="-10" noProof="0" dirty="0">
+                <a:solidFill>
+                  <a:srgbClr val="002060"/>
+                </a:solidFill>
+                <a:highlight>
+                  <a:srgbClr val="FFFF00"/>
+                </a:highlight>
+                <a:uFill>
+                  <a:solidFill>
+                    <a:srgbClr val="39A0D2"/>
+                  </a:solidFill>
+                </a:uFill>
+                <a:latin typeface="Century Gothic" panose="020B0502020202020204" pitchFamily="34" charset="0"/>
+                <a:cs typeface="Calibri"/>
+              </a:rPr>
+              <a:t> Almaty)</a:t>
+            </a:r>
+          </a:p>
+          <a:p>
+            <a:pPr marL="12700" algn="l">
+              <a:spcAft>
+                <a:spcPts val="1200"/>
+              </a:spcAft>
+            </a:pPr>
+            <a:r>
+              <a:rPr lang="en-US" sz="1100" spc="-10" noProof="0" dirty="0">
+                <a:solidFill>
+                  <a:srgbClr val="002060"/>
+                </a:solidFill>
+                <a:uFill>
+                  <a:solidFill>
+                    <a:srgbClr val="39A0D2"/>
+                  </a:solidFill>
+                </a:uFill>
+                <a:latin typeface="Century Gothic" panose="020B0502020202020204" pitchFamily="34" charset="0"/>
+                <a:cs typeface="Calibri"/>
+              </a:rPr>
+              <a:t>18:00 </a:t>
+            </a:r>
+            <a:r>
               <a:rPr lang="en-US" sz="1100" b="1" spc="-10" noProof="0" dirty="0">
                 <a:solidFill>
                   <a:srgbClr val="002060"/>
@@ -5464,8 +6258,15 @@
                 <a:latin typeface="Century Gothic" panose="020B0502020202020204" pitchFamily="34" charset="0"/>
                 <a:cs typeface="Calibri"/>
               </a:rPr>
-              <a:t>Mr. Marat M. Idrissov</a:t>
-            </a:r>
+              <a:t>Networking Reception / Buffet</a:t>
+            </a:r>
+          </a:p>
+          <a:p>
+            <a:pPr marL="12700" algn="l">
+              <a:spcAft>
+                <a:spcPts val="1200"/>
+              </a:spcAft>
+            </a:pPr>
             <a:r>
               <a:rPr lang="en-US" sz="1100" spc="-10" noProof="0" dirty="0">
                 <a:solidFill>
@@ -5479,464 +6280,30 @@
                 <a:latin typeface="Century Gothic" panose="020B0502020202020204" pitchFamily="34" charset="0"/>
                 <a:cs typeface="Calibri"/>
               </a:rPr>
-              <a:t>, Kazakhstan Industry Development Institute</a:t>
-            </a:r>
-          </a:p>
-          <a:p>
-            <a:pPr marL="12700" algn="just">
-              <a:lnSpc>
-                <a:spcPct val="100000"/>
-              </a:lnSpc>
+              <a:t>21:00 </a:t>
+            </a:r>
+            <a:r>
+              <a:rPr lang="en-US" sz="1100" b="1" spc="-10" noProof="0" dirty="0">
+                <a:solidFill>
+                  <a:srgbClr val="002060"/>
+                </a:solidFill>
+                <a:uFill>
+                  <a:solidFill>
+                    <a:srgbClr val="39A0D2"/>
+                  </a:solidFill>
+                </a:uFill>
+                <a:latin typeface="Century Gothic" panose="020B0502020202020204" pitchFamily="34" charset="0"/>
+                <a:cs typeface="Calibri"/>
+              </a:rPr>
+              <a:t>End of Event</a:t>
+            </a:r>
+          </a:p>
+          <a:p>
+            <a:pPr marL="12700" algn="l">
               <a:spcAft>
                 <a:spcPts val="600"/>
               </a:spcAft>
             </a:pPr>
-            <a:endParaRPr lang="en-US" sz="1100" spc="-10" noProof="0" dirty="0">
-              <a:solidFill>
-                <a:srgbClr val="002060"/>
-              </a:solidFill>
-              <a:uFill>
-                <a:solidFill>
-                  <a:srgbClr val="39A0D2"/>
-                </a:solidFill>
-              </a:uFill>
-              <a:latin typeface="Century Gothic" panose="020B0502020202020204" pitchFamily="34" charset="0"/>
-              <a:cs typeface="Calibri"/>
-            </a:endParaRPr>
-          </a:p>
-          <a:p>
-            <a:pPr marL="12700" algn="just">
-              <a:lnSpc>
-                <a:spcPct val="100000"/>
-              </a:lnSpc>
-            </a:pPr>
-            <a:r>
-              <a:rPr lang="en-US" sz="1100" spc="-10" noProof="0" dirty="0">
-                <a:solidFill>
-                  <a:srgbClr val="002060"/>
-                </a:solidFill>
-                <a:uFill>
-                  <a:solidFill>
-                    <a:srgbClr val="39A0D2"/>
-                  </a:solidFill>
-                </a:uFill>
-                <a:latin typeface="Century Gothic" panose="020B0502020202020204" pitchFamily="34" charset="0"/>
-                <a:cs typeface="Calibri"/>
-              </a:rPr>
-              <a:t>12:45 – 13:00 </a:t>
-            </a:r>
-            <a:r>
-              <a:rPr lang="en-US" sz="1100" b="1" spc="-10" noProof="0" dirty="0">
-                <a:solidFill>
-                  <a:srgbClr val="002060"/>
-                </a:solidFill>
-                <a:uFill>
-                  <a:solidFill>
-                    <a:srgbClr val="39A0D2"/>
-                  </a:solidFill>
-                </a:uFill>
-                <a:latin typeface="Century Gothic" panose="020B0502020202020204" pitchFamily="34" charset="0"/>
-                <a:cs typeface="Calibri"/>
-              </a:rPr>
-              <a:t>Q&amp;A Session with Forum Participants / Open Discussion</a:t>
-            </a:r>
-          </a:p>
-          <a:p>
-            <a:pPr marL="12700" algn="just">
-              <a:lnSpc>
-                <a:spcPct val="100000"/>
-              </a:lnSpc>
-            </a:pPr>
-            <a:r>
-              <a:rPr lang="en-US" sz="1100" b="1" i="1" spc="-10" noProof="0" dirty="0">
-                <a:solidFill>
-                  <a:srgbClr val="002060"/>
-                </a:solidFill>
-                <a:uFill>
-                  <a:solidFill>
-                    <a:srgbClr val="39A0D2"/>
-                  </a:solidFill>
-                </a:uFill>
-                <a:latin typeface="Century Gothic" panose="020B0502020202020204" pitchFamily="34" charset="0"/>
-                <a:cs typeface="Calibri"/>
-              </a:rPr>
-              <a:t>Moderator: </a:t>
-            </a:r>
-            <a:r>
-              <a:rPr lang="en-US" sz="1100" b="1" spc="-10" noProof="0" dirty="0">
-                <a:solidFill>
-                  <a:srgbClr val="002060"/>
-                </a:solidFill>
-                <a:uFill>
-                  <a:solidFill>
-                    <a:srgbClr val="39A0D2"/>
-                  </a:solidFill>
-                </a:uFill>
-                <a:latin typeface="Century Gothic" panose="020B0502020202020204" pitchFamily="34" charset="0"/>
-                <a:cs typeface="Calibri"/>
-              </a:rPr>
-              <a:t>Mr. Marat M. Idrissov</a:t>
-            </a:r>
-            <a:r>
-              <a:rPr lang="en-US" sz="1100" spc="-10" noProof="0" dirty="0">
-                <a:solidFill>
-                  <a:srgbClr val="002060"/>
-                </a:solidFill>
-                <a:uFill>
-                  <a:solidFill>
-                    <a:srgbClr val="39A0D2"/>
-                  </a:solidFill>
-                </a:uFill>
-                <a:latin typeface="Century Gothic" panose="020B0502020202020204" pitchFamily="34" charset="0"/>
-                <a:cs typeface="Calibri"/>
-              </a:rPr>
-              <a:t>, Kazakhstan Industry Development Institute</a:t>
-            </a:r>
-          </a:p>
-          <a:p>
-            <a:pPr marL="12700" algn="just">
-              <a:lnSpc>
-                <a:spcPct val="100000"/>
-              </a:lnSpc>
-              <a:spcAft>
-                <a:spcPts val="600"/>
-              </a:spcAft>
-            </a:pPr>
-            <a:endParaRPr lang="en-US" sz="1100" spc="-10" noProof="0" dirty="0">
-              <a:solidFill>
-                <a:srgbClr val="002060"/>
-              </a:solidFill>
-              <a:uFill>
-                <a:solidFill>
-                  <a:srgbClr val="39A0D2"/>
-                </a:solidFill>
-              </a:uFill>
-              <a:latin typeface="Century Gothic" panose="020B0502020202020204" pitchFamily="34" charset="0"/>
-              <a:cs typeface="Calibri"/>
-            </a:endParaRPr>
-          </a:p>
-          <a:p>
-            <a:pPr marL="12700" algn="just">
-              <a:lnSpc>
-                <a:spcPct val="100000"/>
-              </a:lnSpc>
-              <a:spcAft>
-                <a:spcPts val="600"/>
-              </a:spcAft>
-            </a:pPr>
-            <a:r>
-              <a:rPr lang="en-US" sz="1100" spc="-10" noProof="0" dirty="0">
-                <a:solidFill>
-                  <a:srgbClr val="002060"/>
-                </a:solidFill>
-                <a:uFill>
-                  <a:solidFill>
-                    <a:srgbClr val="39A0D2"/>
-                  </a:solidFill>
-                </a:uFill>
-                <a:latin typeface="Century Gothic" panose="020B0502020202020204" pitchFamily="34" charset="0"/>
-                <a:cs typeface="Calibri"/>
-              </a:rPr>
-              <a:t>13:00 – 14:30 </a:t>
-            </a:r>
-            <a:r>
-              <a:rPr lang="en-US" sz="1100" b="1" spc="-10" noProof="0" dirty="0">
-                <a:solidFill>
-                  <a:srgbClr val="002060"/>
-                </a:solidFill>
-                <a:uFill>
-                  <a:solidFill>
-                    <a:srgbClr val="39A0D2"/>
-                  </a:solidFill>
-                </a:uFill>
-                <a:latin typeface="Century Gothic" panose="020B0502020202020204" pitchFamily="34" charset="0"/>
-                <a:cs typeface="Calibri"/>
-              </a:rPr>
-              <a:t>Lunch Break</a:t>
-            </a:r>
-          </a:p>
-          <a:p>
-            <a:pPr marL="12700" algn="just">
-              <a:lnSpc>
-                <a:spcPct val="100000"/>
-              </a:lnSpc>
-              <a:spcAft>
-                <a:spcPts val="600"/>
-              </a:spcAft>
-            </a:pPr>
-            <a:endParaRPr lang="en-US" sz="1100" b="1" spc="-10" noProof="0" dirty="0">
-              <a:solidFill>
-                <a:srgbClr val="002060"/>
-              </a:solidFill>
-              <a:uFill>
-                <a:solidFill>
-                  <a:srgbClr val="39A0D2"/>
-                </a:solidFill>
-              </a:uFill>
-              <a:latin typeface="Century Gothic" panose="020B0502020202020204" pitchFamily="34" charset="0"/>
-              <a:cs typeface="Calibri"/>
-            </a:endParaRPr>
-          </a:p>
-          <a:p>
-            <a:pPr marL="12700" algn="just">
-              <a:lnSpc>
-                <a:spcPct val="100000"/>
-              </a:lnSpc>
-            </a:pPr>
-            <a:r>
-              <a:rPr lang="en-US" sz="1100" spc="-10" noProof="0" dirty="0">
-                <a:solidFill>
-                  <a:srgbClr val="002060"/>
-                </a:solidFill>
-                <a:uFill>
-                  <a:solidFill>
-                    <a:srgbClr val="39A0D2"/>
-                  </a:solidFill>
-                </a:uFill>
-                <a:latin typeface="Century Gothic" panose="020B0502020202020204" pitchFamily="34" charset="0"/>
-                <a:cs typeface="Calibri"/>
-              </a:rPr>
-              <a:t>14:30 – 17:00</a:t>
-            </a:r>
-            <a:r>
-              <a:rPr lang="en-US" sz="1100" b="1" spc="-10" noProof="0" dirty="0">
-                <a:solidFill>
-                  <a:srgbClr val="002060"/>
-                </a:solidFill>
-                <a:uFill>
-                  <a:solidFill>
-                    <a:srgbClr val="39A0D2"/>
-                  </a:solidFill>
-                </a:uFill>
-                <a:latin typeface="Century Gothic" panose="020B0502020202020204" pitchFamily="34" charset="0"/>
-                <a:cs typeface="Calibri"/>
-              </a:rPr>
-              <a:t> B2B Meetings</a:t>
-            </a:r>
-          </a:p>
-          <a:p>
-            <a:pPr marL="12700" algn="just">
-              <a:lnSpc>
-                <a:spcPct val="100000"/>
-              </a:lnSpc>
-            </a:pPr>
-            <a:r>
-              <a:rPr lang="en-US" sz="1100" spc="-10" noProof="0" dirty="0">
-                <a:solidFill>
-                  <a:srgbClr val="002060"/>
-                </a:solidFill>
-                <a:uFill>
-                  <a:solidFill>
-                    <a:srgbClr val="39A0D2"/>
-                  </a:solidFill>
-                </a:uFill>
-                <a:latin typeface="Century Gothic" panose="020B0502020202020204" pitchFamily="34" charset="0"/>
-                <a:cs typeface="Calibri"/>
-              </a:rPr>
-              <a:t>A series of targeted business meetings aimed at identifying potential partners and discussing joint scientific, educational, and business projects. For participants’ convenience, the official Forum website will provide information on attendees and a meeting-scheduling system.</a:t>
-            </a:r>
-          </a:p>
-          <a:p>
-            <a:pPr marL="12700" algn="just">
-              <a:lnSpc>
-                <a:spcPct val="100000"/>
-              </a:lnSpc>
-              <a:spcAft>
-                <a:spcPts val="600"/>
-              </a:spcAft>
-            </a:pPr>
-            <a:endParaRPr lang="en-US" sz="1100" spc="-10" noProof="0" dirty="0">
-              <a:solidFill>
-                <a:srgbClr val="002060"/>
-              </a:solidFill>
-              <a:uFill>
-                <a:solidFill>
-                  <a:srgbClr val="39A0D2"/>
-                </a:solidFill>
-              </a:uFill>
-              <a:latin typeface="Century Gothic" panose="020B0502020202020204" pitchFamily="34" charset="0"/>
-              <a:cs typeface="Calibri"/>
-            </a:endParaRPr>
-          </a:p>
-          <a:p>
-            <a:pPr marL="12700" algn="just">
-              <a:lnSpc>
-                <a:spcPct val="100000"/>
-              </a:lnSpc>
-              <a:spcAft>
-                <a:spcPts val="600"/>
-              </a:spcAft>
-            </a:pPr>
-            <a:r>
-              <a:rPr lang="en-US" sz="1100" spc="-10" noProof="0" dirty="0">
-                <a:solidFill>
-                  <a:srgbClr val="002060"/>
-                </a:solidFill>
-                <a:uFill>
-                  <a:solidFill>
-                    <a:srgbClr val="39A0D2"/>
-                  </a:solidFill>
-                </a:uFill>
-                <a:latin typeface="Century Gothic" panose="020B0502020202020204" pitchFamily="34" charset="0"/>
-                <a:cs typeface="Calibri"/>
-              </a:rPr>
-              <a:t>17:00 </a:t>
-            </a:r>
-            <a:r>
-              <a:rPr lang="en-US" sz="1100" b="1" spc="-10" noProof="0" dirty="0">
-                <a:solidFill>
-                  <a:srgbClr val="002060"/>
-                </a:solidFill>
-                <a:uFill>
-                  <a:solidFill>
-                    <a:srgbClr val="39A0D2"/>
-                  </a:solidFill>
-                </a:uFill>
-                <a:latin typeface="Century Gothic" panose="020B0502020202020204" pitchFamily="34" charset="0"/>
-                <a:cs typeface="Calibri"/>
-              </a:rPr>
-              <a:t>Closing of the Forum</a:t>
-            </a:r>
-          </a:p>
-          <a:p>
-            <a:pPr marL="12700" algn="just">
-              <a:lnSpc>
-                <a:spcPct val="100000"/>
-              </a:lnSpc>
-              <a:spcAft>
-                <a:spcPts val="600"/>
-              </a:spcAft>
-            </a:pPr>
-            <a:endParaRPr lang="en-US" sz="1100" spc="-10" noProof="0" dirty="0">
-              <a:solidFill>
-                <a:srgbClr val="002060"/>
-              </a:solidFill>
-              <a:uFill>
-                <a:solidFill>
-                  <a:srgbClr val="39A0D2"/>
-                </a:solidFill>
-              </a:uFill>
-              <a:latin typeface="Century Gothic" panose="020B0502020202020204" pitchFamily="34" charset="0"/>
-              <a:cs typeface="Calibri"/>
-            </a:endParaRPr>
-          </a:p>
-          <a:p>
-            <a:pPr marL="12700" algn="just">
-              <a:lnSpc>
-                <a:spcPct val="100000"/>
-              </a:lnSpc>
-            </a:pPr>
-            <a:r>
-              <a:rPr lang="en-US" sz="1100" b="1" spc="-10" noProof="0" dirty="0">
-                <a:solidFill>
-                  <a:srgbClr val="002060"/>
-                </a:solidFill>
-                <a:uFill>
-                  <a:solidFill>
-                    <a:srgbClr val="39A0D2"/>
-                  </a:solidFill>
-                </a:uFill>
-                <a:latin typeface="Century Gothic" panose="020B0502020202020204" pitchFamily="34" charset="0"/>
-                <a:cs typeface="Calibri"/>
-              </a:rPr>
-              <a:t>Evening Reception</a:t>
-            </a:r>
-            <a:endParaRPr lang="en-US" sz="1100" spc="-10" noProof="0" dirty="0">
-              <a:solidFill>
-                <a:srgbClr val="002060"/>
-              </a:solidFill>
-              <a:highlight>
-                <a:srgbClr val="FFFF00"/>
-              </a:highlight>
-              <a:uFill>
-                <a:solidFill>
-                  <a:srgbClr val="39A0D2"/>
-                </a:solidFill>
-              </a:uFill>
-              <a:latin typeface="Century Gothic" panose="020B0502020202020204" pitchFamily="34" charset="0"/>
-              <a:cs typeface="Calibri"/>
-            </a:endParaRPr>
-          </a:p>
-          <a:p>
-            <a:pPr marL="12700" algn="just">
-              <a:lnSpc>
-                <a:spcPct val="100000"/>
-              </a:lnSpc>
-            </a:pPr>
-            <a:r>
-              <a:rPr lang="en-US" sz="1100" spc="-10" noProof="0" dirty="0">
-                <a:solidFill>
-                  <a:srgbClr val="002060"/>
-                </a:solidFill>
-                <a:uFill>
-                  <a:solidFill>
-                    <a:srgbClr val="39A0D2"/>
-                  </a:solidFill>
-                </a:uFill>
-                <a:latin typeface="Century Gothic" panose="020B0502020202020204" pitchFamily="34" charset="0"/>
-                <a:cs typeface="Calibri"/>
-              </a:rPr>
-              <a:t>18:00 </a:t>
-            </a:r>
-            <a:r>
-              <a:rPr lang="en-US" sz="1100" b="1" spc="-10" noProof="0" dirty="0">
-                <a:solidFill>
-                  <a:srgbClr val="002060"/>
-                </a:solidFill>
-                <a:uFill>
-                  <a:solidFill>
-                    <a:srgbClr val="39A0D2"/>
-                  </a:solidFill>
-                </a:uFill>
-                <a:latin typeface="Century Gothic" panose="020B0502020202020204" pitchFamily="34" charset="0"/>
-                <a:cs typeface="Calibri"/>
-              </a:rPr>
-              <a:t>Networking Reception / Buffet</a:t>
-            </a:r>
-          </a:p>
-          <a:p>
-            <a:pPr marL="12700" algn="just">
-              <a:lnSpc>
-                <a:spcPct val="100000"/>
-              </a:lnSpc>
-            </a:pPr>
-            <a:r>
-              <a:rPr lang="en-US" sz="1100" spc="-10" noProof="0" dirty="0">
-                <a:solidFill>
-                  <a:srgbClr val="002060"/>
-                </a:solidFill>
-                <a:uFill>
-                  <a:solidFill>
-                    <a:srgbClr val="39A0D2"/>
-                  </a:solidFill>
-                </a:uFill>
-                <a:latin typeface="Century Gothic" panose="020B0502020202020204" pitchFamily="34" charset="0"/>
-                <a:cs typeface="Calibri"/>
-              </a:rPr>
-              <a:t>21:00 </a:t>
-            </a:r>
-            <a:r>
-              <a:rPr lang="en-US" sz="1100" b="1" spc="-10" noProof="0" dirty="0">
-                <a:solidFill>
-                  <a:srgbClr val="002060"/>
-                </a:solidFill>
-                <a:uFill>
-                  <a:solidFill>
-                    <a:srgbClr val="39A0D2"/>
-                  </a:solidFill>
-                </a:uFill>
-                <a:latin typeface="Century Gothic" panose="020B0502020202020204" pitchFamily="34" charset="0"/>
-                <a:cs typeface="Calibri"/>
-              </a:rPr>
-              <a:t>End of Event</a:t>
-            </a:r>
-          </a:p>
-          <a:p>
-            <a:pPr marL="12700" algn="just">
-              <a:lnSpc>
-                <a:spcPct val="100000"/>
-              </a:lnSpc>
-            </a:pPr>
             <a:r>
               <a:rPr lang="en-US" sz="1100" spc="-10" noProof="0" dirty="0">
                 <a:solidFill>
@@ -5970,6 +6337,36 @@
           </a:p>
         </p:txBody>
       </p:sp>
+      <p:pic>
+        <p:nvPicPr>
+          <p:cNvPr id="5" name="Grafik 4"/>
+          <p:cNvPicPr>
+            <a:picLocks noChangeAspect="1"/>
+          </p:cNvPicPr>
+          <p:nvPr/>
+        </p:nvPicPr>
+        <p:blipFill>
+          <a:blip r:embed="rId3" cstate="print">
+            <a:extLst>
+              <a:ext uri="{28A0092B-C50C-407E-A947-70E740481C1C}">
+                <a14:useLocalDpi xmlns:a14="http://schemas.microsoft.com/office/drawing/2010/main" val="0"/>
+              </a:ext>
+            </a:extLst>
+          </a:blip>
+          <a:stretch>
+            <a:fillRect/>
+          </a:stretch>
+        </p:blipFill>
+        <p:spPr>
+          <a:xfrm>
+            <a:off x="691830" y="381969"/>
+            <a:ext cx="982591" cy="462881"/>
+          </a:xfrm>
+          <a:prstGeom prst="rect">
+            <a:avLst/>
+          </a:prstGeom>
+        </p:spPr>
+      </p:pic>
     </p:spTree>
     <p:extLst>
       <p:ext uri="{BB962C8B-B14F-4D97-AF65-F5344CB8AC3E}">
@@ -6579,4 +6976,309 @@
     </a:ext>
   </a:extLst>
 </a:theme>
+</file>
+
+<file path=customXml/item1.xml><?xml version="1.0" encoding="utf-8"?>
+<p:properties xmlns:p="http://schemas.microsoft.com/office/2006/metadata/properties" xmlns:xsi="http://www.w3.org/2001/XMLSchema-instance" xmlns:pc="http://schemas.microsoft.com/office/infopath/2007/PartnerControls">
+  <documentManagement>
+    <TaxCatchAll xmlns="c945b90e-fc88-49af-b28e-2201e397b9a1"/>
+    <lcf76f155ced4ddcb4097134ff3c332f xmlns="dd447142-1aa6-4a72-a007-63df8aaaa9f8">
+      <Terms xmlns="http://schemas.microsoft.com/office/infopath/2007/PartnerControls"/>
+    </lcf76f155ced4ddcb4097134ff3c332f>
+  </documentManagement>
+</p:properties>
+</file>
+
+<file path=customXml/item2.xml><?xml version="1.0" encoding="utf-8"?>
+<ct:contentTypeSchema xmlns:ct="http://schemas.microsoft.com/office/2006/metadata/contentType" xmlns:ma="http://schemas.microsoft.com/office/2006/metadata/properties/metaAttributes" ct:_="" ma:_="" ma:contentTypeName="Dokument" ma:contentTypeID="0x0101004840DA7A1AA00843BF7BE267E1CB408D" ma:contentTypeVersion="16" ma:contentTypeDescription="Ein neues Dokument erstellen." ma:contentTypeScope="" ma:versionID="cf8e11fa954ad01a02db4d0e36146d6b">
+  <xsd:schema xmlns:xsd="http://www.w3.org/2001/XMLSchema" xmlns:xs="http://www.w3.org/2001/XMLSchema" xmlns:p="http://schemas.microsoft.com/office/2006/metadata/properties" xmlns:ns2="dd447142-1aa6-4a72-a007-63df8aaaa9f8" xmlns:ns3="c945b90e-fc88-49af-b28e-2201e397b9a1" targetNamespace="http://schemas.microsoft.com/office/2006/metadata/properties" ma:root="true" ma:fieldsID="1462049e7e9ba608de639a380a24340d" ns2:_="" ns3:_="">
+    <xsd:import namespace="dd447142-1aa6-4a72-a007-63df8aaaa9f8"/>
+    <xsd:import namespace="c945b90e-fc88-49af-b28e-2201e397b9a1"/>
+    <xsd:element name="properties">
+      <xsd:complexType>
+        <xsd:sequence>
+          <xsd:element name="documentManagement">
+            <xsd:complexType>
+              <xsd:all>
+                <xsd:element ref="ns2:MediaServiceMetadata" minOccurs="0"/>
+                <xsd:element ref="ns2:MediaServiceFastMetadata" minOccurs="0"/>
+                <xsd:element ref="ns2:MediaServiceObjectDetectorVersions" minOccurs="0"/>
+                <xsd:element ref="ns3:SharedWithUsers" minOccurs="0"/>
+                <xsd:element ref="ns3:SharedWithDetails" minOccurs="0"/>
+                <xsd:element ref="ns2:MediaServiceDateTaken" minOccurs="0"/>
+                <xsd:element ref="ns2:MediaServiceGenerationTime" minOccurs="0"/>
+                <xsd:element ref="ns2:MediaServiceEventHashCode" minOccurs="0"/>
+                <xsd:element ref="ns2:MediaLengthInSeconds" minOccurs="0"/>
+                <xsd:element ref="ns2:lcf76f155ced4ddcb4097134ff3c332f" minOccurs="0"/>
+                <xsd:element ref="ns3:TaxCatchAll" minOccurs="0"/>
+                <xsd:element ref="ns2:MediaServiceOCR" minOccurs="0"/>
+                <xsd:element ref="ns2:MediaServiceSearchProperties" minOccurs="0"/>
+                <xsd:element ref="ns2:MediaServiceLocation" minOccurs="0"/>
+                <xsd:element ref="ns2:MediaServiceBillingMetadata" minOccurs="0"/>
+              </xsd:all>
+            </xsd:complexType>
+          </xsd:element>
+        </xsd:sequence>
+      </xsd:complexType>
+    </xsd:element>
+  </xsd:schema>
+  <xsd:schema xmlns:xsd="http://www.w3.org/2001/XMLSchema" xmlns:xs="http://www.w3.org/2001/XMLSchema" xmlns:dms="http://schemas.microsoft.com/office/2006/documentManagement/types" xmlns:pc="http://schemas.microsoft.com/office/infopath/2007/PartnerControls" targetNamespace="dd447142-1aa6-4a72-a007-63df8aaaa9f8" elementFormDefault="qualified">
+    <xsd:import namespace="http://schemas.microsoft.com/office/2006/documentManagement/types"/>
+    <xsd:import namespace="http://schemas.microsoft.com/office/infopath/2007/PartnerControls"/>
+    <xsd:element name="MediaServiceMetadata" ma:index="8" nillable="true" ma:displayName="MediaServiceMetadata" ma:hidden="true" ma:internalName="MediaServiceMetadata" ma:readOnly="true">
+      <xsd:simpleType>
+        <xsd:restriction base="dms:Note"/>
+      </xsd:simpleType>
+    </xsd:element>
+    <xsd:element name="MediaServiceFastMetadata" ma:index="9" nillable="true" ma:displayName="MediaServiceFastMetadata" ma:hidden="true" ma:internalName="MediaServiceFastMetadata" ma:readOnly="true">
+      <xsd:simpleType>
+        <xsd:restriction base="dms:Note"/>
+      </xsd:simpleType>
+    </xsd:element>
+    <xsd:element name="MediaServiceObjectDetectorVersions" ma:index="10" nillable="true" ma:displayName="MediaServiceObjectDetectorVersions" ma:hidden="true" ma:indexed="true" ma:internalName="MediaServiceObjectDetectorVersions" ma:readOnly="true">
+      <xsd:simpleType>
+        <xsd:restriction base="dms:Text"/>
+      </xsd:simpleType>
+    </xsd:element>
+    <xsd:element name="MediaServiceDateTaken" ma:index="13" nillable="true" ma:displayName="MediaServiceDateTaken" ma:hidden="true" ma:indexed="true" ma:internalName="MediaServiceDateTaken" ma:readOnly="true">
+      <xsd:simpleType>
+        <xsd:restriction base="dms:Text"/>
+      </xsd:simpleType>
+    </xsd:element>
+    <xsd:element name="MediaServiceGenerationTime" ma:index="14" nillable="true" ma:displayName="MediaServiceGenerationTime" ma:hidden="true" ma:internalName="MediaServiceGenerationTime" ma:readOnly="true">
+      <xsd:simpleType>
+        <xsd:restriction base="dms:Text"/>
+      </xsd:simpleType>
+    </xsd:element>
+    <xsd:element name="MediaServiceEventHashCode" ma:index="15" nillable="true" ma:displayName="MediaServiceEventHashCode" ma:hidden="true" ma:internalName="MediaServiceEventHashCode" ma:readOnly="true">
+      <xsd:simpleType>
+        <xsd:restriction base="dms:Text"/>
+      </xsd:simpleType>
+    </xsd:element>
+    <xsd:element name="MediaLengthInSeconds" ma:index="16" nillable="true" ma:displayName="MediaLengthInSeconds" ma:hidden="true" ma:internalName="MediaLengthInSeconds" ma:readOnly="true">
+      <xsd:simpleType>
+        <xsd:restriction base="dms:Unknown"/>
+      </xsd:simpleType>
+    </xsd:element>
+    <xsd:element name="lcf76f155ced4ddcb4097134ff3c332f" ma:index="18" nillable="true" ma:taxonomy="true" ma:internalName="lcf76f155ced4ddcb4097134ff3c332f" ma:taxonomyFieldName="MediaServiceImageTags" ma:displayName="Bildmarkierungen" ma:readOnly="false" ma:fieldId="{5cf76f15-5ced-4ddc-b409-7134ff3c332f}" ma:taxonomyMulti="true" ma:sspId="0aed264e-563a-469a-8ebe-271e849ec10c" ma:termSetId="09814cd3-568e-fe90-9814-8d621ff8fb84" ma:anchorId="fba54fb3-c3e1-fe81-a776-ca4b69148c4d" ma:open="true" ma:isKeyword="false">
+      <xsd:complexType>
+        <xsd:sequence>
+          <xsd:element ref="pc:Terms" minOccurs="0" maxOccurs="1"/>
+        </xsd:sequence>
+      </xsd:complexType>
+    </xsd:element>
+    <xsd:element name="MediaServiceOCR" ma:index="20" nillable="true" ma:displayName="Extracted Text" ma:internalName="MediaServiceOCR" ma:readOnly="true">
+      <xsd:simpleType>
+        <xsd:restriction base="dms:Note">
+          <xsd:maxLength value="255"/>
+        </xsd:restriction>
+      </xsd:simpleType>
+    </xsd:element>
+    <xsd:element name="MediaServiceSearchProperties" ma:index="21" nillable="true" ma:displayName="MediaServiceSearchProperties" ma:hidden="true" ma:internalName="MediaServiceSearchProperties" ma:readOnly="true">
+      <xsd:simpleType>
+        <xsd:restriction base="dms:Note"/>
+      </xsd:simpleType>
+    </xsd:element>
+    <xsd:element name="MediaServiceLocation" ma:index="22" nillable="true" ma:displayName="Location" ma:indexed="true" ma:internalName="MediaServiceLocation" ma:readOnly="true">
+      <xsd:simpleType>
+        <xsd:restriction base="dms:Text"/>
+      </xsd:simpleType>
+    </xsd:element>
+    <xsd:element name="MediaServiceBillingMetadata" ma:index="23" nillable="true" ma:displayName="MediaServiceBillingMetadata" ma:hidden="true" ma:internalName="MediaServiceBillingMetadata" ma:readOnly="true">
+      <xsd:simpleType>
+        <xsd:restriction base="dms:Note"/>
+      </xsd:simpleType>
+    </xsd:element>
+  </xsd:schema>
+  <xsd:schema xmlns:xsd="http://www.w3.org/2001/XMLSchema" xmlns:xs="http://www.w3.org/2001/XMLSchema" xmlns:dms="http://schemas.microsoft.com/office/2006/documentManagement/types" xmlns:pc="http://schemas.microsoft.com/office/infopath/2007/PartnerControls" targetNamespace="c945b90e-fc88-49af-b28e-2201e397b9a1" elementFormDefault="qualified">
+    <xsd:import namespace="http://schemas.microsoft.com/office/2006/documentManagement/types"/>
+    <xsd:import namespace="http://schemas.microsoft.com/office/infopath/2007/PartnerControls"/>
+    <xsd:element name="SharedWithUsers" ma:index="11" nillable="true" ma:displayName="Freigegeben für" ma:internalName="SharedWithUsers" ma:readOnly="true">
+      <xsd:complexType>
+        <xsd:complexContent>
+          <xsd:extension base="dms:UserMulti">
+            <xsd:sequence>
+              <xsd:element name="UserInfo" minOccurs="0" maxOccurs="unbounded">
+                <xsd:complexType>
+                  <xsd:sequence>
+                    <xsd:element name="DisplayName" type="xsd:string" minOccurs="0"/>
+                    <xsd:element name="AccountId" type="dms:UserId" minOccurs="0" nillable="true"/>
+                    <xsd:element name="AccountType" type="xsd:string" minOccurs="0"/>
+                  </xsd:sequence>
+                </xsd:complexType>
+              </xsd:element>
+            </xsd:sequence>
+          </xsd:extension>
+        </xsd:complexContent>
+      </xsd:complexType>
+    </xsd:element>
+    <xsd:element name="SharedWithDetails" ma:index="12" nillable="true" ma:displayName="Freigegeben für - Details" ma:internalName="SharedWithDetails" ma:readOnly="true">
+      <xsd:simpleType>
+        <xsd:restriction base="dms:Note">
+          <xsd:maxLength value="255"/>
+        </xsd:restriction>
+      </xsd:simpleType>
+    </xsd:element>
+    <xsd:element name="TaxCatchAll" ma:index="19" nillable="true" ma:displayName="Taxonomy Catch All Column" ma:hidden="true" ma:list="{12ee92ea-e074-4350-ac3b-5cf132dea3f3}" ma:internalName="TaxCatchAll" ma:showField="CatchAllData" ma:web="c945b90e-fc88-49af-b28e-2201e397b9a1">
+      <xsd:complexType>
+        <xsd:complexContent>
+          <xsd:extension base="dms:MultiChoiceLookup">
+            <xsd:sequence>
+              <xsd:element name="Value" type="dms:Lookup" maxOccurs="unbounded" minOccurs="0" nillable="true"/>
+            </xsd:sequence>
+          </xsd:extension>
+        </xsd:complexContent>
+      </xsd:complexType>
+    </xsd:element>
+  </xsd:schema>
+  <xsd:schema xmlns="http://schemas.openxmlformats.org/package/2006/metadata/core-properties" xmlns:xsd="http://www.w3.org/2001/XMLSchema" xmlns:xsi="http://www.w3.org/2001/XMLSchema-instance" xmlns:dc="http://purl.org/dc/elements/1.1/" xmlns:dcterms="http://purl.org/dc/terms/" xmlns:odoc="http://schemas.microsoft.com/internal/obd" targetNamespace="http://schemas.openxmlformats.org/package/2006/metadata/core-properties" elementFormDefault="qualified" attributeFormDefault="unqualified" blockDefault="#all">
+    <xsd:import namespace="http://purl.org/dc/elements/1.1/" schemaLocation="http://dublincore.org/schemas/xmls/qdc/2003/04/02/dc.xsd"/>
+    <xsd:import namespace="http://purl.org/dc/terms/" schemaLocation="http://dublincore.org/schemas/xmls/qdc/2003/04/02/dcterms.xsd"/>
+    <xsd:element name="coreProperties" type="CT_coreProperties"/>
+    <xsd:complexType name="CT_coreProperties">
+      <xsd:all>
+        <xsd:element ref="dc:creator" minOccurs="0" maxOccurs="1"/>
+        <xsd:element ref="dcterms:created" minOccurs="0" maxOccurs="1"/>
+        <xsd:element ref="dc:identifier" minOccurs="0" maxOccurs="1"/>
+        <xsd:element name="contentType" minOccurs="0" maxOccurs="1" type="xsd:string" ma:index="0" ma:displayName="Inhaltstyp"/>
+        <xsd:element ref="dc:title" minOccurs="0" maxOccurs="1" ma:index="4" ma:displayName="Titel"/>
+        <xsd:element ref="dc:subject" minOccurs="0" maxOccurs="1"/>
+        <xsd:element ref="dc:description" minOccurs="0" maxOccurs="1"/>
+        <xsd:element name="keywords" minOccurs="0" maxOccurs="1" type="xsd:string"/>
+        <xsd:element ref="dc:language" minOccurs="0" maxOccurs="1"/>
+        <xsd:element name="category" minOccurs="0" maxOccurs="1" type="xsd:string"/>
+        <xsd:element name="version" minOccurs="0" maxOccurs="1" type="xsd:string"/>
+        <xsd:element name="revision" minOccurs="0" maxOccurs="1" type="xsd:string">
+          <xsd:annotation>
+            <xsd:documentation>
+                        This value indicates the number of saves or revisions. The application is responsible for updating this value after each revision.
+                    </xsd:documentation>
+          </xsd:annotation>
+        </xsd:element>
+        <xsd:element name="lastModifiedBy" minOccurs="0" maxOccurs="1" type="xsd:string"/>
+        <xsd:element ref="dcterms:modified" minOccurs="0" maxOccurs="1"/>
+        <xsd:element name="contentStatus" minOccurs="0" maxOccurs="1" type="xsd:string"/>
+      </xsd:all>
+    </xsd:complexType>
+  </xsd:schema>
+  <xs:schema xmlns:pc="http://schemas.microsoft.com/office/infopath/2007/PartnerControls" xmlns:xs="http://www.w3.org/2001/XMLSchema" targetNamespace="http://schemas.microsoft.com/office/infopath/2007/PartnerControls" elementFormDefault="qualified" attributeFormDefault="unqualified">
+    <xs:element name="Person">
+      <xs:complexType>
+        <xs:sequence>
+          <xs:element ref="pc:DisplayName" minOccurs="0"/>
+          <xs:element ref="pc:AccountId" minOccurs="0"/>
+          <xs:element ref="pc:AccountType" minOccurs="0"/>
+        </xs:sequence>
+      </xs:complexType>
+    </xs:element>
+    <xs:element name="DisplayName" type="xs:string"/>
+    <xs:element name="AccountId" type="xs:string"/>
+    <xs:element name="AccountType" type="xs:string"/>
+    <xs:element name="BDCAssociatedEntity">
+      <xs:complexType>
+        <xs:sequence>
+          <xs:element ref="pc:BDCEntity" minOccurs="0" maxOccurs="unbounded"/>
+        </xs:sequence>
+        <xs:attribute ref="pc:EntityNamespace"/>
+        <xs:attribute ref="pc:EntityName"/>
+        <xs:attribute ref="pc:SystemInstanceName"/>
+        <xs:attribute ref="pc:AssociationName"/>
+      </xs:complexType>
+    </xs:element>
+    <xs:attribute name="EntityNamespace" type="xs:string"/>
+    <xs:attribute name="EntityName" type="xs:string"/>
+    <xs:attribute name="SystemInstanceName" type="xs:string"/>
+    <xs:attribute name="AssociationName" type="xs:string"/>
+    <xs:element name="BDCEntity">
+      <xs:complexType>
+        <xs:sequence>
+          <xs:element ref="pc:EntityDisplayName" minOccurs="0"/>
+          <xs:element ref="pc:EntityInstanceReference" minOccurs="0"/>
+          <xs:element ref="pc:EntityId1" minOccurs="0"/>
+          <xs:element ref="pc:EntityId2" minOccurs="0"/>
+          <xs:element ref="pc:EntityId3" minOccurs="0"/>
+          <xs:element ref="pc:EntityId4" minOccurs="0"/>
+          <xs:element ref="pc:EntityId5" minOccurs="0"/>
+        </xs:sequence>
+      </xs:complexType>
+    </xs:element>
+    <xs:element name="EntityDisplayName" type="xs:string"/>
+    <xs:element name="EntityInstanceReference" type="xs:string"/>
+    <xs:element name="EntityId1" type="xs:string"/>
+    <xs:element name="EntityId2" type="xs:string"/>
+    <xs:element name="EntityId3" type="xs:string"/>
+    <xs:element name="EntityId4" type="xs:string"/>
+    <xs:element name="EntityId5" type="xs:string"/>
+    <xs:element name="Terms">
+      <xs:complexType>
+        <xs:sequence>
+          <xs:element ref="pc:TermInfo" minOccurs="0" maxOccurs="unbounded"/>
+        </xs:sequence>
+      </xs:complexType>
+    </xs:element>
+    <xs:element name="TermInfo">
+      <xs:complexType>
+        <xs:sequence>
+          <xs:element ref="pc:TermName" minOccurs="0"/>
+          <xs:element ref="pc:TermId" minOccurs="0"/>
+        </xs:sequence>
+      </xs:complexType>
+    </xs:element>
+    <xs:element name="TermName" type="xs:string"/>
+    <xs:element name="TermId" type="xs:string"/>
+  </xs:schema>
+</ct:contentTypeSchema>
+</file>
+
+<file path=customXml/item3.xml><?xml version="1.0" encoding="utf-8"?>
+<?mso-contentType ?>
+<FormTemplates xmlns="http://schemas.microsoft.com/sharepoint/v3/contenttype/forms">
+  <Display>DocumentLibraryForm</Display>
+  <Edit>DocumentLibraryForm</Edit>
+  <New>DocumentLibraryForm</New>
+</FormTemplates>
+</file>
+
+<file path=customXml/itemProps1.xml><?xml version="1.0" encoding="utf-8"?>
+<ds:datastoreItem xmlns:ds="http://schemas.openxmlformats.org/officeDocument/2006/customXml" ds:itemID="{13F9BE75-9081-4137-A096-23F8FB543BAD}">
+  <ds:schemaRefs>
+    <ds:schemaRef ds:uri="http://purl.org/dc/elements/1.1/"/>
+    <ds:schemaRef ds:uri="dd447142-1aa6-4a72-a007-63df8aaaa9f8"/>
+    <ds:schemaRef ds:uri="http://purl.org/dc/dcmitype/"/>
+    <ds:schemaRef ds:uri="c945b90e-fc88-49af-b28e-2201e397b9a1"/>
+    <ds:schemaRef ds:uri="http://schemas.microsoft.com/office/2006/documentManagement/types"/>
+    <ds:schemaRef ds:uri="http://schemas.microsoft.com/office/infopath/2007/PartnerControls"/>
+    <ds:schemaRef ds:uri="http://schemas.openxmlformats.org/package/2006/metadata/core-properties"/>
+    <ds:schemaRef ds:uri="http://schemas.microsoft.com/office/2006/metadata/properties"/>
+    <ds:schemaRef ds:uri="http://www.w3.org/XML/1998/namespace"/>
+    <ds:schemaRef ds:uri="http://purl.org/dc/terms/"/>
+  </ds:schemaRefs>
+</ds:datastoreItem>
+</file>
+
+<file path=customXml/itemProps2.xml><?xml version="1.0" encoding="utf-8"?>
+<ds:datastoreItem xmlns:ds="http://schemas.openxmlformats.org/officeDocument/2006/customXml" ds:itemID="{8E37B3B6-26DD-43E9-834B-8BEE9532C15F}">
+  <ds:schemaRefs>
+    <ds:schemaRef ds:uri="http://schemas.microsoft.com/office/2006/metadata/contentType"/>
+    <ds:schemaRef ds:uri="http://schemas.microsoft.com/office/2006/metadata/properties/metaAttributes"/>
+    <ds:schemaRef ds:uri="http://www.w3.org/2001/XMLSchema"/>
+    <ds:schemaRef ds:uri="http://schemas.microsoft.com/office/2006/metadata/properties"/>
+    <ds:schemaRef ds:uri="dd447142-1aa6-4a72-a007-63df8aaaa9f8"/>
+    <ds:schemaRef ds:uri="c945b90e-fc88-49af-b28e-2201e397b9a1"/>
+    <ds:schemaRef ds:uri="http://schemas.microsoft.com/office/2006/documentManagement/types"/>
+    <ds:schemaRef ds:uri="http://schemas.microsoft.com/office/infopath/2007/PartnerControls"/>
+    <ds:schemaRef ds:uri="http://schemas.openxmlformats.org/package/2006/metadata/core-properties"/>
+    <ds:schemaRef ds:uri="http://purl.org/dc/elements/1.1/"/>
+    <ds:schemaRef ds:uri="http://purl.org/dc/terms/"/>
+    <ds:schemaRef ds:uri="http://schemas.microsoft.com/internal/obd"/>
+  </ds:schemaRefs>
+</ds:datastoreItem>
+</file>
+
+<file path=customXml/itemProps3.xml><?xml version="1.0" encoding="utf-8"?>
+<ds:datastoreItem xmlns:ds="http://schemas.openxmlformats.org/officeDocument/2006/customXml" ds:itemID="{3B4D5896-D522-4991-8C9D-60ADCCA9ACEE}">
+  <ds:schemaRefs>
+    <ds:schemaRef ds:uri="http://schemas.microsoft.com/sharepoint/v3/contenttype/forms"/>
+  </ds:schemaRefs>
+</ds:datastoreItem>
 </file>
</xml_diff>